<commit_message>
powerpoint seq diagram + componenti client side (da rivedere)
</commit_message>
<xml_diff>
--- a/deliverables/PresentazioneProgettoTIW.pptx
+++ b/deliverables/PresentazioneProgettoTIW.pptx
@@ -25,6 +25,30 @@
     <p:sldId id="275" r:id="rId19"/>
     <p:sldId id="276" r:id="rId20"/>
     <p:sldId id="277" r:id="rId21"/>
+    <p:sldId id="301" r:id="rId22"/>
+    <p:sldId id="278" r:id="rId23"/>
+    <p:sldId id="279" r:id="rId24"/>
+    <p:sldId id="280" r:id="rId25"/>
+    <p:sldId id="281" r:id="rId26"/>
+    <p:sldId id="282" r:id="rId27"/>
+    <p:sldId id="283" r:id="rId28"/>
+    <p:sldId id="284" r:id="rId29"/>
+    <p:sldId id="285" r:id="rId30"/>
+    <p:sldId id="286" r:id="rId31"/>
+    <p:sldId id="287" r:id="rId32"/>
+    <p:sldId id="288" r:id="rId33"/>
+    <p:sldId id="289" r:id="rId34"/>
+    <p:sldId id="290" r:id="rId35"/>
+    <p:sldId id="291" r:id="rId36"/>
+    <p:sldId id="292" r:id="rId37"/>
+    <p:sldId id="293" r:id="rId38"/>
+    <p:sldId id="294" r:id="rId39"/>
+    <p:sldId id="295" r:id="rId40"/>
+    <p:sldId id="296" r:id="rId41"/>
+    <p:sldId id="297" r:id="rId42"/>
+    <p:sldId id="298" r:id="rId43"/>
+    <p:sldId id="299" r:id="rId44"/>
+    <p:sldId id="300" r:id="rId45"/>
   </p:sldIdLst>
   <p:sldSz cx="12192000" cy="6858000"/>
   <p:notesSz cx="6858000" cy="9144000"/>
@@ -284,7 +308,7 @@
           <a:p>
             <a:fld id="{D1D1EADE-8E88-4C7C-8AC5-FB148DE4940E}" type="datetime1">
               <a:rPr lang="en-US" smtClean="0"/>
-              <a:t>8/24/25</a:t>
+              <a:t>8/24/2025</a:t>
             </a:fld>
             <a:endParaRPr lang="en-US"/>
           </a:p>
@@ -484,7 +508,7 @@
           <a:p>
             <a:fld id="{EC3C8B9C-477D-492A-96AD-1FC2CC997A73}" type="datetime1">
               <a:rPr lang="en-US" smtClean="0"/>
-              <a:t>8/24/25</a:t>
+              <a:t>8/24/2025</a:t>
             </a:fld>
             <a:endParaRPr lang="en-US"/>
           </a:p>
@@ -694,7 +718,7 @@
           <a:p>
             <a:fld id="{42D3AED5-E26D-4E29-B1B3-7847B6779594}" type="datetime1">
               <a:rPr lang="en-US" smtClean="0"/>
-              <a:t>8/24/25</a:t>
+              <a:t>8/24/2025</a:t>
             </a:fld>
             <a:endParaRPr lang="en-US"/>
           </a:p>
@@ -894,7 +918,7 @@
           <a:p>
             <a:fld id="{157B6794-849E-4626-908B-D15793550EFB}" type="datetime1">
               <a:rPr lang="en-US" smtClean="0"/>
-              <a:t>8/24/25</a:t>
+              <a:t>8/24/2025</a:t>
             </a:fld>
             <a:endParaRPr lang="en-US"/>
           </a:p>
@@ -1170,7 +1194,7 @@
           <a:p>
             <a:fld id="{63DB64E7-5594-42A3-ADBF-E95A7ACEAD64}" type="datetime1">
               <a:rPr lang="en-US" smtClean="0"/>
-              <a:t>8/24/25</a:t>
+              <a:t>8/24/2025</a:t>
             </a:fld>
             <a:endParaRPr lang="en-US"/>
           </a:p>
@@ -1443,7 +1467,7 @@
           <a:p>
             <a:fld id="{18462B0B-D248-4FFB-8695-AD7FA4B1284A}" type="datetime1">
               <a:rPr lang="en-US" smtClean="0"/>
-              <a:t>8/24/25</a:t>
+              <a:t>8/24/2025</a:t>
             </a:fld>
             <a:endParaRPr lang="en-US"/>
           </a:p>
@@ -1866,7 +1890,7 @@
           <a:p>
             <a:fld id="{D0378EFB-9159-4510-B73F-4F0409ADE937}" type="datetime1">
               <a:rPr lang="en-US" smtClean="0"/>
-              <a:t>8/24/25</a:t>
+              <a:t>8/24/2025</a:t>
             </a:fld>
             <a:endParaRPr lang="en-US"/>
           </a:p>
@@ -2008,7 +2032,7 @@
           <a:p>
             <a:fld id="{89BC9412-2452-4BED-A324-9D8C115361AD}" type="datetime1">
               <a:rPr lang="en-US" smtClean="0"/>
-              <a:t>8/24/25</a:t>
+              <a:t>8/24/2025</a:t>
             </a:fld>
             <a:endParaRPr lang="en-US"/>
           </a:p>
@@ -2121,7 +2145,7 @@
           <a:p>
             <a:fld id="{F5318F62-D251-40E8-A23C-F4CFE9FEAB41}" type="datetime1">
               <a:rPr lang="en-US" smtClean="0"/>
-              <a:t>8/24/25</a:t>
+              <a:t>8/24/2025</a:t>
             </a:fld>
             <a:endParaRPr lang="en-US"/>
           </a:p>
@@ -2434,7 +2458,7 @@
           <a:p>
             <a:fld id="{44F76144-149E-4874-93A5-554A0357CF82}" type="datetime1">
               <a:rPr lang="en-US" smtClean="0"/>
-              <a:t>8/24/25</a:t>
+              <a:t>8/24/2025</a:t>
             </a:fld>
             <a:endParaRPr lang="en-US"/>
           </a:p>
@@ -2727,7 +2751,7 @@
           <a:p>
             <a:fld id="{50BA65D8-0540-4835-AE5C-25D29DBA01BE}" type="datetime1">
               <a:rPr lang="en-US" smtClean="0"/>
-              <a:t>8/24/25</a:t>
+              <a:t>8/24/2025</a:t>
             </a:fld>
             <a:endParaRPr lang="en-US"/>
           </a:p>
@@ -2969,7 +2993,7 @@
           <a:p>
             <a:fld id="{E31BA835-12AC-4E8F-955A-EA3F4DE2791F}" type="datetime1">
               <a:rPr lang="en-US" smtClean="0"/>
-              <a:t>8/24/25</a:t>
+              <a:t>8/24/2025</a:t>
             </a:fld>
             <a:endParaRPr lang="en-US"/>
           </a:p>
@@ -9385,6 +9409,3188 @@
 </p:sld>
 </file>
 
+<file path=ppt/slides/slide21.xml><?xml version="1.0" encoding="utf-8"?>
+<p:sld xmlns:a="http://schemas.openxmlformats.org/drawingml/2006/main" xmlns:r="http://schemas.openxmlformats.org/officeDocument/2006/relationships" xmlns:p="http://schemas.openxmlformats.org/presentationml/2006/main">
+  <p:cSld>
+    <p:spTree>
+      <p:nvGrpSpPr>
+        <p:cNvPr id="1" name="">
+          <a:extLst>
+            <a:ext uri="{FF2B5EF4-FFF2-40B4-BE49-F238E27FC236}">
+              <a16:creationId xmlns:a16="http://schemas.microsoft.com/office/drawing/2014/main" id="{F8E22F65-028F-A28C-2740-A91BC4AB4C45}"/>
+            </a:ext>
+          </a:extLst>
+        </p:cNvPr>
+        <p:cNvGrpSpPr/>
+        <p:nvPr/>
+      </p:nvGrpSpPr>
+      <p:grpSpPr>
+        <a:xfrm>
+          <a:off x="0" y="0"/>
+          <a:ext cx="0" cy="0"/>
+          <a:chOff x="0" y="0"/>
+          <a:chExt cx="0" cy="0"/>
+        </a:xfrm>
+      </p:grpSpPr>
+      <p:sp>
+        <p:nvSpPr>
+          <p:cNvPr id="2" name="Titolo 1">
+            <a:extLst>
+              <a:ext uri="{FF2B5EF4-FFF2-40B4-BE49-F238E27FC236}">
+                <a16:creationId xmlns:a16="http://schemas.microsoft.com/office/drawing/2014/main" id="{58E9E2F2-FB03-0F5B-9E43-A6091C0D8CCC}"/>
+              </a:ext>
+            </a:extLst>
+          </p:cNvPr>
+          <p:cNvSpPr>
+            <a:spLocks noGrp="1"/>
+          </p:cNvSpPr>
+          <p:nvPr>
+            <p:ph type="title"/>
+          </p:nvPr>
+        </p:nvSpPr>
+        <p:spPr/>
+        <p:txBody>
+          <a:bodyPr/>
+          <a:lstStyle/>
+          <a:p>
+            <a:pPr algn="ctr"/>
+            <a:r>
+              <a:rPr lang="it-IT" dirty="0"/>
+              <a:t>Componenti – client side</a:t>
+            </a:r>
+          </a:p>
+        </p:txBody>
+      </p:sp>
+      <p:sp>
+        <p:nvSpPr>
+          <p:cNvPr id="3" name="Segnaposto contenuto 2">
+            <a:extLst>
+              <a:ext uri="{FF2B5EF4-FFF2-40B4-BE49-F238E27FC236}">
+                <a16:creationId xmlns:a16="http://schemas.microsoft.com/office/drawing/2014/main" id="{962A4388-9DBB-DA07-A6B2-D328B76D544B}"/>
+              </a:ext>
+            </a:extLst>
+          </p:cNvPr>
+          <p:cNvSpPr>
+            <a:spLocks noGrp="1"/>
+          </p:cNvSpPr>
+          <p:nvPr>
+            <p:ph idx="1"/>
+          </p:nvPr>
+        </p:nvSpPr>
+        <p:spPr>
+          <a:xfrm>
+            <a:off x="276582" y="1752862"/>
+            <a:ext cx="5088229" cy="3739896"/>
+          </a:xfrm>
+        </p:spPr>
+        <p:txBody>
+          <a:bodyPr>
+            <a:normAutofit/>
+          </a:bodyPr>
+          <a:lstStyle/>
+          <a:p>
+            <a:r>
+              <a:rPr lang="it-IT" b="1" dirty="0"/>
+              <a:t>Home</a:t>
+            </a:r>
+          </a:p>
+          <a:p>
+            <a:pPr marL="457200" lvl="1" indent="0" eaLnBrk="0" fontAlgn="base" hangingPunct="0">
+              <a:lnSpc>
+                <a:spcPct val="100000"/>
+              </a:lnSpc>
+              <a:spcBef>
+                <a:spcPct val="0"/>
+              </a:spcBef>
+              <a:spcAft>
+                <a:spcPct val="0"/>
+              </a:spcAft>
+              <a:buFontTx/>
+              <a:buChar char="•"/>
+            </a:pPr>
+            <a:r>
+              <a:rPr lang="it-IT" altLang="it-IT" sz="1200" dirty="0" err="1">
+                <a:latin typeface="Arial Unicode MS"/>
+              </a:rPr>
+              <a:t>showVendo</a:t>
+            </a:r>
+            <a:r>
+              <a:rPr lang="it-IT" altLang="it-IT" sz="1200" dirty="0">
+                <a:latin typeface="Arial Unicode MS"/>
+              </a:rPr>
+              <a:t>()</a:t>
+            </a:r>
+            <a:r>
+              <a:rPr lang="it-IT" altLang="it-IT" sz="1200" dirty="0"/>
+              <a:t> → mostra la pagina Vendo e nasconde le altre</a:t>
+            </a:r>
+            <a:endParaRPr lang="it-IT" altLang="it-IT" sz="1200" dirty="0">
+              <a:latin typeface="Arial" panose="020B0604020202020204" pitchFamily="34" charset="0"/>
+            </a:endParaRPr>
+          </a:p>
+          <a:p>
+            <a:pPr marL="457200" lvl="1" indent="0" eaLnBrk="0" fontAlgn="base" hangingPunct="0">
+              <a:lnSpc>
+                <a:spcPct val="100000"/>
+              </a:lnSpc>
+              <a:spcBef>
+                <a:spcPct val="0"/>
+              </a:spcBef>
+              <a:spcAft>
+                <a:spcPct val="0"/>
+              </a:spcAft>
+              <a:buFontTx/>
+              <a:buChar char="•"/>
+            </a:pPr>
+            <a:r>
+              <a:rPr lang="it-IT" altLang="it-IT" sz="1200" dirty="0" err="1">
+                <a:latin typeface="Arial Unicode MS"/>
+              </a:rPr>
+              <a:t>showAcquisto</a:t>
+            </a:r>
+            <a:r>
+              <a:rPr lang="it-IT" altLang="it-IT" sz="1200" dirty="0">
+                <a:latin typeface="Arial Unicode MS"/>
+              </a:rPr>
+              <a:t>()</a:t>
+            </a:r>
+            <a:r>
+              <a:rPr lang="it-IT" altLang="it-IT" sz="1200" dirty="0"/>
+              <a:t> → mostra la pagina Acquisto e nasconde le altre</a:t>
+            </a:r>
+            <a:endParaRPr lang="it-IT" altLang="it-IT" sz="1200" dirty="0">
+              <a:latin typeface="Arial" panose="020B0604020202020204" pitchFamily="34" charset="0"/>
+            </a:endParaRPr>
+          </a:p>
+          <a:p>
+            <a:pPr marL="457200" lvl="1" indent="0" eaLnBrk="0" fontAlgn="base" hangingPunct="0">
+              <a:lnSpc>
+                <a:spcPct val="100000"/>
+              </a:lnSpc>
+              <a:spcBef>
+                <a:spcPct val="0"/>
+              </a:spcBef>
+              <a:spcAft>
+                <a:spcPct val="0"/>
+              </a:spcAft>
+              <a:buFontTx/>
+              <a:buChar char="•"/>
+            </a:pPr>
+            <a:r>
+              <a:rPr lang="it-IT" altLang="it-IT" sz="1200" dirty="0" err="1">
+                <a:latin typeface="Arial Unicode MS"/>
+              </a:rPr>
+              <a:t>hideAllPages</a:t>
+            </a:r>
+            <a:r>
+              <a:rPr lang="it-IT" altLang="it-IT" sz="1200" dirty="0">
+                <a:latin typeface="Arial Unicode MS"/>
+              </a:rPr>
+              <a:t>()</a:t>
+            </a:r>
+            <a:r>
+              <a:rPr lang="it-IT" altLang="it-IT" sz="1200" dirty="0"/>
+              <a:t> → nasconde tutte le pagine</a:t>
+            </a:r>
+            <a:endParaRPr lang="it-IT" altLang="it-IT" sz="1200" dirty="0">
+              <a:latin typeface="Arial" panose="020B0604020202020204" pitchFamily="34" charset="0"/>
+            </a:endParaRPr>
+          </a:p>
+          <a:p>
+            <a:pPr marL="457200" lvl="1" indent="0" eaLnBrk="0" fontAlgn="base" hangingPunct="0">
+              <a:lnSpc>
+                <a:spcPct val="100000"/>
+              </a:lnSpc>
+              <a:spcBef>
+                <a:spcPct val="0"/>
+              </a:spcBef>
+              <a:spcAft>
+                <a:spcPct val="0"/>
+              </a:spcAft>
+              <a:buFontTx/>
+              <a:buChar char="•"/>
+            </a:pPr>
+            <a:r>
+              <a:rPr lang="it-IT" altLang="it-IT" sz="1200" dirty="0" err="1">
+                <a:latin typeface="Arial Unicode MS"/>
+              </a:rPr>
+              <a:t>renderPageByLastAction</a:t>
+            </a:r>
+            <a:r>
+              <a:rPr lang="it-IT" altLang="it-IT" sz="1200" dirty="0">
+                <a:latin typeface="Arial Unicode MS"/>
+              </a:rPr>
+              <a:t>()</a:t>
+            </a:r>
+            <a:r>
+              <a:rPr lang="it-IT" altLang="it-IT" sz="1200" dirty="0"/>
+              <a:t> → apre Vendo o Acquisto in base all’ultima azione utente</a:t>
+            </a:r>
+            <a:endParaRPr lang="it-IT" sz="1200" b="1" dirty="0"/>
+          </a:p>
+          <a:p>
+            <a:pPr lvl="1">
+              <a:buFont typeface="Courier New" panose="02070309020205020404" pitchFamily="49" charset="0"/>
+              <a:buChar char="o"/>
+            </a:pPr>
+            <a:endParaRPr lang="it-IT" b="1" dirty="0"/>
+          </a:p>
+          <a:p>
+            <a:pPr lvl="1">
+              <a:buFont typeface="Courier New" panose="02070309020205020404" pitchFamily="49" charset="0"/>
+              <a:buChar char="o"/>
+            </a:pPr>
+            <a:endParaRPr lang="it-IT" sz="1400" dirty="0"/>
+          </a:p>
+        </p:txBody>
+      </p:sp>
+      <p:sp>
+        <p:nvSpPr>
+          <p:cNvPr id="4" name="CasellaDiTesto 3">
+            <a:extLst>
+              <a:ext uri="{FF2B5EF4-FFF2-40B4-BE49-F238E27FC236}">
+                <a16:creationId xmlns:a16="http://schemas.microsoft.com/office/drawing/2014/main" id="{1292F17C-75CD-B5B0-8B0F-8B952D8EE178}"/>
+              </a:ext>
+            </a:extLst>
+          </p:cNvPr>
+          <p:cNvSpPr txBox="1"/>
+          <p:nvPr/>
+        </p:nvSpPr>
+        <p:spPr>
+          <a:xfrm>
+            <a:off x="5788864" y="1568196"/>
+            <a:ext cx="614271" cy="369332"/>
+          </a:xfrm>
+          <a:prstGeom prst="rect">
+            <a:avLst/>
+          </a:prstGeom>
+          <a:noFill/>
+        </p:spPr>
+        <p:txBody>
+          <a:bodyPr wrap="none" rtlCol="0">
+            <a:spAutoFit/>
+          </a:bodyPr>
+          <a:lstStyle/>
+          <a:p>
+            <a:r>
+              <a:rPr lang="it-IT" dirty="0"/>
+              <a:t>RIA</a:t>
+            </a:r>
+          </a:p>
+        </p:txBody>
+      </p:sp>
+      <p:sp>
+        <p:nvSpPr>
+          <p:cNvPr id="6" name="Segnaposto contenuto 2">
+            <a:extLst>
+              <a:ext uri="{FF2B5EF4-FFF2-40B4-BE49-F238E27FC236}">
+                <a16:creationId xmlns:a16="http://schemas.microsoft.com/office/drawing/2014/main" id="{CEAA40AF-A523-5452-1183-34767D48E707}"/>
+              </a:ext>
+            </a:extLst>
+          </p:cNvPr>
+          <p:cNvSpPr txBox="1">
+            <a:spLocks/>
+          </p:cNvSpPr>
+          <p:nvPr/>
+        </p:nvSpPr>
+        <p:spPr>
+          <a:xfrm>
+            <a:off x="276581" y="3060454"/>
+            <a:ext cx="6075831" cy="3739896"/>
+          </a:xfrm>
+          <a:prstGeom prst="rect">
+            <a:avLst/>
+          </a:prstGeom>
+        </p:spPr>
+        <p:txBody>
+          <a:bodyPr vert="horz" lIns="91440" tIns="45720" rIns="91440" bIns="45720" rtlCol="0">
+            <a:normAutofit/>
+          </a:bodyPr>
+          <a:lstStyle>
+            <a:lvl1pPr marL="228600" indent="-228600" algn="l" defTabSz="914400" rtl="0" eaLnBrk="1" latinLnBrk="0" hangingPunct="1">
+              <a:lnSpc>
+                <a:spcPct val="110000"/>
+              </a:lnSpc>
+              <a:spcBef>
+                <a:spcPts val="1000"/>
+              </a:spcBef>
+              <a:buFont typeface="Arial" panose="020B0604020202020204" pitchFamily="34" charset="0"/>
+              <a:buChar char="•"/>
+              <a:defRPr sz="2000" kern="1200">
+                <a:solidFill>
+                  <a:schemeClr val="tx1"/>
+                </a:solidFill>
+                <a:latin typeface="+mn-lt"/>
+                <a:ea typeface="+mn-ea"/>
+                <a:cs typeface="+mn-cs"/>
+              </a:defRPr>
+            </a:lvl1pPr>
+            <a:lvl2pPr marL="685800" indent="-228600" algn="l" defTabSz="914400" rtl="0" eaLnBrk="1" latinLnBrk="0" hangingPunct="1">
+              <a:lnSpc>
+                <a:spcPct val="110000"/>
+              </a:lnSpc>
+              <a:spcBef>
+                <a:spcPts val="500"/>
+              </a:spcBef>
+              <a:buFont typeface="Arial" panose="020B0604020202020204" pitchFamily="34" charset="0"/>
+              <a:buChar char="•"/>
+              <a:defRPr sz="1800" kern="1200">
+                <a:solidFill>
+                  <a:schemeClr val="tx1"/>
+                </a:solidFill>
+                <a:latin typeface="+mn-lt"/>
+                <a:ea typeface="+mn-ea"/>
+                <a:cs typeface="+mn-cs"/>
+              </a:defRPr>
+            </a:lvl2pPr>
+            <a:lvl3pPr marL="1143000" indent="-228600" algn="l" defTabSz="914400" rtl="0" eaLnBrk="1" latinLnBrk="0" hangingPunct="1">
+              <a:lnSpc>
+                <a:spcPct val="110000"/>
+              </a:lnSpc>
+              <a:spcBef>
+                <a:spcPts val="500"/>
+              </a:spcBef>
+              <a:buFont typeface="Arial" panose="020B0604020202020204" pitchFamily="34" charset="0"/>
+              <a:buChar char="•"/>
+              <a:defRPr sz="1600" kern="1200">
+                <a:solidFill>
+                  <a:schemeClr val="tx1"/>
+                </a:solidFill>
+                <a:latin typeface="+mn-lt"/>
+                <a:ea typeface="+mn-ea"/>
+                <a:cs typeface="+mn-cs"/>
+              </a:defRPr>
+            </a:lvl3pPr>
+            <a:lvl4pPr marL="1600200" indent="-228600" algn="l" defTabSz="914400" rtl="0" eaLnBrk="1" latinLnBrk="0" hangingPunct="1">
+              <a:lnSpc>
+                <a:spcPct val="110000"/>
+              </a:lnSpc>
+              <a:spcBef>
+                <a:spcPts val="500"/>
+              </a:spcBef>
+              <a:buFont typeface="Arial" panose="020B0604020202020204" pitchFamily="34" charset="0"/>
+              <a:buChar char="•"/>
+              <a:defRPr sz="1400" kern="1200">
+                <a:solidFill>
+                  <a:schemeClr val="tx1"/>
+                </a:solidFill>
+                <a:latin typeface="+mn-lt"/>
+                <a:ea typeface="+mn-ea"/>
+                <a:cs typeface="+mn-cs"/>
+              </a:defRPr>
+            </a:lvl4pPr>
+            <a:lvl5pPr marL="2057400" indent="-228600" algn="l" defTabSz="914400" rtl="0" eaLnBrk="1" latinLnBrk="0" hangingPunct="1">
+              <a:lnSpc>
+                <a:spcPct val="110000"/>
+              </a:lnSpc>
+              <a:spcBef>
+                <a:spcPts val="500"/>
+              </a:spcBef>
+              <a:buFont typeface="Arial" panose="020B0604020202020204" pitchFamily="34" charset="0"/>
+              <a:buChar char="•"/>
+              <a:defRPr sz="1400" kern="1200">
+                <a:solidFill>
+                  <a:schemeClr val="tx1"/>
+                </a:solidFill>
+                <a:latin typeface="+mn-lt"/>
+                <a:ea typeface="+mn-ea"/>
+                <a:cs typeface="+mn-cs"/>
+              </a:defRPr>
+            </a:lvl5pPr>
+            <a:lvl6pPr marL="2514600" indent="-228600" algn="l" defTabSz="914400" rtl="0" eaLnBrk="1" latinLnBrk="0" hangingPunct="1">
+              <a:lnSpc>
+                <a:spcPct val="90000"/>
+              </a:lnSpc>
+              <a:spcBef>
+                <a:spcPts val="500"/>
+              </a:spcBef>
+              <a:buFont typeface="Arial" panose="020B0604020202020204" pitchFamily="34" charset="0"/>
+              <a:buChar char="•"/>
+              <a:defRPr sz="1800" kern="1200">
+                <a:solidFill>
+                  <a:schemeClr val="tx1"/>
+                </a:solidFill>
+                <a:latin typeface="+mn-lt"/>
+                <a:ea typeface="+mn-ea"/>
+                <a:cs typeface="+mn-cs"/>
+              </a:defRPr>
+            </a:lvl6pPr>
+            <a:lvl7pPr marL="2971800" indent="-228600" algn="l" defTabSz="914400" rtl="0" eaLnBrk="1" latinLnBrk="0" hangingPunct="1">
+              <a:lnSpc>
+                <a:spcPct val="90000"/>
+              </a:lnSpc>
+              <a:spcBef>
+                <a:spcPts val="500"/>
+              </a:spcBef>
+              <a:buFont typeface="Arial" panose="020B0604020202020204" pitchFamily="34" charset="0"/>
+              <a:buChar char="•"/>
+              <a:defRPr sz="1800" kern="1200">
+                <a:solidFill>
+                  <a:schemeClr val="tx1"/>
+                </a:solidFill>
+                <a:latin typeface="+mn-lt"/>
+                <a:ea typeface="+mn-ea"/>
+                <a:cs typeface="+mn-cs"/>
+              </a:defRPr>
+            </a:lvl7pPr>
+            <a:lvl8pPr marL="3429000" indent="-228600" algn="l" defTabSz="914400" rtl="0" eaLnBrk="1" latinLnBrk="0" hangingPunct="1">
+              <a:lnSpc>
+                <a:spcPct val="90000"/>
+              </a:lnSpc>
+              <a:spcBef>
+                <a:spcPts val="500"/>
+              </a:spcBef>
+              <a:buFont typeface="Arial" panose="020B0604020202020204" pitchFamily="34" charset="0"/>
+              <a:buChar char="•"/>
+              <a:defRPr sz="1800" kern="1200">
+                <a:solidFill>
+                  <a:schemeClr val="tx1"/>
+                </a:solidFill>
+                <a:latin typeface="+mn-lt"/>
+                <a:ea typeface="+mn-ea"/>
+                <a:cs typeface="+mn-cs"/>
+              </a:defRPr>
+            </a:lvl8pPr>
+            <a:lvl9pPr marL="3886200" indent="-228600" algn="l" defTabSz="914400" rtl="0" eaLnBrk="1" latinLnBrk="0" hangingPunct="1">
+              <a:lnSpc>
+                <a:spcPct val="90000"/>
+              </a:lnSpc>
+              <a:spcBef>
+                <a:spcPts val="500"/>
+              </a:spcBef>
+              <a:buFont typeface="Arial" panose="020B0604020202020204" pitchFamily="34" charset="0"/>
+              <a:buChar char="•"/>
+              <a:defRPr sz="1800" kern="1200">
+                <a:solidFill>
+                  <a:schemeClr val="tx1"/>
+                </a:solidFill>
+                <a:latin typeface="+mn-lt"/>
+                <a:ea typeface="+mn-ea"/>
+                <a:cs typeface="+mn-cs"/>
+              </a:defRPr>
+            </a:lvl9pPr>
+          </a:lstStyle>
+          <a:p>
+            <a:r>
+              <a:rPr lang="it-IT" b="1" dirty="0"/>
+              <a:t>Vendo</a:t>
+            </a:r>
+          </a:p>
+          <a:p>
+            <a:pPr marL="457200" lvl="1" indent="0" eaLnBrk="0" fontAlgn="base" hangingPunct="0">
+              <a:lnSpc>
+                <a:spcPct val="100000"/>
+              </a:lnSpc>
+              <a:spcBef>
+                <a:spcPct val="0"/>
+              </a:spcBef>
+              <a:spcAft>
+                <a:spcPct val="0"/>
+              </a:spcAft>
+              <a:buFontTx/>
+              <a:buChar char="•"/>
+            </a:pPr>
+            <a:r>
+              <a:rPr lang="it-IT" altLang="it-IT" sz="1200" dirty="0" err="1">
+                <a:latin typeface="Arial Unicode MS"/>
+              </a:rPr>
+              <a:t>renderVendoPage</a:t>
+            </a:r>
+            <a:r>
+              <a:rPr lang="it-IT" altLang="it-IT" sz="1200" dirty="0">
+                <a:latin typeface="Arial Unicode MS"/>
+              </a:rPr>
+              <a:t>()</a:t>
+            </a:r>
+            <a:r>
+              <a:rPr lang="it-IT" altLang="it-IT" sz="1200" dirty="0"/>
+              <a:t> → inizializza pagina Vendo e collega i pulsanti</a:t>
+            </a:r>
+            <a:endParaRPr lang="it-IT" altLang="it-IT" sz="1200" dirty="0">
+              <a:latin typeface="Arial" panose="020B0604020202020204" pitchFamily="34" charset="0"/>
+            </a:endParaRPr>
+          </a:p>
+          <a:p>
+            <a:pPr marL="457200" lvl="1" indent="0" eaLnBrk="0" fontAlgn="base" hangingPunct="0">
+              <a:lnSpc>
+                <a:spcPct val="100000"/>
+              </a:lnSpc>
+              <a:spcBef>
+                <a:spcPct val="0"/>
+              </a:spcBef>
+              <a:spcAft>
+                <a:spcPct val="0"/>
+              </a:spcAft>
+              <a:buFontTx/>
+              <a:buChar char="•"/>
+            </a:pPr>
+            <a:r>
+              <a:rPr lang="it-IT" altLang="it-IT" sz="1200" dirty="0" err="1">
+                <a:latin typeface="Arial Unicode MS"/>
+              </a:rPr>
+              <a:t>aggiungiArticolo</a:t>
+            </a:r>
+            <a:r>
+              <a:rPr lang="it-IT" altLang="it-IT" sz="1200" dirty="0">
+                <a:latin typeface="Arial Unicode MS"/>
+              </a:rPr>
+              <a:t>()</a:t>
+            </a:r>
+            <a:r>
+              <a:rPr lang="it-IT" altLang="it-IT" sz="1200" dirty="0"/>
+              <a:t> → invia un nuovo articolo al server</a:t>
+            </a:r>
+            <a:endParaRPr lang="it-IT" altLang="it-IT" sz="1200" dirty="0">
+              <a:latin typeface="Arial" panose="020B0604020202020204" pitchFamily="34" charset="0"/>
+            </a:endParaRPr>
+          </a:p>
+          <a:p>
+            <a:pPr marL="457200" lvl="1" indent="0" eaLnBrk="0" fontAlgn="base" hangingPunct="0">
+              <a:lnSpc>
+                <a:spcPct val="100000"/>
+              </a:lnSpc>
+              <a:spcBef>
+                <a:spcPct val="0"/>
+              </a:spcBef>
+              <a:spcAft>
+                <a:spcPct val="0"/>
+              </a:spcAft>
+              <a:buFontTx/>
+              <a:buChar char="•"/>
+            </a:pPr>
+            <a:r>
+              <a:rPr lang="it-IT" altLang="it-IT" sz="1200" dirty="0" err="1">
+                <a:latin typeface="Arial Unicode MS"/>
+              </a:rPr>
+              <a:t>creaAsta</a:t>
+            </a:r>
+            <a:r>
+              <a:rPr lang="it-IT" altLang="it-IT" sz="1200" dirty="0">
+                <a:latin typeface="Arial Unicode MS"/>
+              </a:rPr>
+              <a:t>()</a:t>
+            </a:r>
+            <a:r>
+              <a:rPr lang="it-IT" altLang="it-IT" sz="1200" dirty="0"/>
+              <a:t> → crea una nuova asta con articoli selezionati</a:t>
+            </a:r>
+            <a:endParaRPr lang="it-IT" altLang="it-IT" sz="1200" dirty="0">
+              <a:latin typeface="Arial" panose="020B0604020202020204" pitchFamily="34" charset="0"/>
+            </a:endParaRPr>
+          </a:p>
+          <a:p>
+            <a:pPr marL="457200" lvl="1" indent="0" eaLnBrk="0" fontAlgn="base" hangingPunct="0">
+              <a:lnSpc>
+                <a:spcPct val="100000"/>
+              </a:lnSpc>
+              <a:spcBef>
+                <a:spcPct val="0"/>
+              </a:spcBef>
+              <a:spcAft>
+                <a:spcPct val="0"/>
+              </a:spcAft>
+              <a:buFontTx/>
+              <a:buChar char="•"/>
+            </a:pPr>
+            <a:r>
+              <a:rPr lang="it-IT" altLang="it-IT" sz="1200" dirty="0" err="1">
+                <a:latin typeface="Arial Unicode MS"/>
+              </a:rPr>
+              <a:t>aggiornaArticoliDisponibili</a:t>
+            </a:r>
+            <a:r>
+              <a:rPr lang="it-IT" altLang="it-IT" sz="1200" dirty="0">
+                <a:latin typeface="Arial Unicode MS"/>
+              </a:rPr>
+              <a:t>()</a:t>
+            </a:r>
+            <a:r>
+              <a:rPr lang="it-IT" altLang="it-IT" sz="1200" dirty="0"/>
+              <a:t> → aggiorna la lista articoli disponibili per asta</a:t>
+            </a:r>
+            <a:endParaRPr lang="it-IT" altLang="it-IT" sz="1200" dirty="0">
+              <a:latin typeface="Arial" panose="020B0604020202020204" pitchFamily="34" charset="0"/>
+            </a:endParaRPr>
+          </a:p>
+          <a:p>
+            <a:pPr marL="457200" lvl="1" indent="0" eaLnBrk="0" fontAlgn="base" hangingPunct="0">
+              <a:lnSpc>
+                <a:spcPct val="100000"/>
+              </a:lnSpc>
+              <a:spcBef>
+                <a:spcPct val="0"/>
+              </a:spcBef>
+              <a:spcAft>
+                <a:spcPct val="0"/>
+              </a:spcAft>
+              <a:buFontTx/>
+              <a:buChar char="•"/>
+            </a:pPr>
+            <a:r>
+              <a:rPr lang="it-IT" altLang="it-IT" sz="1200" dirty="0" err="1">
+                <a:latin typeface="Arial Unicode MS"/>
+              </a:rPr>
+              <a:t>aggiungiArticoloAllaTabella</a:t>
+            </a:r>
+            <a:r>
+              <a:rPr lang="it-IT" altLang="it-IT" sz="1200" dirty="0">
+                <a:latin typeface="Arial Unicode MS"/>
+              </a:rPr>
+              <a:t>()</a:t>
+            </a:r>
+            <a:r>
+              <a:rPr lang="it-IT" altLang="it-IT" sz="1200" dirty="0"/>
+              <a:t> → aggiunge una riga articolo alla tabella nuova asta</a:t>
+            </a:r>
+            <a:endParaRPr lang="it-IT" altLang="it-IT" sz="1200" dirty="0">
+              <a:latin typeface="Arial" panose="020B0604020202020204" pitchFamily="34" charset="0"/>
+            </a:endParaRPr>
+          </a:p>
+          <a:p>
+            <a:pPr marL="457200" lvl="1" indent="0" eaLnBrk="0" fontAlgn="base" hangingPunct="0">
+              <a:lnSpc>
+                <a:spcPct val="100000"/>
+              </a:lnSpc>
+              <a:spcBef>
+                <a:spcPct val="0"/>
+              </a:spcBef>
+              <a:spcAft>
+                <a:spcPct val="0"/>
+              </a:spcAft>
+              <a:buFontTx/>
+              <a:buChar char="•"/>
+            </a:pPr>
+            <a:r>
+              <a:rPr lang="it-IT" altLang="it-IT" sz="1200" dirty="0" err="1">
+                <a:latin typeface="Arial Unicode MS"/>
+              </a:rPr>
+              <a:t>caricaListeAperte</a:t>
+            </a:r>
+            <a:r>
+              <a:rPr lang="it-IT" altLang="it-IT" sz="1200" dirty="0">
+                <a:latin typeface="Arial Unicode MS"/>
+              </a:rPr>
+              <a:t>()</a:t>
+            </a:r>
+            <a:r>
+              <a:rPr lang="it-IT" altLang="it-IT" sz="1200" dirty="0"/>
+              <a:t> → carica e mostra le aste aperte dell’utente</a:t>
+            </a:r>
+            <a:endParaRPr lang="it-IT" altLang="it-IT" sz="1200" dirty="0">
+              <a:latin typeface="Arial" panose="020B0604020202020204" pitchFamily="34" charset="0"/>
+            </a:endParaRPr>
+          </a:p>
+          <a:p>
+            <a:pPr marL="457200" lvl="1" indent="0" eaLnBrk="0" fontAlgn="base" hangingPunct="0">
+              <a:lnSpc>
+                <a:spcPct val="100000"/>
+              </a:lnSpc>
+              <a:spcBef>
+                <a:spcPct val="0"/>
+              </a:spcBef>
+              <a:spcAft>
+                <a:spcPct val="0"/>
+              </a:spcAft>
+              <a:buFontTx/>
+              <a:buChar char="•"/>
+            </a:pPr>
+            <a:r>
+              <a:rPr lang="it-IT" altLang="it-IT" sz="1200" dirty="0" err="1">
+                <a:latin typeface="Arial Unicode MS"/>
+              </a:rPr>
+              <a:t>caricaListeChiuse</a:t>
+            </a:r>
+            <a:r>
+              <a:rPr lang="it-IT" altLang="it-IT" sz="1200" dirty="0">
+                <a:latin typeface="Arial Unicode MS"/>
+              </a:rPr>
+              <a:t>()</a:t>
+            </a:r>
+            <a:r>
+              <a:rPr lang="it-IT" altLang="it-IT" sz="1200" dirty="0"/>
+              <a:t> → carica e mostra le aste chiuse dell’utente</a:t>
+            </a:r>
+            <a:endParaRPr lang="it-IT" altLang="it-IT" sz="1200" dirty="0">
+              <a:latin typeface="Arial" panose="020B0604020202020204" pitchFamily="34" charset="0"/>
+            </a:endParaRPr>
+          </a:p>
+          <a:p>
+            <a:pPr marL="457200" lvl="1" indent="0" eaLnBrk="0" fontAlgn="base" hangingPunct="0">
+              <a:lnSpc>
+                <a:spcPct val="100000"/>
+              </a:lnSpc>
+              <a:spcBef>
+                <a:spcPct val="0"/>
+              </a:spcBef>
+              <a:spcAft>
+                <a:spcPct val="0"/>
+              </a:spcAft>
+              <a:buFontTx/>
+              <a:buChar char="•"/>
+            </a:pPr>
+            <a:r>
+              <a:rPr lang="it-IT" altLang="it-IT" sz="1200" dirty="0" err="1">
+                <a:latin typeface="Arial Unicode MS"/>
+              </a:rPr>
+              <a:t>inizializzaClickDettaglioAstaAperta</a:t>
+            </a:r>
+            <a:r>
+              <a:rPr lang="it-IT" altLang="it-IT" sz="1200" dirty="0">
+                <a:latin typeface="Arial Unicode MS"/>
+              </a:rPr>
+              <a:t>()</a:t>
+            </a:r>
+            <a:r>
+              <a:rPr lang="it-IT" altLang="it-IT" sz="1200" dirty="0"/>
+              <a:t> → click su ID asta aperta → dettaglio</a:t>
+            </a:r>
+            <a:endParaRPr lang="it-IT" altLang="it-IT" sz="1200" dirty="0">
+              <a:latin typeface="Arial" panose="020B0604020202020204" pitchFamily="34" charset="0"/>
+            </a:endParaRPr>
+          </a:p>
+          <a:p>
+            <a:pPr marL="457200" lvl="1" indent="0" eaLnBrk="0" fontAlgn="base" hangingPunct="0">
+              <a:lnSpc>
+                <a:spcPct val="100000"/>
+              </a:lnSpc>
+              <a:spcBef>
+                <a:spcPct val="0"/>
+              </a:spcBef>
+              <a:spcAft>
+                <a:spcPct val="0"/>
+              </a:spcAft>
+              <a:buFontTx/>
+              <a:buChar char="•"/>
+            </a:pPr>
+            <a:r>
+              <a:rPr lang="it-IT" altLang="it-IT" sz="1200" dirty="0" err="1">
+                <a:latin typeface="Arial Unicode MS"/>
+              </a:rPr>
+              <a:t>inizializzaClickDettaglioAsteChiuse</a:t>
+            </a:r>
+            <a:r>
+              <a:rPr lang="it-IT" altLang="it-IT" sz="1200" dirty="0">
+                <a:latin typeface="Arial Unicode MS"/>
+              </a:rPr>
+              <a:t>()</a:t>
+            </a:r>
+            <a:r>
+              <a:rPr lang="it-IT" altLang="it-IT" sz="1200" dirty="0"/>
+              <a:t> → click su ID asta chiusa → dettaglio</a:t>
+            </a:r>
+            <a:endParaRPr lang="it-IT" altLang="it-IT" sz="1200" dirty="0">
+              <a:latin typeface="Arial" panose="020B0604020202020204" pitchFamily="34" charset="0"/>
+            </a:endParaRPr>
+          </a:p>
+          <a:p>
+            <a:pPr marL="457200" lvl="1" indent="0" eaLnBrk="0" fontAlgn="base" hangingPunct="0">
+              <a:lnSpc>
+                <a:spcPct val="100000"/>
+              </a:lnSpc>
+              <a:spcBef>
+                <a:spcPct val="0"/>
+              </a:spcBef>
+              <a:spcAft>
+                <a:spcPct val="0"/>
+              </a:spcAft>
+              <a:buFontTx/>
+              <a:buChar char="•"/>
+            </a:pPr>
+            <a:r>
+              <a:rPr lang="it-IT" altLang="it-IT" sz="1200" dirty="0" err="1">
+                <a:latin typeface="Arial Unicode MS"/>
+              </a:rPr>
+              <a:t>resetMSG</a:t>
+            </a:r>
+            <a:r>
+              <a:rPr lang="it-IT" altLang="it-IT" sz="1200" dirty="0">
+                <a:latin typeface="Arial Unicode MS"/>
+              </a:rPr>
+              <a:t>()</a:t>
+            </a:r>
+            <a:r>
+              <a:rPr lang="it-IT" altLang="it-IT" sz="1200" dirty="0"/>
+              <a:t> → pulisce i messaggi a schermo</a:t>
+            </a:r>
+            <a:endParaRPr lang="it-IT" altLang="it-IT" sz="1200" dirty="0">
+              <a:latin typeface="Arial" panose="020B0604020202020204" pitchFamily="34" charset="0"/>
+            </a:endParaRPr>
+          </a:p>
+          <a:p>
+            <a:pPr lvl="1"/>
+            <a:endParaRPr lang="it-IT" b="1" dirty="0"/>
+          </a:p>
+          <a:p>
+            <a:endParaRPr lang="it-IT" b="1" dirty="0"/>
+          </a:p>
+          <a:p>
+            <a:endParaRPr lang="it-IT" b="1" dirty="0"/>
+          </a:p>
+          <a:p>
+            <a:pPr lvl="1">
+              <a:buFont typeface="Courier New" panose="02070309020205020404" pitchFamily="49" charset="0"/>
+              <a:buChar char="o"/>
+            </a:pPr>
+            <a:endParaRPr lang="it-IT" b="1" dirty="0"/>
+          </a:p>
+          <a:p>
+            <a:pPr lvl="1">
+              <a:buFont typeface="Courier New" panose="02070309020205020404" pitchFamily="49" charset="0"/>
+              <a:buChar char="o"/>
+            </a:pPr>
+            <a:endParaRPr lang="it-IT" sz="1400" dirty="0"/>
+          </a:p>
+        </p:txBody>
+      </p:sp>
+      <p:sp>
+        <p:nvSpPr>
+          <p:cNvPr id="10" name="Segnaposto contenuto 2">
+            <a:extLst>
+              <a:ext uri="{FF2B5EF4-FFF2-40B4-BE49-F238E27FC236}">
+                <a16:creationId xmlns:a16="http://schemas.microsoft.com/office/drawing/2014/main" id="{BB2F039C-CB89-3612-7BCE-2D13D43443B9}"/>
+              </a:ext>
+            </a:extLst>
+          </p:cNvPr>
+          <p:cNvSpPr txBox="1">
+            <a:spLocks/>
+          </p:cNvSpPr>
+          <p:nvPr/>
+        </p:nvSpPr>
+        <p:spPr>
+          <a:xfrm>
+            <a:off x="6172200" y="3549658"/>
+            <a:ext cx="6019800" cy="3739896"/>
+          </a:xfrm>
+          <a:prstGeom prst="rect">
+            <a:avLst/>
+          </a:prstGeom>
+        </p:spPr>
+        <p:txBody>
+          <a:bodyPr vert="horz" lIns="91440" tIns="45720" rIns="91440" bIns="45720" rtlCol="0">
+            <a:normAutofit/>
+          </a:bodyPr>
+          <a:lstStyle>
+            <a:lvl1pPr marL="228600" indent="-228600" algn="l" defTabSz="914400" rtl="0" eaLnBrk="1" latinLnBrk="0" hangingPunct="1">
+              <a:lnSpc>
+                <a:spcPct val="110000"/>
+              </a:lnSpc>
+              <a:spcBef>
+                <a:spcPts val="1000"/>
+              </a:spcBef>
+              <a:buFont typeface="Arial" panose="020B0604020202020204" pitchFamily="34" charset="0"/>
+              <a:buChar char="•"/>
+              <a:defRPr sz="2000" kern="1200">
+                <a:solidFill>
+                  <a:schemeClr val="tx1"/>
+                </a:solidFill>
+                <a:latin typeface="+mn-lt"/>
+                <a:ea typeface="+mn-ea"/>
+                <a:cs typeface="+mn-cs"/>
+              </a:defRPr>
+            </a:lvl1pPr>
+            <a:lvl2pPr marL="685800" indent="-228600" algn="l" defTabSz="914400" rtl="0" eaLnBrk="1" latinLnBrk="0" hangingPunct="1">
+              <a:lnSpc>
+                <a:spcPct val="110000"/>
+              </a:lnSpc>
+              <a:spcBef>
+                <a:spcPts val="500"/>
+              </a:spcBef>
+              <a:buFont typeface="Arial" panose="020B0604020202020204" pitchFamily="34" charset="0"/>
+              <a:buChar char="•"/>
+              <a:defRPr sz="1800" kern="1200">
+                <a:solidFill>
+                  <a:schemeClr val="tx1"/>
+                </a:solidFill>
+                <a:latin typeface="+mn-lt"/>
+                <a:ea typeface="+mn-ea"/>
+                <a:cs typeface="+mn-cs"/>
+              </a:defRPr>
+            </a:lvl2pPr>
+            <a:lvl3pPr marL="1143000" indent="-228600" algn="l" defTabSz="914400" rtl="0" eaLnBrk="1" latinLnBrk="0" hangingPunct="1">
+              <a:lnSpc>
+                <a:spcPct val="110000"/>
+              </a:lnSpc>
+              <a:spcBef>
+                <a:spcPts val="500"/>
+              </a:spcBef>
+              <a:buFont typeface="Arial" panose="020B0604020202020204" pitchFamily="34" charset="0"/>
+              <a:buChar char="•"/>
+              <a:defRPr sz="1600" kern="1200">
+                <a:solidFill>
+                  <a:schemeClr val="tx1"/>
+                </a:solidFill>
+                <a:latin typeface="+mn-lt"/>
+                <a:ea typeface="+mn-ea"/>
+                <a:cs typeface="+mn-cs"/>
+              </a:defRPr>
+            </a:lvl3pPr>
+            <a:lvl4pPr marL="1600200" indent="-228600" algn="l" defTabSz="914400" rtl="0" eaLnBrk="1" latinLnBrk="0" hangingPunct="1">
+              <a:lnSpc>
+                <a:spcPct val="110000"/>
+              </a:lnSpc>
+              <a:spcBef>
+                <a:spcPts val="500"/>
+              </a:spcBef>
+              <a:buFont typeface="Arial" panose="020B0604020202020204" pitchFamily="34" charset="0"/>
+              <a:buChar char="•"/>
+              <a:defRPr sz="1400" kern="1200">
+                <a:solidFill>
+                  <a:schemeClr val="tx1"/>
+                </a:solidFill>
+                <a:latin typeface="+mn-lt"/>
+                <a:ea typeface="+mn-ea"/>
+                <a:cs typeface="+mn-cs"/>
+              </a:defRPr>
+            </a:lvl4pPr>
+            <a:lvl5pPr marL="2057400" indent="-228600" algn="l" defTabSz="914400" rtl="0" eaLnBrk="1" latinLnBrk="0" hangingPunct="1">
+              <a:lnSpc>
+                <a:spcPct val="110000"/>
+              </a:lnSpc>
+              <a:spcBef>
+                <a:spcPts val="500"/>
+              </a:spcBef>
+              <a:buFont typeface="Arial" panose="020B0604020202020204" pitchFamily="34" charset="0"/>
+              <a:buChar char="•"/>
+              <a:defRPr sz="1400" kern="1200">
+                <a:solidFill>
+                  <a:schemeClr val="tx1"/>
+                </a:solidFill>
+                <a:latin typeface="+mn-lt"/>
+                <a:ea typeface="+mn-ea"/>
+                <a:cs typeface="+mn-cs"/>
+              </a:defRPr>
+            </a:lvl5pPr>
+            <a:lvl6pPr marL="2514600" indent="-228600" algn="l" defTabSz="914400" rtl="0" eaLnBrk="1" latinLnBrk="0" hangingPunct="1">
+              <a:lnSpc>
+                <a:spcPct val="90000"/>
+              </a:lnSpc>
+              <a:spcBef>
+                <a:spcPts val="500"/>
+              </a:spcBef>
+              <a:buFont typeface="Arial" panose="020B0604020202020204" pitchFamily="34" charset="0"/>
+              <a:buChar char="•"/>
+              <a:defRPr sz="1800" kern="1200">
+                <a:solidFill>
+                  <a:schemeClr val="tx1"/>
+                </a:solidFill>
+                <a:latin typeface="+mn-lt"/>
+                <a:ea typeface="+mn-ea"/>
+                <a:cs typeface="+mn-cs"/>
+              </a:defRPr>
+            </a:lvl6pPr>
+            <a:lvl7pPr marL="2971800" indent="-228600" algn="l" defTabSz="914400" rtl="0" eaLnBrk="1" latinLnBrk="0" hangingPunct="1">
+              <a:lnSpc>
+                <a:spcPct val="90000"/>
+              </a:lnSpc>
+              <a:spcBef>
+                <a:spcPts val="500"/>
+              </a:spcBef>
+              <a:buFont typeface="Arial" panose="020B0604020202020204" pitchFamily="34" charset="0"/>
+              <a:buChar char="•"/>
+              <a:defRPr sz="1800" kern="1200">
+                <a:solidFill>
+                  <a:schemeClr val="tx1"/>
+                </a:solidFill>
+                <a:latin typeface="+mn-lt"/>
+                <a:ea typeface="+mn-ea"/>
+                <a:cs typeface="+mn-cs"/>
+              </a:defRPr>
+            </a:lvl7pPr>
+            <a:lvl8pPr marL="3429000" indent="-228600" algn="l" defTabSz="914400" rtl="0" eaLnBrk="1" latinLnBrk="0" hangingPunct="1">
+              <a:lnSpc>
+                <a:spcPct val="90000"/>
+              </a:lnSpc>
+              <a:spcBef>
+                <a:spcPts val="500"/>
+              </a:spcBef>
+              <a:buFont typeface="Arial" panose="020B0604020202020204" pitchFamily="34" charset="0"/>
+              <a:buChar char="•"/>
+              <a:defRPr sz="1800" kern="1200">
+                <a:solidFill>
+                  <a:schemeClr val="tx1"/>
+                </a:solidFill>
+                <a:latin typeface="+mn-lt"/>
+                <a:ea typeface="+mn-ea"/>
+                <a:cs typeface="+mn-cs"/>
+              </a:defRPr>
+            </a:lvl8pPr>
+            <a:lvl9pPr marL="3886200" indent="-228600" algn="l" defTabSz="914400" rtl="0" eaLnBrk="1" latinLnBrk="0" hangingPunct="1">
+              <a:lnSpc>
+                <a:spcPct val="90000"/>
+              </a:lnSpc>
+              <a:spcBef>
+                <a:spcPts val="500"/>
+              </a:spcBef>
+              <a:buFont typeface="Arial" panose="020B0604020202020204" pitchFamily="34" charset="0"/>
+              <a:buChar char="•"/>
+              <a:defRPr sz="1800" kern="1200">
+                <a:solidFill>
+                  <a:schemeClr val="tx1"/>
+                </a:solidFill>
+                <a:latin typeface="+mn-lt"/>
+                <a:ea typeface="+mn-ea"/>
+                <a:cs typeface="+mn-cs"/>
+              </a:defRPr>
+            </a:lvl9pPr>
+          </a:lstStyle>
+          <a:p>
+            <a:r>
+              <a:rPr lang="it-IT" b="1" dirty="0" err="1"/>
+              <a:t>DettaglioAsta</a:t>
+            </a:r>
+            <a:endParaRPr lang="it-IT" b="1" dirty="0"/>
+          </a:p>
+          <a:p>
+            <a:pPr marL="457200" lvl="1" indent="0" eaLnBrk="0" fontAlgn="base" hangingPunct="0">
+              <a:lnSpc>
+                <a:spcPct val="100000"/>
+              </a:lnSpc>
+              <a:spcBef>
+                <a:spcPct val="0"/>
+              </a:spcBef>
+              <a:spcAft>
+                <a:spcPct val="0"/>
+              </a:spcAft>
+              <a:buFontTx/>
+              <a:buChar char="•"/>
+            </a:pPr>
+            <a:r>
+              <a:rPr lang="it-IT" altLang="it-IT" sz="1200" dirty="0" err="1">
+                <a:latin typeface="Arial Unicode MS"/>
+              </a:rPr>
+              <a:t>mostraDettaglioAstaAperta</a:t>
+            </a:r>
+            <a:r>
+              <a:rPr lang="it-IT" altLang="it-IT" sz="1200" dirty="0">
+                <a:latin typeface="Arial Unicode MS"/>
+              </a:rPr>
+              <a:t>(data)</a:t>
+            </a:r>
+            <a:r>
+              <a:rPr lang="it-IT" altLang="it-IT" sz="1200" dirty="0"/>
+              <a:t> → mostra dettagli e offerte di un’asta aperta</a:t>
+            </a:r>
+            <a:endParaRPr lang="it-IT" altLang="it-IT" sz="1200" dirty="0">
+              <a:latin typeface="Arial" panose="020B0604020202020204" pitchFamily="34" charset="0"/>
+            </a:endParaRPr>
+          </a:p>
+          <a:p>
+            <a:pPr marL="457200" lvl="1" indent="0" eaLnBrk="0" fontAlgn="base" hangingPunct="0">
+              <a:lnSpc>
+                <a:spcPct val="100000"/>
+              </a:lnSpc>
+              <a:spcBef>
+                <a:spcPct val="0"/>
+              </a:spcBef>
+              <a:spcAft>
+                <a:spcPct val="0"/>
+              </a:spcAft>
+              <a:buFontTx/>
+              <a:buChar char="•"/>
+            </a:pPr>
+            <a:r>
+              <a:rPr lang="it-IT" altLang="it-IT" sz="1200" dirty="0" err="1">
+                <a:latin typeface="Arial Unicode MS"/>
+              </a:rPr>
+              <a:t>mostraDettaglioAstaChiusa</a:t>
+            </a:r>
+            <a:r>
+              <a:rPr lang="it-IT" altLang="it-IT" sz="1200" dirty="0">
+                <a:latin typeface="Arial Unicode MS"/>
+              </a:rPr>
+              <a:t>(data)</a:t>
+            </a:r>
+            <a:r>
+              <a:rPr lang="it-IT" altLang="it-IT" sz="1200" dirty="0"/>
+              <a:t> → mostra dettagli di un’asta chiusa</a:t>
+            </a:r>
+            <a:endParaRPr lang="it-IT" altLang="it-IT" sz="1200" dirty="0">
+              <a:latin typeface="Arial" panose="020B0604020202020204" pitchFamily="34" charset="0"/>
+            </a:endParaRPr>
+          </a:p>
+          <a:p>
+            <a:pPr marL="457200" lvl="1" indent="0" eaLnBrk="0" fontAlgn="base" hangingPunct="0">
+              <a:lnSpc>
+                <a:spcPct val="100000"/>
+              </a:lnSpc>
+              <a:spcBef>
+                <a:spcPct val="0"/>
+              </a:spcBef>
+              <a:spcAft>
+                <a:spcPct val="0"/>
+              </a:spcAft>
+              <a:buFontTx/>
+              <a:buChar char="•"/>
+            </a:pPr>
+            <a:r>
+              <a:rPr lang="it-IT" altLang="it-IT" sz="1200" dirty="0" err="1">
+                <a:latin typeface="Arial Unicode MS"/>
+              </a:rPr>
+              <a:t>caricaChiudiAstaButton</a:t>
+            </a:r>
+            <a:r>
+              <a:rPr lang="it-IT" altLang="it-IT" sz="1200" dirty="0">
+                <a:latin typeface="Arial Unicode MS"/>
+              </a:rPr>
+              <a:t>()</a:t>
+            </a:r>
+            <a:r>
+              <a:rPr lang="it-IT" altLang="it-IT" sz="1200" dirty="0"/>
+              <a:t> → collega bottone “Chiudi asta” e invia richiesta al server</a:t>
+            </a:r>
+            <a:endParaRPr lang="it-IT" altLang="it-IT" sz="1200" dirty="0">
+              <a:latin typeface="Arial" panose="020B0604020202020204" pitchFamily="34" charset="0"/>
+            </a:endParaRPr>
+          </a:p>
+          <a:p>
+            <a:pPr lvl="1"/>
+            <a:endParaRPr lang="it-IT" b="1" dirty="0"/>
+          </a:p>
+          <a:p>
+            <a:pPr lvl="1"/>
+            <a:endParaRPr lang="it-IT" b="1" dirty="0"/>
+          </a:p>
+          <a:p>
+            <a:pPr lvl="1">
+              <a:buFont typeface="Courier New" panose="02070309020205020404" pitchFamily="49" charset="0"/>
+              <a:buChar char="o"/>
+            </a:pPr>
+            <a:endParaRPr lang="it-IT" b="1" dirty="0"/>
+          </a:p>
+          <a:p>
+            <a:pPr lvl="1">
+              <a:buFont typeface="Courier New" panose="02070309020205020404" pitchFamily="49" charset="0"/>
+              <a:buChar char="o"/>
+            </a:pPr>
+            <a:endParaRPr lang="it-IT" sz="1400" dirty="0"/>
+          </a:p>
+        </p:txBody>
+      </p:sp>
+      <p:sp>
+        <p:nvSpPr>
+          <p:cNvPr id="12" name="Segnaposto contenuto 2">
+            <a:extLst>
+              <a:ext uri="{FF2B5EF4-FFF2-40B4-BE49-F238E27FC236}">
+                <a16:creationId xmlns:a16="http://schemas.microsoft.com/office/drawing/2014/main" id="{D04FA927-EC0F-E43A-1F4A-3B6FFE9AC345}"/>
+              </a:ext>
+            </a:extLst>
+          </p:cNvPr>
+          <p:cNvSpPr txBox="1">
+            <a:spLocks/>
+          </p:cNvSpPr>
+          <p:nvPr/>
+        </p:nvSpPr>
+        <p:spPr>
+          <a:xfrm>
+            <a:off x="6095999" y="1870341"/>
+            <a:ext cx="5682236" cy="3739896"/>
+          </a:xfrm>
+          <a:prstGeom prst="rect">
+            <a:avLst/>
+          </a:prstGeom>
+        </p:spPr>
+        <p:txBody>
+          <a:bodyPr vert="horz" lIns="91440" tIns="45720" rIns="91440" bIns="45720" rtlCol="0">
+            <a:normAutofit/>
+          </a:bodyPr>
+          <a:lstStyle>
+            <a:lvl1pPr marL="228600" indent="-228600" algn="l" defTabSz="914400" rtl="0" eaLnBrk="1" latinLnBrk="0" hangingPunct="1">
+              <a:lnSpc>
+                <a:spcPct val="110000"/>
+              </a:lnSpc>
+              <a:spcBef>
+                <a:spcPts val="1000"/>
+              </a:spcBef>
+              <a:buFont typeface="Arial" panose="020B0604020202020204" pitchFamily="34" charset="0"/>
+              <a:buChar char="•"/>
+              <a:defRPr sz="2000" kern="1200">
+                <a:solidFill>
+                  <a:schemeClr val="tx1"/>
+                </a:solidFill>
+                <a:latin typeface="+mn-lt"/>
+                <a:ea typeface="+mn-ea"/>
+                <a:cs typeface="+mn-cs"/>
+              </a:defRPr>
+            </a:lvl1pPr>
+            <a:lvl2pPr marL="685800" indent="-228600" algn="l" defTabSz="914400" rtl="0" eaLnBrk="1" latinLnBrk="0" hangingPunct="1">
+              <a:lnSpc>
+                <a:spcPct val="110000"/>
+              </a:lnSpc>
+              <a:spcBef>
+                <a:spcPts val="500"/>
+              </a:spcBef>
+              <a:buFont typeface="Arial" panose="020B0604020202020204" pitchFamily="34" charset="0"/>
+              <a:buChar char="•"/>
+              <a:defRPr sz="1800" kern="1200">
+                <a:solidFill>
+                  <a:schemeClr val="tx1"/>
+                </a:solidFill>
+                <a:latin typeface="+mn-lt"/>
+                <a:ea typeface="+mn-ea"/>
+                <a:cs typeface="+mn-cs"/>
+              </a:defRPr>
+            </a:lvl2pPr>
+            <a:lvl3pPr marL="1143000" indent="-228600" algn="l" defTabSz="914400" rtl="0" eaLnBrk="1" latinLnBrk="0" hangingPunct="1">
+              <a:lnSpc>
+                <a:spcPct val="110000"/>
+              </a:lnSpc>
+              <a:spcBef>
+                <a:spcPts val="500"/>
+              </a:spcBef>
+              <a:buFont typeface="Arial" panose="020B0604020202020204" pitchFamily="34" charset="0"/>
+              <a:buChar char="•"/>
+              <a:defRPr sz="1600" kern="1200">
+                <a:solidFill>
+                  <a:schemeClr val="tx1"/>
+                </a:solidFill>
+                <a:latin typeface="+mn-lt"/>
+                <a:ea typeface="+mn-ea"/>
+                <a:cs typeface="+mn-cs"/>
+              </a:defRPr>
+            </a:lvl3pPr>
+            <a:lvl4pPr marL="1600200" indent="-228600" algn="l" defTabSz="914400" rtl="0" eaLnBrk="1" latinLnBrk="0" hangingPunct="1">
+              <a:lnSpc>
+                <a:spcPct val="110000"/>
+              </a:lnSpc>
+              <a:spcBef>
+                <a:spcPts val="500"/>
+              </a:spcBef>
+              <a:buFont typeface="Arial" panose="020B0604020202020204" pitchFamily="34" charset="0"/>
+              <a:buChar char="•"/>
+              <a:defRPr sz="1400" kern="1200">
+                <a:solidFill>
+                  <a:schemeClr val="tx1"/>
+                </a:solidFill>
+                <a:latin typeface="+mn-lt"/>
+                <a:ea typeface="+mn-ea"/>
+                <a:cs typeface="+mn-cs"/>
+              </a:defRPr>
+            </a:lvl4pPr>
+            <a:lvl5pPr marL="2057400" indent="-228600" algn="l" defTabSz="914400" rtl="0" eaLnBrk="1" latinLnBrk="0" hangingPunct="1">
+              <a:lnSpc>
+                <a:spcPct val="110000"/>
+              </a:lnSpc>
+              <a:spcBef>
+                <a:spcPts val="500"/>
+              </a:spcBef>
+              <a:buFont typeface="Arial" panose="020B0604020202020204" pitchFamily="34" charset="0"/>
+              <a:buChar char="•"/>
+              <a:defRPr sz="1400" kern="1200">
+                <a:solidFill>
+                  <a:schemeClr val="tx1"/>
+                </a:solidFill>
+                <a:latin typeface="+mn-lt"/>
+                <a:ea typeface="+mn-ea"/>
+                <a:cs typeface="+mn-cs"/>
+              </a:defRPr>
+            </a:lvl5pPr>
+            <a:lvl6pPr marL="2514600" indent="-228600" algn="l" defTabSz="914400" rtl="0" eaLnBrk="1" latinLnBrk="0" hangingPunct="1">
+              <a:lnSpc>
+                <a:spcPct val="90000"/>
+              </a:lnSpc>
+              <a:spcBef>
+                <a:spcPts val="500"/>
+              </a:spcBef>
+              <a:buFont typeface="Arial" panose="020B0604020202020204" pitchFamily="34" charset="0"/>
+              <a:buChar char="•"/>
+              <a:defRPr sz="1800" kern="1200">
+                <a:solidFill>
+                  <a:schemeClr val="tx1"/>
+                </a:solidFill>
+                <a:latin typeface="+mn-lt"/>
+                <a:ea typeface="+mn-ea"/>
+                <a:cs typeface="+mn-cs"/>
+              </a:defRPr>
+            </a:lvl6pPr>
+            <a:lvl7pPr marL="2971800" indent="-228600" algn="l" defTabSz="914400" rtl="0" eaLnBrk="1" latinLnBrk="0" hangingPunct="1">
+              <a:lnSpc>
+                <a:spcPct val="90000"/>
+              </a:lnSpc>
+              <a:spcBef>
+                <a:spcPts val="500"/>
+              </a:spcBef>
+              <a:buFont typeface="Arial" panose="020B0604020202020204" pitchFamily="34" charset="0"/>
+              <a:buChar char="•"/>
+              <a:defRPr sz="1800" kern="1200">
+                <a:solidFill>
+                  <a:schemeClr val="tx1"/>
+                </a:solidFill>
+                <a:latin typeface="+mn-lt"/>
+                <a:ea typeface="+mn-ea"/>
+                <a:cs typeface="+mn-cs"/>
+              </a:defRPr>
+            </a:lvl7pPr>
+            <a:lvl8pPr marL="3429000" indent="-228600" algn="l" defTabSz="914400" rtl="0" eaLnBrk="1" latinLnBrk="0" hangingPunct="1">
+              <a:lnSpc>
+                <a:spcPct val="90000"/>
+              </a:lnSpc>
+              <a:spcBef>
+                <a:spcPts val="500"/>
+              </a:spcBef>
+              <a:buFont typeface="Arial" panose="020B0604020202020204" pitchFamily="34" charset="0"/>
+              <a:buChar char="•"/>
+              <a:defRPr sz="1800" kern="1200">
+                <a:solidFill>
+                  <a:schemeClr val="tx1"/>
+                </a:solidFill>
+                <a:latin typeface="+mn-lt"/>
+                <a:ea typeface="+mn-ea"/>
+                <a:cs typeface="+mn-cs"/>
+              </a:defRPr>
+            </a:lvl8pPr>
+            <a:lvl9pPr marL="3886200" indent="-228600" algn="l" defTabSz="914400" rtl="0" eaLnBrk="1" latinLnBrk="0" hangingPunct="1">
+              <a:lnSpc>
+                <a:spcPct val="90000"/>
+              </a:lnSpc>
+              <a:spcBef>
+                <a:spcPts val="500"/>
+              </a:spcBef>
+              <a:buFont typeface="Arial" panose="020B0604020202020204" pitchFamily="34" charset="0"/>
+              <a:buChar char="•"/>
+              <a:defRPr sz="1800" kern="1200">
+                <a:solidFill>
+                  <a:schemeClr val="tx1"/>
+                </a:solidFill>
+                <a:latin typeface="+mn-lt"/>
+                <a:ea typeface="+mn-ea"/>
+                <a:cs typeface="+mn-cs"/>
+              </a:defRPr>
+            </a:lvl9pPr>
+          </a:lstStyle>
+          <a:p>
+            <a:r>
+              <a:rPr lang="it-IT" b="1" dirty="0"/>
+              <a:t>Acquisto</a:t>
+            </a:r>
+          </a:p>
+          <a:p>
+            <a:pPr marL="457200" lvl="1" indent="0" eaLnBrk="0" fontAlgn="base" hangingPunct="0">
+              <a:lnSpc>
+                <a:spcPct val="100000"/>
+              </a:lnSpc>
+              <a:spcBef>
+                <a:spcPct val="0"/>
+              </a:spcBef>
+              <a:spcAft>
+                <a:spcPct val="0"/>
+              </a:spcAft>
+              <a:buFontTx/>
+              <a:buChar char="•"/>
+            </a:pPr>
+            <a:r>
+              <a:rPr lang="it-IT" altLang="it-IT" sz="1200" dirty="0" err="1">
+                <a:latin typeface="Arial Unicode MS"/>
+              </a:rPr>
+              <a:t>renderAcquistoPage</a:t>
+            </a:r>
+            <a:r>
+              <a:rPr lang="it-IT" altLang="it-IT" sz="1200" dirty="0">
+                <a:latin typeface="Arial Unicode MS"/>
+              </a:rPr>
+              <a:t>()</a:t>
+            </a:r>
+            <a:r>
+              <a:rPr lang="it-IT" altLang="it-IT" sz="1200" dirty="0"/>
+              <a:t> → apre pagina Acquisto e collega pulsante ricerca</a:t>
+            </a:r>
+            <a:endParaRPr lang="it-IT" altLang="it-IT" sz="1200" dirty="0">
+              <a:latin typeface="Arial" panose="020B0604020202020204" pitchFamily="34" charset="0"/>
+            </a:endParaRPr>
+          </a:p>
+          <a:p>
+            <a:pPr marL="457200" lvl="1" indent="0" eaLnBrk="0" fontAlgn="base" hangingPunct="0">
+              <a:lnSpc>
+                <a:spcPct val="100000"/>
+              </a:lnSpc>
+              <a:spcBef>
+                <a:spcPct val="0"/>
+              </a:spcBef>
+              <a:spcAft>
+                <a:spcPct val="0"/>
+              </a:spcAft>
+              <a:buFontTx/>
+              <a:buChar char="•"/>
+            </a:pPr>
+            <a:r>
+              <a:rPr lang="it-IT" altLang="it-IT" sz="1200" dirty="0" err="1">
+                <a:latin typeface="Arial Unicode MS"/>
+              </a:rPr>
+              <a:t>searchAstaByKeyword</a:t>
+            </a:r>
+            <a:r>
+              <a:rPr lang="it-IT" altLang="it-IT" sz="1200" dirty="0">
+                <a:latin typeface="Arial Unicode MS"/>
+              </a:rPr>
+              <a:t>()</a:t>
+            </a:r>
+            <a:r>
+              <a:rPr lang="it-IT" altLang="it-IT" sz="1200" dirty="0"/>
+              <a:t> → cerca aste per parola chiave</a:t>
+            </a:r>
+            <a:endParaRPr lang="it-IT" altLang="it-IT" sz="1200" dirty="0">
+              <a:latin typeface="Arial" panose="020B0604020202020204" pitchFamily="34" charset="0"/>
+            </a:endParaRPr>
+          </a:p>
+          <a:p>
+            <a:pPr marL="457200" lvl="1" indent="0" eaLnBrk="0" fontAlgn="base" hangingPunct="0">
+              <a:lnSpc>
+                <a:spcPct val="100000"/>
+              </a:lnSpc>
+              <a:spcBef>
+                <a:spcPct val="0"/>
+              </a:spcBef>
+              <a:spcAft>
+                <a:spcPct val="0"/>
+              </a:spcAft>
+              <a:buFontTx/>
+              <a:buChar char="•"/>
+            </a:pPr>
+            <a:r>
+              <a:rPr lang="it-IT" altLang="it-IT" sz="1200" dirty="0" err="1">
+                <a:latin typeface="Arial Unicode MS"/>
+              </a:rPr>
+              <a:t>showAsteByKeyword</a:t>
+            </a:r>
+            <a:r>
+              <a:rPr lang="it-IT" altLang="it-IT" sz="1200" dirty="0">
+                <a:latin typeface="Arial Unicode MS"/>
+              </a:rPr>
+              <a:t>(</a:t>
+            </a:r>
+            <a:r>
+              <a:rPr lang="it-IT" altLang="it-IT" sz="1200" dirty="0" err="1">
+                <a:latin typeface="Arial Unicode MS"/>
+              </a:rPr>
+              <a:t>request</a:t>
+            </a:r>
+            <a:r>
+              <a:rPr lang="it-IT" altLang="it-IT" sz="1200" dirty="0">
+                <a:latin typeface="Arial Unicode MS"/>
+              </a:rPr>
+              <a:t>)</a:t>
+            </a:r>
+            <a:r>
+              <a:rPr lang="it-IT" altLang="it-IT" sz="1200" dirty="0"/>
+              <a:t> → mostra i risultati della ricerca</a:t>
+            </a:r>
+            <a:endParaRPr lang="it-IT" altLang="it-IT" sz="1200" dirty="0">
+              <a:latin typeface="Arial" panose="020B0604020202020204" pitchFamily="34" charset="0"/>
+            </a:endParaRPr>
+          </a:p>
+          <a:p>
+            <a:pPr marL="457200" lvl="1" indent="0" eaLnBrk="0" fontAlgn="base" hangingPunct="0">
+              <a:lnSpc>
+                <a:spcPct val="100000"/>
+              </a:lnSpc>
+              <a:spcBef>
+                <a:spcPct val="0"/>
+              </a:spcBef>
+              <a:spcAft>
+                <a:spcPct val="0"/>
+              </a:spcAft>
+              <a:buFontTx/>
+              <a:buChar char="•"/>
+            </a:pPr>
+            <a:r>
+              <a:rPr lang="it-IT" altLang="it-IT" sz="1200" dirty="0" err="1">
+                <a:latin typeface="Arial Unicode MS"/>
+              </a:rPr>
+              <a:t>addAstaTrovataInTable</a:t>
+            </a:r>
+            <a:r>
+              <a:rPr lang="it-IT" altLang="it-IT" sz="1200" dirty="0">
+                <a:latin typeface="Arial Unicode MS"/>
+              </a:rPr>
+              <a:t>(asta)</a:t>
+            </a:r>
+            <a:r>
+              <a:rPr lang="it-IT" altLang="it-IT" sz="1200" dirty="0"/>
+              <a:t> → aggiunge una riga asta trovata in tabella</a:t>
+            </a:r>
+            <a:endParaRPr lang="it-IT" altLang="it-IT" sz="1200" dirty="0">
+              <a:latin typeface="Arial" panose="020B0604020202020204" pitchFamily="34" charset="0"/>
+            </a:endParaRPr>
+          </a:p>
+          <a:p>
+            <a:pPr marL="457200" lvl="1" indent="0" eaLnBrk="0" fontAlgn="base" hangingPunct="0">
+              <a:lnSpc>
+                <a:spcPct val="100000"/>
+              </a:lnSpc>
+              <a:spcBef>
+                <a:spcPct val="0"/>
+              </a:spcBef>
+              <a:spcAft>
+                <a:spcPct val="0"/>
+              </a:spcAft>
+              <a:buFontTx/>
+              <a:buChar char="•"/>
+            </a:pPr>
+            <a:r>
+              <a:rPr lang="it-IT" altLang="it-IT" sz="1200" dirty="0" err="1">
+                <a:latin typeface="Arial Unicode MS"/>
+              </a:rPr>
+              <a:t>renderAsteVisionateEAggiudicate</a:t>
+            </a:r>
+            <a:r>
+              <a:rPr lang="it-IT" altLang="it-IT" sz="1200" dirty="0">
+                <a:latin typeface="Arial Unicode MS"/>
+              </a:rPr>
+              <a:t>()</a:t>
+            </a:r>
+            <a:r>
+              <a:rPr lang="it-IT" altLang="it-IT" sz="1200" dirty="0"/>
+              <a:t> → mostra aste visitate e vinte</a:t>
+            </a:r>
+            <a:endParaRPr lang="it-IT" altLang="it-IT" sz="1200" dirty="0">
+              <a:latin typeface="Arial" panose="020B0604020202020204" pitchFamily="34" charset="0"/>
+            </a:endParaRPr>
+          </a:p>
+          <a:p>
+            <a:pPr marL="457200" lvl="1" indent="0" eaLnBrk="0" fontAlgn="base" hangingPunct="0">
+              <a:lnSpc>
+                <a:spcPct val="100000"/>
+              </a:lnSpc>
+              <a:spcBef>
+                <a:spcPct val="0"/>
+              </a:spcBef>
+              <a:spcAft>
+                <a:spcPct val="0"/>
+              </a:spcAft>
+              <a:buFontTx/>
+              <a:buChar char="•"/>
+            </a:pPr>
+            <a:r>
+              <a:rPr lang="it-IT" altLang="it-IT" sz="1200" dirty="0" err="1">
+                <a:latin typeface="Arial Unicode MS"/>
+              </a:rPr>
+              <a:t>addAstaVintaInTable</a:t>
+            </a:r>
+            <a:r>
+              <a:rPr lang="it-IT" altLang="it-IT" sz="1200" dirty="0">
+                <a:latin typeface="Arial Unicode MS"/>
+              </a:rPr>
+              <a:t>(asta)</a:t>
+            </a:r>
+            <a:r>
+              <a:rPr lang="it-IT" altLang="it-IT" sz="1200" dirty="0"/>
+              <a:t> → aggiunge asta vinta in tabella</a:t>
+            </a:r>
+            <a:endParaRPr lang="it-IT" altLang="it-IT" sz="1200" dirty="0">
+              <a:latin typeface="Arial" panose="020B0604020202020204" pitchFamily="34" charset="0"/>
+            </a:endParaRPr>
+          </a:p>
+          <a:p>
+            <a:pPr lvl="1"/>
+            <a:endParaRPr lang="it-IT" b="1" dirty="0"/>
+          </a:p>
+          <a:p>
+            <a:pPr lvl="1">
+              <a:buFont typeface="Courier New" panose="02070309020205020404" pitchFamily="49" charset="0"/>
+              <a:buChar char="o"/>
+            </a:pPr>
+            <a:endParaRPr lang="it-IT" b="1" dirty="0"/>
+          </a:p>
+          <a:p>
+            <a:pPr lvl="1">
+              <a:buFont typeface="Courier New" panose="02070309020205020404" pitchFamily="49" charset="0"/>
+              <a:buChar char="o"/>
+            </a:pPr>
+            <a:endParaRPr lang="it-IT" sz="1400" dirty="0"/>
+          </a:p>
+        </p:txBody>
+      </p:sp>
+      <p:sp>
+        <p:nvSpPr>
+          <p:cNvPr id="13" name="Segnaposto contenuto 2">
+            <a:extLst>
+              <a:ext uri="{FF2B5EF4-FFF2-40B4-BE49-F238E27FC236}">
+                <a16:creationId xmlns:a16="http://schemas.microsoft.com/office/drawing/2014/main" id="{1F890BC6-1059-90D7-118F-9773B9012093}"/>
+              </a:ext>
+            </a:extLst>
+          </p:cNvPr>
+          <p:cNvSpPr txBox="1">
+            <a:spLocks/>
+          </p:cNvSpPr>
+          <p:nvPr/>
+        </p:nvSpPr>
+        <p:spPr>
+          <a:xfrm>
+            <a:off x="6172200" y="4739771"/>
+            <a:ext cx="5819419" cy="3739896"/>
+          </a:xfrm>
+          <a:prstGeom prst="rect">
+            <a:avLst/>
+          </a:prstGeom>
+        </p:spPr>
+        <p:txBody>
+          <a:bodyPr vert="horz" lIns="91440" tIns="45720" rIns="91440" bIns="45720" rtlCol="0">
+            <a:normAutofit/>
+          </a:bodyPr>
+          <a:lstStyle>
+            <a:lvl1pPr marL="228600" indent="-228600" algn="l" defTabSz="914400" rtl="0" eaLnBrk="1" latinLnBrk="0" hangingPunct="1">
+              <a:lnSpc>
+                <a:spcPct val="110000"/>
+              </a:lnSpc>
+              <a:spcBef>
+                <a:spcPts val="1000"/>
+              </a:spcBef>
+              <a:buFont typeface="Arial" panose="020B0604020202020204" pitchFamily="34" charset="0"/>
+              <a:buChar char="•"/>
+              <a:defRPr sz="2000" kern="1200">
+                <a:solidFill>
+                  <a:schemeClr val="tx1"/>
+                </a:solidFill>
+                <a:latin typeface="+mn-lt"/>
+                <a:ea typeface="+mn-ea"/>
+                <a:cs typeface="+mn-cs"/>
+              </a:defRPr>
+            </a:lvl1pPr>
+            <a:lvl2pPr marL="685800" indent="-228600" algn="l" defTabSz="914400" rtl="0" eaLnBrk="1" latinLnBrk="0" hangingPunct="1">
+              <a:lnSpc>
+                <a:spcPct val="110000"/>
+              </a:lnSpc>
+              <a:spcBef>
+                <a:spcPts val="500"/>
+              </a:spcBef>
+              <a:buFont typeface="Arial" panose="020B0604020202020204" pitchFamily="34" charset="0"/>
+              <a:buChar char="•"/>
+              <a:defRPr sz="1800" kern="1200">
+                <a:solidFill>
+                  <a:schemeClr val="tx1"/>
+                </a:solidFill>
+                <a:latin typeface="+mn-lt"/>
+                <a:ea typeface="+mn-ea"/>
+                <a:cs typeface="+mn-cs"/>
+              </a:defRPr>
+            </a:lvl2pPr>
+            <a:lvl3pPr marL="1143000" indent="-228600" algn="l" defTabSz="914400" rtl="0" eaLnBrk="1" latinLnBrk="0" hangingPunct="1">
+              <a:lnSpc>
+                <a:spcPct val="110000"/>
+              </a:lnSpc>
+              <a:spcBef>
+                <a:spcPts val="500"/>
+              </a:spcBef>
+              <a:buFont typeface="Arial" panose="020B0604020202020204" pitchFamily="34" charset="0"/>
+              <a:buChar char="•"/>
+              <a:defRPr sz="1600" kern="1200">
+                <a:solidFill>
+                  <a:schemeClr val="tx1"/>
+                </a:solidFill>
+                <a:latin typeface="+mn-lt"/>
+                <a:ea typeface="+mn-ea"/>
+                <a:cs typeface="+mn-cs"/>
+              </a:defRPr>
+            </a:lvl3pPr>
+            <a:lvl4pPr marL="1600200" indent="-228600" algn="l" defTabSz="914400" rtl="0" eaLnBrk="1" latinLnBrk="0" hangingPunct="1">
+              <a:lnSpc>
+                <a:spcPct val="110000"/>
+              </a:lnSpc>
+              <a:spcBef>
+                <a:spcPts val="500"/>
+              </a:spcBef>
+              <a:buFont typeface="Arial" panose="020B0604020202020204" pitchFamily="34" charset="0"/>
+              <a:buChar char="•"/>
+              <a:defRPr sz="1400" kern="1200">
+                <a:solidFill>
+                  <a:schemeClr val="tx1"/>
+                </a:solidFill>
+                <a:latin typeface="+mn-lt"/>
+                <a:ea typeface="+mn-ea"/>
+                <a:cs typeface="+mn-cs"/>
+              </a:defRPr>
+            </a:lvl4pPr>
+            <a:lvl5pPr marL="2057400" indent="-228600" algn="l" defTabSz="914400" rtl="0" eaLnBrk="1" latinLnBrk="0" hangingPunct="1">
+              <a:lnSpc>
+                <a:spcPct val="110000"/>
+              </a:lnSpc>
+              <a:spcBef>
+                <a:spcPts val="500"/>
+              </a:spcBef>
+              <a:buFont typeface="Arial" panose="020B0604020202020204" pitchFamily="34" charset="0"/>
+              <a:buChar char="•"/>
+              <a:defRPr sz="1400" kern="1200">
+                <a:solidFill>
+                  <a:schemeClr val="tx1"/>
+                </a:solidFill>
+                <a:latin typeface="+mn-lt"/>
+                <a:ea typeface="+mn-ea"/>
+                <a:cs typeface="+mn-cs"/>
+              </a:defRPr>
+            </a:lvl5pPr>
+            <a:lvl6pPr marL="2514600" indent="-228600" algn="l" defTabSz="914400" rtl="0" eaLnBrk="1" latinLnBrk="0" hangingPunct="1">
+              <a:lnSpc>
+                <a:spcPct val="90000"/>
+              </a:lnSpc>
+              <a:spcBef>
+                <a:spcPts val="500"/>
+              </a:spcBef>
+              <a:buFont typeface="Arial" panose="020B0604020202020204" pitchFamily="34" charset="0"/>
+              <a:buChar char="•"/>
+              <a:defRPr sz="1800" kern="1200">
+                <a:solidFill>
+                  <a:schemeClr val="tx1"/>
+                </a:solidFill>
+                <a:latin typeface="+mn-lt"/>
+                <a:ea typeface="+mn-ea"/>
+                <a:cs typeface="+mn-cs"/>
+              </a:defRPr>
+            </a:lvl6pPr>
+            <a:lvl7pPr marL="2971800" indent="-228600" algn="l" defTabSz="914400" rtl="0" eaLnBrk="1" latinLnBrk="0" hangingPunct="1">
+              <a:lnSpc>
+                <a:spcPct val="90000"/>
+              </a:lnSpc>
+              <a:spcBef>
+                <a:spcPts val="500"/>
+              </a:spcBef>
+              <a:buFont typeface="Arial" panose="020B0604020202020204" pitchFamily="34" charset="0"/>
+              <a:buChar char="•"/>
+              <a:defRPr sz="1800" kern="1200">
+                <a:solidFill>
+                  <a:schemeClr val="tx1"/>
+                </a:solidFill>
+                <a:latin typeface="+mn-lt"/>
+                <a:ea typeface="+mn-ea"/>
+                <a:cs typeface="+mn-cs"/>
+              </a:defRPr>
+            </a:lvl7pPr>
+            <a:lvl8pPr marL="3429000" indent="-228600" algn="l" defTabSz="914400" rtl="0" eaLnBrk="1" latinLnBrk="0" hangingPunct="1">
+              <a:lnSpc>
+                <a:spcPct val="90000"/>
+              </a:lnSpc>
+              <a:spcBef>
+                <a:spcPts val="500"/>
+              </a:spcBef>
+              <a:buFont typeface="Arial" panose="020B0604020202020204" pitchFamily="34" charset="0"/>
+              <a:buChar char="•"/>
+              <a:defRPr sz="1800" kern="1200">
+                <a:solidFill>
+                  <a:schemeClr val="tx1"/>
+                </a:solidFill>
+                <a:latin typeface="+mn-lt"/>
+                <a:ea typeface="+mn-ea"/>
+                <a:cs typeface="+mn-cs"/>
+              </a:defRPr>
+            </a:lvl8pPr>
+            <a:lvl9pPr marL="3886200" indent="-228600" algn="l" defTabSz="914400" rtl="0" eaLnBrk="1" latinLnBrk="0" hangingPunct="1">
+              <a:lnSpc>
+                <a:spcPct val="90000"/>
+              </a:lnSpc>
+              <a:spcBef>
+                <a:spcPts val="500"/>
+              </a:spcBef>
+              <a:buFont typeface="Arial" panose="020B0604020202020204" pitchFamily="34" charset="0"/>
+              <a:buChar char="•"/>
+              <a:defRPr sz="1800" kern="1200">
+                <a:solidFill>
+                  <a:schemeClr val="tx1"/>
+                </a:solidFill>
+                <a:latin typeface="+mn-lt"/>
+                <a:ea typeface="+mn-ea"/>
+                <a:cs typeface="+mn-cs"/>
+              </a:defRPr>
+            </a:lvl9pPr>
+          </a:lstStyle>
+          <a:p>
+            <a:r>
+              <a:rPr lang="it-IT" b="1" dirty="0"/>
+              <a:t>Offerta</a:t>
+            </a:r>
+          </a:p>
+          <a:p>
+            <a:pPr marL="457200" lvl="1" indent="0" eaLnBrk="0" fontAlgn="base" hangingPunct="0">
+              <a:lnSpc>
+                <a:spcPct val="100000"/>
+              </a:lnSpc>
+              <a:spcBef>
+                <a:spcPct val="0"/>
+              </a:spcBef>
+              <a:spcAft>
+                <a:spcPct val="0"/>
+              </a:spcAft>
+              <a:buFontTx/>
+              <a:buChar char="•"/>
+            </a:pPr>
+            <a:r>
+              <a:rPr lang="it-IT" altLang="it-IT" sz="1200" dirty="0" err="1">
+                <a:latin typeface="Arial Unicode MS"/>
+              </a:rPr>
+              <a:t>renderOffertaPage</a:t>
+            </a:r>
+            <a:r>
+              <a:rPr lang="it-IT" altLang="it-IT" sz="1200" dirty="0">
+                <a:latin typeface="Arial Unicode MS"/>
+              </a:rPr>
+              <a:t>(</a:t>
+            </a:r>
+            <a:r>
+              <a:rPr lang="it-IT" altLang="it-IT" sz="1200" dirty="0" err="1">
+                <a:latin typeface="Arial Unicode MS"/>
+              </a:rPr>
+              <a:t>idAsta</a:t>
+            </a:r>
+            <a:r>
+              <a:rPr lang="it-IT" altLang="it-IT" sz="1200" dirty="0">
+                <a:latin typeface="Arial Unicode MS"/>
+              </a:rPr>
+              <a:t>)</a:t>
+            </a:r>
+            <a:r>
+              <a:rPr lang="it-IT" altLang="it-IT" sz="1200" dirty="0"/>
+              <a:t> → mostra pagina offerta per una certa asta</a:t>
+            </a:r>
+            <a:endParaRPr lang="it-IT" altLang="it-IT" sz="1200" dirty="0">
+              <a:latin typeface="Arial" panose="020B0604020202020204" pitchFamily="34" charset="0"/>
+            </a:endParaRPr>
+          </a:p>
+          <a:p>
+            <a:pPr marL="457200" lvl="1" indent="0" eaLnBrk="0" fontAlgn="base" hangingPunct="0">
+              <a:lnSpc>
+                <a:spcPct val="100000"/>
+              </a:lnSpc>
+              <a:spcBef>
+                <a:spcPct val="0"/>
+              </a:spcBef>
+              <a:spcAft>
+                <a:spcPct val="0"/>
+              </a:spcAft>
+              <a:buFontTx/>
+              <a:buChar char="•"/>
+            </a:pPr>
+            <a:r>
+              <a:rPr lang="it-IT" altLang="it-IT" sz="1200" dirty="0" err="1">
+                <a:latin typeface="Arial Unicode MS"/>
+              </a:rPr>
+              <a:t>addArticoloInTable</a:t>
+            </a:r>
+            <a:r>
+              <a:rPr lang="it-IT" altLang="it-IT" sz="1200" dirty="0">
+                <a:latin typeface="Arial Unicode MS"/>
+              </a:rPr>
+              <a:t>(articolo)</a:t>
+            </a:r>
+            <a:r>
+              <a:rPr lang="it-IT" altLang="it-IT" sz="1200" dirty="0"/>
+              <a:t> → aggiunge un articolo alla tabella articoli asta</a:t>
+            </a:r>
+            <a:endParaRPr lang="it-IT" altLang="it-IT" sz="1200" dirty="0">
+              <a:latin typeface="Arial" panose="020B0604020202020204" pitchFamily="34" charset="0"/>
+            </a:endParaRPr>
+          </a:p>
+          <a:p>
+            <a:pPr marL="457200" lvl="1" indent="0" eaLnBrk="0" fontAlgn="base" hangingPunct="0">
+              <a:lnSpc>
+                <a:spcPct val="100000"/>
+              </a:lnSpc>
+              <a:spcBef>
+                <a:spcPct val="0"/>
+              </a:spcBef>
+              <a:spcAft>
+                <a:spcPct val="0"/>
+              </a:spcAft>
+              <a:buFontTx/>
+              <a:buChar char="•"/>
+            </a:pPr>
+            <a:r>
+              <a:rPr lang="it-IT" altLang="it-IT" sz="1200" dirty="0" err="1">
+                <a:latin typeface="Arial Unicode MS"/>
+              </a:rPr>
+              <a:t>addOffertaInTable</a:t>
+            </a:r>
+            <a:r>
+              <a:rPr lang="it-IT" altLang="it-IT" sz="1200" dirty="0">
+                <a:latin typeface="Arial Unicode MS"/>
+              </a:rPr>
+              <a:t>(offerta, nuova)</a:t>
+            </a:r>
+            <a:r>
+              <a:rPr lang="it-IT" altLang="it-IT" sz="1200" dirty="0"/>
+              <a:t> → aggiunge un’offerta alla tabella offerte</a:t>
+            </a:r>
+            <a:endParaRPr lang="it-IT" altLang="it-IT" sz="1200" dirty="0">
+              <a:latin typeface="Arial" panose="020B0604020202020204" pitchFamily="34" charset="0"/>
+            </a:endParaRPr>
+          </a:p>
+          <a:p>
+            <a:pPr marL="457200" lvl="1" indent="0" eaLnBrk="0" fontAlgn="base" hangingPunct="0">
+              <a:lnSpc>
+                <a:spcPct val="100000"/>
+              </a:lnSpc>
+              <a:spcBef>
+                <a:spcPct val="0"/>
+              </a:spcBef>
+              <a:spcAft>
+                <a:spcPct val="0"/>
+              </a:spcAft>
+              <a:buFontTx/>
+              <a:buChar char="•"/>
+            </a:pPr>
+            <a:r>
+              <a:rPr lang="it-IT" altLang="it-IT" sz="1200" dirty="0" err="1">
+                <a:latin typeface="Arial Unicode MS"/>
+              </a:rPr>
+              <a:t>faiOfferta</a:t>
+            </a:r>
+            <a:r>
+              <a:rPr lang="it-IT" altLang="it-IT" sz="1200" dirty="0">
+                <a:latin typeface="Arial Unicode MS"/>
+              </a:rPr>
+              <a:t>(</a:t>
+            </a:r>
+            <a:r>
+              <a:rPr lang="it-IT" altLang="it-IT" sz="1200" dirty="0" err="1">
+                <a:latin typeface="Arial Unicode MS"/>
+              </a:rPr>
+              <a:t>prezzoIniziale</a:t>
+            </a:r>
+            <a:r>
+              <a:rPr lang="it-IT" altLang="it-IT" sz="1200" dirty="0">
+                <a:latin typeface="Arial Unicode MS"/>
+              </a:rPr>
+              <a:t>, </a:t>
+            </a:r>
+            <a:r>
+              <a:rPr lang="it-IT" altLang="it-IT" sz="1200" dirty="0" err="1">
+                <a:latin typeface="Arial Unicode MS"/>
+              </a:rPr>
+              <a:t>prezzoOffertaMassima</a:t>
+            </a:r>
+            <a:r>
+              <a:rPr lang="it-IT" altLang="it-IT" sz="1200" dirty="0">
+                <a:latin typeface="Arial Unicode MS"/>
+              </a:rPr>
+              <a:t>, </a:t>
+            </a:r>
+            <a:r>
+              <a:rPr lang="it-IT" altLang="it-IT" sz="1200" dirty="0" err="1">
+                <a:latin typeface="Arial Unicode MS"/>
+              </a:rPr>
+              <a:t>rialzoMinimo</a:t>
+            </a:r>
+            <a:r>
+              <a:rPr lang="it-IT" altLang="it-IT" sz="1200" dirty="0">
+                <a:latin typeface="Arial Unicode MS"/>
+              </a:rPr>
+              <a:t>)</a:t>
+            </a:r>
+            <a:r>
+              <a:rPr lang="it-IT" altLang="it-IT" sz="1200" dirty="0"/>
+              <a:t> → invia una nuova offerta al server</a:t>
+            </a:r>
+            <a:endParaRPr lang="it-IT" altLang="it-IT" sz="1200" dirty="0">
+              <a:latin typeface="Arial" panose="020B0604020202020204" pitchFamily="34" charset="0"/>
+            </a:endParaRPr>
+          </a:p>
+          <a:p>
+            <a:pPr lvl="1"/>
+            <a:endParaRPr lang="it-IT" b="1" dirty="0"/>
+          </a:p>
+          <a:p>
+            <a:pPr lvl="1"/>
+            <a:endParaRPr lang="it-IT" b="1" dirty="0"/>
+          </a:p>
+          <a:p>
+            <a:pPr lvl="1">
+              <a:buFont typeface="Courier New" panose="02070309020205020404" pitchFamily="49" charset="0"/>
+              <a:buChar char="o"/>
+            </a:pPr>
+            <a:endParaRPr lang="it-IT" b="1" dirty="0"/>
+          </a:p>
+          <a:p>
+            <a:pPr lvl="1">
+              <a:buFont typeface="Courier New" panose="02070309020205020404" pitchFamily="49" charset="0"/>
+              <a:buChar char="o"/>
+            </a:pPr>
+            <a:endParaRPr lang="it-IT" sz="1400" dirty="0"/>
+          </a:p>
+        </p:txBody>
+      </p:sp>
+      <p:sp>
+        <p:nvSpPr>
+          <p:cNvPr id="17" name="Rectangle 7">
+            <a:extLst>
+              <a:ext uri="{FF2B5EF4-FFF2-40B4-BE49-F238E27FC236}">
+                <a16:creationId xmlns:a16="http://schemas.microsoft.com/office/drawing/2014/main" id="{5A043DE1-F99E-90A4-37A3-757CB7335A38}"/>
+              </a:ext>
+            </a:extLst>
+          </p:cNvPr>
+          <p:cNvSpPr>
+            <a:spLocks noChangeArrowheads="1"/>
+          </p:cNvSpPr>
+          <p:nvPr/>
+        </p:nvSpPr>
+        <p:spPr bwMode="auto">
+          <a:xfrm>
+            <a:off x="0" y="0"/>
+            <a:ext cx="12192000" cy="0"/>
+          </a:xfrm>
+          <a:prstGeom prst="rect">
+            <a:avLst/>
+          </a:prstGeom>
+          <a:noFill/>
+          <a:ln>
+            <a:noFill/>
+          </a:ln>
+          <a:effectLst/>
+          <a:extLst>
+            <a:ext uri="{909E8E84-426E-40DD-AFC4-6F175D3DCCD1}">
+              <a14:hiddenFill xmlns:a14="http://schemas.microsoft.com/office/drawing/2010/main">
+                <a:solidFill>
+                  <a:schemeClr val="accent1"/>
+                </a:solidFill>
+              </a14:hiddenFill>
+            </a:ext>
+            <a:ext uri="{91240B29-F687-4F45-9708-019B960494DF}">
+              <a14:hiddenLine xmlns:a14="http://schemas.microsoft.com/office/drawing/2010/main" w="9525">
+                <a:solidFill>
+                  <a:schemeClr val="tx1"/>
+                </a:solidFill>
+                <a:miter lim="800000"/>
+                <a:headEnd/>
+                <a:tailEnd/>
+              </a14:hiddenLine>
+            </a:ext>
+            <a:ext uri="{AF507438-7753-43E0-B8FC-AC1667EBCBE1}">
+              <a14:hiddenEffects xmlns:a14="http://schemas.microsoft.com/office/drawing/2010/main">
+                <a:effectLst>
+                  <a:outerShdw dist="35921" dir="2700000" algn="ctr" rotWithShape="0">
+                    <a:schemeClr val="bg2"/>
+                  </a:outerShdw>
+                </a:effectLst>
+              </a14:hiddenEffects>
+            </a:ext>
+          </a:extLst>
+        </p:spPr>
+        <p:txBody>
+          <a:bodyPr vert="horz" wrap="none" lIns="91440" tIns="45720" rIns="91440" bIns="45720" numCol="1" anchor="ctr" anchorCtr="0" compatLnSpc="1">
+            <a:prstTxWarp prst="textNoShape">
+              <a:avLst/>
+            </a:prstTxWarp>
+            <a:spAutoFit/>
+          </a:bodyPr>
+          <a:lstStyle/>
+          <a:p>
+            <a:pPr marL="0" marR="0" lvl="0" indent="0" algn="l" defTabSz="914400" rtl="0" eaLnBrk="0" fontAlgn="base" latinLnBrk="0" hangingPunct="0">
+              <a:lnSpc>
+                <a:spcPct val="100000"/>
+              </a:lnSpc>
+              <a:spcBef>
+                <a:spcPct val="0"/>
+              </a:spcBef>
+              <a:spcAft>
+                <a:spcPct val="0"/>
+              </a:spcAft>
+              <a:buClrTx/>
+              <a:buSzTx/>
+              <a:buFontTx/>
+              <a:buChar char="•"/>
+              <a:tabLst/>
+            </a:pPr>
+            <a:r>
+              <a:rPr kumimoji="0" lang="it-IT" altLang="it-IT" sz="1000" b="0" i="0" u="none" strike="noStrike" cap="none" normalizeH="0" baseline="0" dirty="0" err="1">
+                <a:ln>
+                  <a:noFill/>
+                </a:ln>
+                <a:solidFill>
+                  <a:schemeClr val="tx1"/>
+                </a:solidFill>
+                <a:effectLst/>
+                <a:latin typeface="Arial Unicode MS"/>
+              </a:rPr>
+              <a:t>renderOffertaPage</a:t>
+            </a:r>
+            <a:r>
+              <a:rPr kumimoji="0" lang="it-IT" altLang="it-IT" sz="1000" b="0" i="0" u="none" strike="noStrike" cap="none" normalizeH="0" baseline="0" dirty="0">
+                <a:ln>
+                  <a:noFill/>
+                </a:ln>
+                <a:solidFill>
+                  <a:schemeClr val="tx1"/>
+                </a:solidFill>
+                <a:effectLst/>
+                <a:latin typeface="Arial Unicode MS"/>
+              </a:rPr>
+              <a:t>(</a:t>
+            </a:r>
+            <a:r>
+              <a:rPr kumimoji="0" lang="it-IT" altLang="it-IT" sz="1000" b="0" i="0" u="none" strike="noStrike" cap="none" normalizeH="0" baseline="0" dirty="0" err="1">
+                <a:ln>
+                  <a:noFill/>
+                </a:ln>
+                <a:solidFill>
+                  <a:schemeClr val="tx1"/>
+                </a:solidFill>
+                <a:effectLst/>
+                <a:latin typeface="Arial Unicode MS"/>
+              </a:rPr>
+              <a:t>idAsta</a:t>
+            </a:r>
+            <a:r>
+              <a:rPr kumimoji="0" lang="it-IT" altLang="it-IT" sz="1000" b="0" i="0" u="none" strike="noStrike" cap="none" normalizeH="0" baseline="0" dirty="0">
+                <a:ln>
+                  <a:noFill/>
+                </a:ln>
+                <a:solidFill>
+                  <a:schemeClr val="tx1"/>
+                </a:solidFill>
+                <a:effectLst/>
+                <a:latin typeface="Arial Unicode MS"/>
+              </a:rPr>
+              <a:t>)</a:t>
+            </a:r>
+            <a:r>
+              <a:rPr kumimoji="0" lang="it-IT" altLang="it-IT" sz="800" b="0" i="0" u="none" strike="noStrike" cap="none" normalizeH="0" baseline="0" dirty="0">
+                <a:ln>
+                  <a:noFill/>
+                </a:ln>
+                <a:solidFill>
+                  <a:schemeClr val="tx1"/>
+                </a:solidFill>
+                <a:effectLst/>
+              </a:rPr>
+              <a:t> → mostra pagina offerta per una certa asta</a:t>
+            </a:r>
+            <a:endParaRPr kumimoji="0" lang="it-IT" altLang="it-IT" sz="1800" b="0" i="0" u="none" strike="noStrike" cap="none" normalizeH="0" baseline="0" dirty="0">
+              <a:ln>
+                <a:noFill/>
+              </a:ln>
+              <a:solidFill>
+                <a:schemeClr val="tx1"/>
+              </a:solidFill>
+              <a:effectLst/>
+              <a:latin typeface="Arial" panose="020B0604020202020204" pitchFamily="34" charset="0"/>
+            </a:endParaRPr>
+          </a:p>
+          <a:p>
+            <a:pPr marL="0" marR="0" lvl="0" indent="0" algn="l" defTabSz="914400" rtl="0" eaLnBrk="0" fontAlgn="base" latinLnBrk="0" hangingPunct="0">
+              <a:lnSpc>
+                <a:spcPct val="100000"/>
+              </a:lnSpc>
+              <a:spcBef>
+                <a:spcPct val="0"/>
+              </a:spcBef>
+              <a:spcAft>
+                <a:spcPct val="0"/>
+              </a:spcAft>
+              <a:buClrTx/>
+              <a:buSzTx/>
+              <a:buFontTx/>
+              <a:buChar char="•"/>
+              <a:tabLst/>
+            </a:pPr>
+            <a:r>
+              <a:rPr kumimoji="0" lang="it-IT" altLang="it-IT" sz="1000" b="0" i="0" u="none" strike="noStrike" cap="none" normalizeH="0" baseline="0" dirty="0" err="1">
+                <a:ln>
+                  <a:noFill/>
+                </a:ln>
+                <a:solidFill>
+                  <a:schemeClr val="tx1"/>
+                </a:solidFill>
+                <a:effectLst/>
+                <a:latin typeface="Arial Unicode MS"/>
+              </a:rPr>
+              <a:t>addArticoloInTable</a:t>
+            </a:r>
+            <a:r>
+              <a:rPr kumimoji="0" lang="it-IT" altLang="it-IT" sz="1000" b="0" i="0" u="none" strike="noStrike" cap="none" normalizeH="0" baseline="0" dirty="0">
+                <a:ln>
+                  <a:noFill/>
+                </a:ln>
+                <a:solidFill>
+                  <a:schemeClr val="tx1"/>
+                </a:solidFill>
+                <a:effectLst/>
+                <a:latin typeface="Arial Unicode MS"/>
+              </a:rPr>
+              <a:t>(articolo)</a:t>
+            </a:r>
+            <a:r>
+              <a:rPr kumimoji="0" lang="it-IT" altLang="it-IT" sz="800" b="0" i="0" u="none" strike="noStrike" cap="none" normalizeH="0" baseline="0" dirty="0">
+                <a:ln>
+                  <a:noFill/>
+                </a:ln>
+                <a:solidFill>
+                  <a:schemeClr val="tx1"/>
+                </a:solidFill>
+                <a:effectLst/>
+              </a:rPr>
+              <a:t> → aggiunge un articolo alla tabella articoli asta</a:t>
+            </a:r>
+            <a:endParaRPr kumimoji="0" lang="it-IT" altLang="it-IT" sz="1800" b="0" i="0" u="none" strike="noStrike" cap="none" normalizeH="0" baseline="0" dirty="0">
+              <a:ln>
+                <a:noFill/>
+              </a:ln>
+              <a:solidFill>
+                <a:schemeClr val="tx1"/>
+              </a:solidFill>
+              <a:effectLst/>
+              <a:latin typeface="Arial" panose="020B0604020202020204" pitchFamily="34" charset="0"/>
+            </a:endParaRPr>
+          </a:p>
+          <a:p>
+            <a:pPr marL="0" marR="0" lvl="0" indent="0" algn="l" defTabSz="914400" rtl="0" eaLnBrk="0" fontAlgn="base" latinLnBrk="0" hangingPunct="0">
+              <a:lnSpc>
+                <a:spcPct val="100000"/>
+              </a:lnSpc>
+              <a:spcBef>
+                <a:spcPct val="0"/>
+              </a:spcBef>
+              <a:spcAft>
+                <a:spcPct val="0"/>
+              </a:spcAft>
+              <a:buClrTx/>
+              <a:buSzTx/>
+              <a:buFontTx/>
+              <a:buChar char="•"/>
+              <a:tabLst/>
+            </a:pPr>
+            <a:r>
+              <a:rPr kumimoji="0" lang="it-IT" altLang="it-IT" sz="1000" b="0" i="0" u="none" strike="noStrike" cap="none" normalizeH="0" baseline="0" dirty="0" err="1">
+                <a:ln>
+                  <a:noFill/>
+                </a:ln>
+                <a:solidFill>
+                  <a:schemeClr val="tx1"/>
+                </a:solidFill>
+                <a:effectLst/>
+                <a:latin typeface="Arial Unicode MS"/>
+              </a:rPr>
+              <a:t>addOffertaInTable</a:t>
+            </a:r>
+            <a:r>
+              <a:rPr kumimoji="0" lang="it-IT" altLang="it-IT" sz="1000" b="0" i="0" u="none" strike="noStrike" cap="none" normalizeH="0" baseline="0" dirty="0">
+                <a:ln>
+                  <a:noFill/>
+                </a:ln>
+                <a:solidFill>
+                  <a:schemeClr val="tx1"/>
+                </a:solidFill>
+                <a:effectLst/>
+                <a:latin typeface="Arial Unicode MS"/>
+              </a:rPr>
+              <a:t>(offerta, nuova)</a:t>
+            </a:r>
+            <a:r>
+              <a:rPr kumimoji="0" lang="it-IT" altLang="it-IT" sz="800" b="0" i="0" u="none" strike="noStrike" cap="none" normalizeH="0" baseline="0" dirty="0">
+                <a:ln>
+                  <a:noFill/>
+                </a:ln>
+                <a:solidFill>
+                  <a:schemeClr val="tx1"/>
+                </a:solidFill>
+                <a:effectLst/>
+              </a:rPr>
+              <a:t> → aggiunge un’offerta alla tabella offerte</a:t>
+            </a:r>
+            <a:endParaRPr kumimoji="0" lang="it-IT" altLang="it-IT" sz="1800" b="0" i="0" u="none" strike="noStrike" cap="none" normalizeH="0" baseline="0" dirty="0">
+              <a:ln>
+                <a:noFill/>
+              </a:ln>
+              <a:solidFill>
+                <a:schemeClr val="tx1"/>
+              </a:solidFill>
+              <a:effectLst/>
+              <a:latin typeface="Arial" panose="020B0604020202020204" pitchFamily="34" charset="0"/>
+            </a:endParaRPr>
+          </a:p>
+          <a:p>
+            <a:pPr marL="0" marR="0" lvl="0" indent="0" algn="l" defTabSz="914400" rtl="0" eaLnBrk="0" fontAlgn="base" latinLnBrk="0" hangingPunct="0">
+              <a:lnSpc>
+                <a:spcPct val="100000"/>
+              </a:lnSpc>
+              <a:spcBef>
+                <a:spcPct val="0"/>
+              </a:spcBef>
+              <a:spcAft>
+                <a:spcPct val="0"/>
+              </a:spcAft>
+              <a:buClrTx/>
+              <a:buSzTx/>
+              <a:buFontTx/>
+              <a:buChar char="•"/>
+              <a:tabLst/>
+            </a:pPr>
+            <a:r>
+              <a:rPr kumimoji="0" lang="it-IT" altLang="it-IT" sz="1000" b="0" i="0" u="none" strike="noStrike" cap="none" normalizeH="0" baseline="0" dirty="0" err="1">
+                <a:ln>
+                  <a:noFill/>
+                </a:ln>
+                <a:solidFill>
+                  <a:schemeClr val="tx1"/>
+                </a:solidFill>
+                <a:effectLst/>
+                <a:latin typeface="Arial Unicode MS"/>
+              </a:rPr>
+              <a:t>faiOfferta</a:t>
+            </a:r>
+            <a:r>
+              <a:rPr kumimoji="0" lang="it-IT" altLang="it-IT" sz="1000" b="0" i="0" u="none" strike="noStrike" cap="none" normalizeH="0" baseline="0" dirty="0">
+                <a:ln>
+                  <a:noFill/>
+                </a:ln>
+                <a:solidFill>
+                  <a:schemeClr val="tx1"/>
+                </a:solidFill>
+                <a:effectLst/>
+                <a:latin typeface="Arial Unicode MS"/>
+              </a:rPr>
+              <a:t>(</a:t>
+            </a:r>
+            <a:r>
+              <a:rPr kumimoji="0" lang="it-IT" altLang="it-IT" sz="1000" b="0" i="0" u="none" strike="noStrike" cap="none" normalizeH="0" baseline="0" dirty="0" err="1">
+                <a:ln>
+                  <a:noFill/>
+                </a:ln>
+                <a:solidFill>
+                  <a:schemeClr val="tx1"/>
+                </a:solidFill>
+                <a:effectLst/>
+                <a:latin typeface="Arial Unicode MS"/>
+              </a:rPr>
+              <a:t>prezzoIniziale</a:t>
+            </a:r>
+            <a:r>
+              <a:rPr kumimoji="0" lang="it-IT" altLang="it-IT" sz="1000" b="0" i="0" u="none" strike="noStrike" cap="none" normalizeH="0" baseline="0" dirty="0">
+                <a:ln>
+                  <a:noFill/>
+                </a:ln>
+                <a:solidFill>
+                  <a:schemeClr val="tx1"/>
+                </a:solidFill>
+                <a:effectLst/>
+                <a:latin typeface="Arial Unicode MS"/>
+              </a:rPr>
+              <a:t>, </a:t>
+            </a:r>
+            <a:r>
+              <a:rPr kumimoji="0" lang="it-IT" altLang="it-IT" sz="1000" b="0" i="0" u="none" strike="noStrike" cap="none" normalizeH="0" baseline="0" dirty="0" err="1">
+                <a:ln>
+                  <a:noFill/>
+                </a:ln>
+                <a:solidFill>
+                  <a:schemeClr val="tx1"/>
+                </a:solidFill>
+                <a:effectLst/>
+                <a:latin typeface="Arial Unicode MS"/>
+              </a:rPr>
+              <a:t>prezzoOffertaMassima</a:t>
+            </a:r>
+            <a:r>
+              <a:rPr kumimoji="0" lang="it-IT" altLang="it-IT" sz="1000" b="0" i="0" u="none" strike="noStrike" cap="none" normalizeH="0" baseline="0" dirty="0">
+                <a:ln>
+                  <a:noFill/>
+                </a:ln>
+                <a:solidFill>
+                  <a:schemeClr val="tx1"/>
+                </a:solidFill>
+                <a:effectLst/>
+                <a:latin typeface="Arial Unicode MS"/>
+              </a:rPr>
+              <a:t>, </a:t>
+            </a:r>
+            <a:r>
+              <a:rPr kumimoji="0" lang="it-IT" altLang="it-IT" sz="1000" b="0" i="0" u="none" strike="noStrike" cap="none" normalizeH="0" baseline="0" dirty="0" err="1">
+                <a:ln>
+                  <a:noFill/>
+                </a:ln>
+                <a:solidFill>
+                  <a:schemeClr val="tx1"/>
+                </a:solidFill>
+                <a:effectLst/>
+                <a:latin typeface="Arial Unicode MS"/>
+              </a:rPr>
+              <a:t>rialzoMinimo</a:t>
+            </a:r>
+            <a:r>
+              <a:rPr kumimoji="0" lang="it-IT" altLang="it-IT" sz="1000" b="0" i="0" u="none" strike="noStrike" cap="none" normalizeH="0" baseline="0" dirty="0">
+                <a:ln>
+                  <a:noFill/>
+                </a:ln>
+                <a:solidFill>
+                  <a:schemeClr val="tx1"/>
+                </a:solidFill>
+                <a:effectLst/>
+                <a:latin typeface="Arial Unicode MS"/>
+              </a:rPr>
+              <a:t>)</a:t>
+            </a:r>
+            <a:r>
+              <a:rPr kumimoji="0" lang="it-IT" altLang="it-IT" sz="800" b="0" i="0" u="none" strike="noStrike" cap="none" normalizeH="0" baseline="0" dirty="0">
+                <a:ln>
+                  <a:noFill/>
+                </a:ln>
+                <a:solidFill>
+                  <a:schemeClr val="tx1"/>
+                </a:solidFill>
+                <a:effectLst/>
+              </a:rPr>
+              <a:t> → invia una nuova offerta al server</a:t>
+            </a:r>
+            <a:endParaRPr kumimoji="0" lang="it-IT" altLang="it-IT" sz="1800" b="0" i="0" u="none" strike="noStrike" cap="none" normalizeH="0" baseline="0" dirty="0">
+              <a:ln>
+                <a:noFill/>
+              </a:ln>
+              <a:solidFill>
+                <a:schemeClr val="tx1"/>
+              </a:solidFill>
+              <a:effectLst/>
+              <a:latin typeface="Arial" panose="020B0604020202020204" pitchFamily="34" charset="0"/>
+            </a:endParaRPr>
+          </a:p>
+        </p:txBody>
+      </p:sp>
+    </p:spTree>
+    <p:extLst>
+      <p:ext uri="{BB962C8B-B14F-4D97-AF65-F5344CB8AC3E}">
+        <p14:creationId xmlns:p14="http://schemas.microsoft.com/office/powerpoint/2010/main" val="3165191962"/>
+      </p:ext>
+    </p:extLst>
+  </p:cSld>
+  <p:clrMapOvr>
+    <a:masterClrMapping/>
+  </p:clrMapOvr>
+</p:sld>
+</file>
+
+<file path=ppt/slides/slide22.xml><?xml version="1.0" encoding="utf-8"?>
+<p:sld xmlns:a="http://schemas.openxmlformats.org/drawingml/2006/main" xmlns:r="http://schemas.openxmlformats.org/officeDocument/2006/relationships" xmlns:p="http://schemas.openxmlformats.org/presentationml/2006/main">
+  <p:cSld>
+    <p:spTree>
+      <p:nvGrpSpPr>
+        <p:cNvPr id="1" name=""/>
+        <p:cNvGrpSpPr/>
+        <p:nvPr/>
+      </p:nvGrpSpPr>
+      <p:grpSpPr>
+        <a:xfrm>
+          <a:off x="0" y="0"/>
+          <a:ext cx="0" cy="0"/>
+          <a:chOff x="0" y="0"/>
+          <a:chExt cx="0" cy="0"/>
+        </a:xfrm>
+      </p:grpSpPr>
+      <p:sp>
+        <p:nvSpPr>
+          <p:cNvPr id="2" name="Titolo 1">
+            <a:extLst>
+              <a:ext uri="{FF2B5EF4-FFF2-40B4-BE49-F238E27FC236}">
+                <a16:creationId xmlns:a16="http://schemas.microsoft.com/office/drawing/2014/main" id="{E9B626C4-C1A0-5F50-9B84-7CB56748E319}"/>
+              </a:ext>
+            </a:extLst>
+          </p:cNvPr>
+          <p:cNvSpPr>
+            <a:spLocks noGrp="1"/>
+          </p:cNvSpPr>
+          <p:nvPr>
+            <p:ph type="title"/>
+          </p:nvPr>
+        </p:nvSpPr>
+        <p:spPr/>
+        <p:txBody>
+          <a:bodyPr/>
+          <a:lstStyle/>
+          <a:p>
+            <a:pPr algn="ctr"/>
+            <a:r>
+              <a:rPr lang="it-IT" dirty="0"/>
+              <a:t>SEQUENCE DIAGRAM – HTML - SIGNUP</a:t>
+            </a:r>
+          </a:p>
+        </p:txBody>
+      </p:sp>
+      <p:pic>
+        <p:nvPicPr>
+          <p:cNvPr id="5" name="Segnaposto contenuto 4" descr="Immagine che contiene testo, schermata, linea, diagramma&#10;&#10;Il contenuto generato dall'IA potrebbe non essere corretto.">
+            <a:extLst>
+              <a:ext uri="{FF2B5EF4-FFF2-40B4-BE49-F238E27FC236}">
+                <a16:creationId xmlns:a16="http://schemas.microsoft.com/office/drawing/2014/main" id="{443E0549-4721-3783-1E48-8E40E3D800F0}"/>
+              </a:ext>
+            </a:extLst>
+          </p:cNvPr>
+          <p:cNvPicPr>
+            <a:picLocks noGrp="1" noChangeAspect="1"/>
+          </p:cNvPicPr>
+          <p:nvPr>
+            <p:ph idx="1"/>
+          </p:nvPr>
+        </p:nvPicPr>
+        <p:blipFill>
+          <a:blip r:embed="rId2"/>
+          <a:stretch>
+            <a:fillRect/>
+          </a:stretch>
+        </p:blipFill>
+        <p:spPr>
+          <a:xfrm>
+            <a:off x="700635" y="1679281"/>
+            <a:ext cx="10790729" cy="4900465"/>
+          </a:xfrm>
+        </p:spPr>
+      </p:pic>
+    </p:spTree>
+    <p:extLst>
+      <p:ext uri="{BB962C8B-B14F-4D97-AF65-F5344CB8AC3E}">
+        <p14:creationId xmlns:p14="http://schemas.microsoft.com/office/powerpoint/2010/main" val="1019899170"/>
+      </p:ext>
+    </p:extLst>
+  </p:cSld>
+  <p:clrMapOvr>
+    <a:masterClrMapping/>
+  </p:clrMapOvr>
+</p:sld>
+</file>
+
+<file path=ppt/slides/slide23.xml><?xml version="1.0" encoding="utf-8"?>
+<p:sld xmlns:a="http://schemas.openxmlformats.org/drawingml/2006/main" xmlns:r="http://schemas.openxmlformats.org/officeDocument/2006/relationships" xmlns:p="http://schemas.openxmlformats.org/presentationml/2006/main">
+  <p:cSld>
+    <p:spTree>
+      <p:nvGrpSpPr>
+        <p:cNvPr id="1" name=""/>
+        <p:cNvGrpSpPr/>
+        <p:nvPr/>
+      </p:nvGrpSpPr>
+      <p:grpSpPr>
+        <a:xfrm>
+          <a:off x="0" y="0"/>
+          <a:ext cx="0" cy="0"/>
+          <a:chOff x="0" y="0"/>
+          <a:chExt cx="0" cy="0"/>
+        </a:xfrm>
+      </p:grpSpPr>
+      <p:sp>
+        <p:nvSpPr>
+          <p:cNvPr id="2" name="Titolo 1">
+            <a:extLst>
+              <a:ext uri="{FF2B5EF4-FFF2-40B4-BE49-F238E27FC236}">
+                <a16:creationId xmlns:a16="http://schemas.microsoft.com/office/drawing/2014/main" id="{99B4FD73-7AFE-A7DA-F9FE-65BEB12EBA73}"/>
+              </a:ext>
+            </a:extLst>
+          </p:cNvPr>
+          <p:cNvSpPr>
+            <a:spLocks noGrp="1"/>
+          </p:cNvSpPr>
+          <p:nvPr>
+            <p:ph type="title"/>
+          </p:nvPr>
+        </p:nvSpPr>
+        <p:spPr/>
+        <p:txBody>
+          <a:bodyPr/>
+          <a:lstStyle/>
+          <a:p>
+            <a:pPr algn="ctr"/>
+            <a:r>
+              <a:rPr lang="it-IT" dirty="0"/>
+              <a:t>SEQUENCE DIAGRAM - LOGIN</a:t>
+            </a:r>
+          </a:p>
+        </p:txBody>
+      </p:sp>
+      <p:pic>
+        <p:nvPicPr>
+          <p:cNvPr id="5" name="Segnaposto contenuto 4" descr="Immagine che contiene testo, schermata, diagramma, linea&#10;&#10;Il contenuto generato dall'IA potrebbe non essere corretto.">
+            <a:extLst>
+              <a:ext uri="{FF2B5EF4-FFF2-40B4-BE49-F238E27FC236}">
+                <a16:creationId xmlns:a16="http://schemas.microsoft.com/office/drawing/2014/main" id="{D343FD7A-BB61-8D5D-44E4-DB07223DF3EF}"/>
+              </a:ext>
+            </a:extLst>
+          </p:cNvPr>
+          <p:cNvPicPr>
+            <a:picLocks noGrp="1" noChangeAspect="1"/>
+          </p:cNvPicPr>
+          <p:nvPr>
+            <p:ph idx="1"/>
+          </p:nvPr>
+        </p:nvPicPr>
+        <p:blipFill>
+          <a:blip r:embed="rId2"/>
+          <a:stretch>
+            <a:fillRect/>
+          </a:stretch>
+        </p:blipFill>
+        <p:spPr>
+          <a:xfrm>
+            <a:off x="700635" y="1594168"/>
+            <a:ext cx="10691265" cy="4996558"/>
+          </a:xfrm>
+        </p:spPr>
+      </p:pic>
+    </p:spTree>
+    <p:extLst>
+      <p:ext uri="{BB962C8B-B14F-4D97-AF65-F5344CB8AC3E}">
+        <p14:creationId xmlns:p14="http://schemas.microsoft.com/office/powerpoint/2010/main" val="2099754950"/>
+      </p:ext>
+    </p:extLst>
+  </p:cSld>
+  <p:clrMapOvr>
+    <a:masterClrMapping/>
+  </p:clrMapOvr>
+</p:sld>
+</file>
+
+<file path=ppt/slides/slide24.xml><?xml version="1.0" encoding="utf-8"?>
+<p:sld xmlns:a="http://schemas.openxmlformats.org/drawingml/2006/main" xmlns:r="http://schemas.openxmlformats.org/officeDocument/2006/relationships" xmlns:p="http://schemas.openxmlformats.org/presentationml/2006/main">
+  <p:cSld>
+    <p:spTree>
+      <p:nvGrpSpPr>
+        <p:cNvPr id="1" name="">
+          <a:extLst>
+            <a:ext uri="{FF2B5EF4-FFF2-40B4-BE49-F238E27FC236}">
+              <a16:creationId xmlns:a16="http://schemas.microsoft.com/office/drawing/2014/main" id="{F0342C25-8C7D-79B4-CBE7-1489A3B65BFF}"/>
+            </a:ext>
+          </a:extLst>
+        </p:cNvPr>
+        <p:cNvGrpSpPr/>
+        <p:nvPr/>
+      </p:nvGrpSpPr>
+      <p:grpSpPr>
+        <a:xfrm>
+          <a:off x="0" y="0"/>
+          <a:ext cx="0" cy="0"/>
+          <a:chOff x="0" y="0"/>
+          <a:chExt cx="0" cy="0"/>
+        </a:xfrm>
+      </p:grpSpPr>
+      <p:sp>
+        <p:nvSpPr>
+          <p:cNvPr id="2" name="Titolo 1">
+            <a:extLst>
+              <a:ext uri="{FF2B5EF4-FFF2-40B4-BE49-F238E27FC236}">
+                <a16:creationId xmlns:a16="http://schemas.microsoft.com/office/drawing/2014/main" id="{F321C98D-26AF-B111-E668-EA470A72AC88}"/>
+              </a:ext>
+            </a:extLst>
+          </p:cNvPr>
+          <p:cNvSpPr>
+            <a:spLocks noGrp="1"/>
+          </p:cNvSpPr>
+          <p:nvPr>
+            <p:ph type="title"/>
+          </p:nvPr>
+        </p:nvSpPr>
+        <p:spPr/>
+        <p:txBody>
+          <a:bodyPr/>
+          <a:lstStyle/>
+          <a:p>
+            <a:pPr algn="ctr"/>
+            <a:r>
+              <a:rPr lang="it-IT" dirty="0"/>
+              <a:t>SEQUENCE DIAGRAM - LOGOUT</a:t>
+            </a:r>
+          </a:p>
+        </p:txBody>
+      </p:sp>
+      <p:pic>
+        <p:nvPicPr>
+          <p:cNvPr id="5" name="Segnaposto contenuto 4" descr="Immagine che contiene testo, schermata, Carattere, linea&#10;&#10;Il contenuto generato dall'IA potrebbe non essere corretto.">
+            <a:extLst>
+              <a:ext uri="{FF2B5EF4-FFF2-40B4-BE49-F238E27FC236}">
+                <a16:creationId xmlns:a16="http://schemas.microsoft.com/office/drawing/2014/main" id="{BE47FCCD-D551-D8A4-7592-3F872B663D16}"/>
+              </a:ext>
+            </a:extLst>
+          </p:cNvPr>
+          <p:cNvPicPr>
+            <a:picLocks noGrp="1" noChangeAspect="1"/>
+          </p:cNvPicPr>
+          <p:nvPr>
+            <p:ph idx="1"/>
+          </p:nvPr>
+        </p:nvPicPr>
+        <p:blipFill>
+          <a:blip r:embed="rId2"/>
+          <a:stretch>
+            <a:fillRect/>
+          </a:stretch>
+        </p:blipFill>
+        <p:spPr>
+          <a:xfrm>
+            <a:off x="2930236" y="2146562"/>
+            <a:ext cx="6681355" cy="3646514"/>
+          </a:xfrm>
+        </p:spPr>
+      </p:pic>
+    </p:spTree>
+    <p:extLst>
+      <p:ext uri="{BB962C8B-B14F-4D97-AF65-F5344CB8AC3E}">
+        <p14:creationId xmlns:p14="http://schemas.microsoft.com/office/powerpoint/2010/main" val="1617431380"/>
+      </p:ext>
+    </p:extLst>
+  </p:cSld>
+  <p:clrMapOvr>
+    <a:masterClrMapping/>
+  </p:clrMapOvr>
+</p:sld>
+</file>
+
+<file path=ppt/slides/slide25.xml><?xml version="1.0" encoding="utf-8"?>
+<p:sld xmlns:a="http://schemas.openxmlformats.org/drawingml/2006/main" xmlns:r="http://schemas.openxmlformats.org/officeDocument/2006/relationships" xmlns:p="http://schemas.openxmlformats.org/presentationml/2006/main">
+  <p:cSld>
+    <p:spTree>
+      <p:nvGrpSpPr>
+        <p:cNvPr id="1" name="">
+          <a:extLst>
+            <a:ext uri="{FF2B5EF4-FFF2-40B4-BE49-F238E27FC236}">
+              <a16:creationId xmlns:a16="http://schemas.microsoft.com/office/drawing/2014/main" id="{DD61F793-A5E2-70FC-B045-C7A049EBBF90}"/>
+            </a:ext>
+          </a:extLst>
+        </p:cNvPr>
+        <p:cNvGrpSpPr/>
+        <p:nvPr/>
+      </p:nvGrpSpPr>
+      <p:grpSpPr>
+        <a:xfrm>
+          <a:off x="0" y="0"/>
+          <a:ext cx="0" cy="0"/>
+          <a:chOff x="0" y="0"/>
+          <a:chExt cx="0" cy="0"/>
+        </a:xfrm>
+      </p:grpSpPr>
+      <p:sp>
+        <p:nvSpPr>
+          <p:cNvPr id="2" name="Titolo 1">
+            <a:extLst>
+              <a:ext uri="{FF2B5EF4-FFF2-40B4-BE49-F238E27FC236}">
+                <a16:creationId xmlns:a16="http://schemas.microsoft.com/office/drawing/2014/main" id="{874A99D3-AFFE-EE00-5AB6-1473583865A4}"/>
+              </a:ext>
+            </a:extLst>
+          </p:cNvPr>
+          <p:cNvSpPr>
+            <a:spLocks noGrp="1"/>
+          </p:cNvSpPr>
+          <p:nvPr>
+            <p:ph type="title"/>
+          </p:nvPr>
+        </p:nvSpPr>
+        <p:spPr/>
+        <p:txBody>
+          <a:bodyPr/>
+          <a:lstStyle/>
+          <a:p>
+            <a:pPr algn="ctr"/>
+            <a:r>
+              <a:rPr lang="it-IT" dirty="0"/>
+              <a:t>SEQUENCE DIAGRAM – GO TO HOME</a:t>
+            </a:r>
+          </a:p>
+        </p:txBody>
+      </p:sp>
+      <p:pic>
+        <p:nvPicPr>
+          <p:cNvPr id="5" name="Segnaposto contenuto 4" descr="Immagine che contiene testo, schermata, Carattere, linea&#10;&#10;Il contenuto generato dall'IA potrebbe non essere corretto.">
+            <a:extLst>
+              <a:ext uri="{FF2B5EF4-FFF2-40B4-BE49-F238E27FC236}">
+                <a16:creationId xmlns:a16="http://schemas.microsoft.com/office/drawing/2014/main" id="{351336D4-80FD-BC4F-B0E3-4BDA202B7F5B}"/>
+              </a:ext>
+            </a:extLst>
+          </p:cNvPr>
+          <p:cNvPicPr>
+            <a:picLocks noGrp="1" noChangeAspect="1"/>
+          </p:cNvPicPr>
+          <p:nvPr>
+            <p:ph idx="1"/>
+          </p:nvPr>
+        </p:nvPicPr>
+        <p:blipFill>
+          <a:blip r:embed="rId2"/>
+          <a:stretch>
+            <a:fillRect/>
+          </a:stretch>
+        </p:blipFill>
+        <p:spPr>
+          <a:xfrm>
+            <a:off x="668939" y="1901536"/>
+            <a:ext cx="10721724" cy="4395355"/>
+          </a:xfrm>
+        </p:spPr>
+      </p:pic>
+    </p:spTree>
+    <p:extLst>
+      <p:ext uri="{BB962C8B-B14F-4D97-AF65-F5344CB8AC3E}">
+        <p14:creationId xmlns:p14="http://schemas.microsoft.com/office/powerpoint/2010/main" val="3283723489"/>
+      </p:ext>
+    </p:extLst>
+  </p:cSld>
+  <p:clrMapOvr>
+    <a:masterClrMapping/>
+  </p:clrMapOvr>
+</p:sld>
+</file>
+
+<file path=ppt/slides/slide26.xml><?xml version="1.0" encoding="utf-8"?>
+<p:sld xmlns:a="http://schemas.openxmlformats.org/drawingml/2006/main" xmlns:r="http://schemas.openxmlformats.org/officeDocument/2006/relationships" xmlns:p="http://schemas.openxmlformats.org/presentationml/2006/main">
+  <p:cSld>
+    <p:spTree>
+      <p:nvGrpSpPr>
+        <p:cNvPr id="1" name="">
+          <a:extLst>
+            <a:ext uri="{FF2B5EF4-FFF2-40B4-BE49-F238E27FC236}">
+              <a16:creationId xmlns:a16="http://schemas.microsoft.com/office/drawing/2014/main" id="{03B90982-14E0-7EDC-E3B0-E59F1B38782E}"/>
+            </a:ext>
+          </a:extLst>
+        </p:cNvPr>
+        <p:cNvGrpSpPr/>
+        <p:nvPr/>
+      </p:nvGrpSpPr>
+      <p:grpSpPr>
+        <a:xfrm>
+          <a:off x="0" y="0"/>
+          <a:ext cx="0" cy="0"/>
+          <a:chOff x="0" y="0"/>
+          <a:chExt cx="0" cy="0"/>
+        </a:xfrm>
+      </p:grpSpPr>
+      <p:sp>
+        <p:nvSpPr>
+          <p:cNvPr id="2" name="Titolo 1">
+            <a:extLst>
+              <a:ext uri="{FF2B5EF4-FFF2-40B4-BE49-F238E27FC236}">
+                <a16:creationId xmlns:a16="http://schemas.microsoft.com/office/drawing/2014/main" id="{3161FF21-4F98-4B66-D43F-39315B5F717B}"/>
+              </a:ext>
+            </a:extLst>
+          </p:cNvPr>
+          <p:cNvSpPr>
+            <a:spLocks noGrp="1"/>
+          </p:cNvSpPr>
+          <p:nvPr>
+            <p:ph type="title"/>
+          </p:nvPr>
+        </p:nvSpPr>
+        <p:spPr/>
+        <p:txBody>
+          <a:bodyPr/>
+          <a:lstStyle/>
+          <a:p>
+            <a:pPr algn="ctr"/>
+            <a:r>
+              <a:rPr lang="it-IT" dirty="0"/>
+              <a:t>SEQUENCE DIAGRAM – GO TO OFFERTA</a:t>
+            </a:r>
+          </a:p>
+        </p:txBody>
+      </p:sp>
+      <p:pic>
+        <p:nvPicPr>
+          <p:cNvPr id="5" name="Segnaposto contenuto 4" descr="Immagine che contiene testo, schermata, Carattere, ricevuta&#10;&#10;Il contenuto generato dall'IA potrebbe non essere corretto.">
+            <a:extLst>
+              <a:ext uri="{FF2B5EF4-FFF2-40B4-BE49-F238E27FC236}">
+                <a16:creationId xmlns:a16="http://schemas.microsoft.com/office/drawing/2014/main" id="{52E16ADF-A56C-0214-C8C6-C5B0400AC617}"/>
+              </a:ext>
+            </a:extLst>
+          </p:cNvPr>
+          <p:cNvPicPr>
+            <a:picLocks noGrp="1" noChangeAspect="1"/>
+          </p:cNvPicPr>
+          <p:nvPr>
+            <p:ph idx="1"/>
+          </p:nvPr>
+        </p:nvPicPr>
+        <p:blipFill>
+          <a:blip r:embed="rId2"/>
+          <a:stretch>
+            <a:fillRect/>
+          </a:stretch>
+        </p:blipFill>
+        <p:spPr>
+          <a:xfrm>
+            <a:off x="1870364" y="1527409"/>
+            <a:ext cx="8333509" cy="5141281"/>
+          </a:xfrm>
+        </p:spPr>
+      </p:pic>
+    </p:spTree>
+    <p:extLst>
+      <p:ext uri="{BB962C8B-B14F-4D97-AF65-F5344CB8AC3E}">
+        <p14:creationId xmlns:p14="http://schemas.microsoft.com/office/powerpoint/2010/main" val="2000968186"/>
+      </p:ext>
+    </p:extLst>
+  </p:cSld>
+  <p:clrMapOvr>
+    <a:masterClrMapping/>
+  </p:clrMapOvr>
+</p:sld>
+</file>
+
+<file path=ppt/slides/slide27.xml><?xml version="1.0" encoding="utf-8"?>
+<p:sld xmlns:a="http://schemas.openxmlformats.org/drawingml/2006/main" xmlns:r="http://schemas.openxmlformats.org/officeDocument/2006/relationships" xmlns:p="http://schemas.openxmlformats.org/presentationml/2006/main">
+  <p:cSld>
+    <p:spTree>
+      <p:nvGrpSpPr>
+        <p:cNvPr id="1" name="">
+          <a:extLst>
+            <a:ext uri="{FF2B5EF4-FFF2-40B4-BE49-F238E27FC236}">
+              <a16:creationId xmlns:a16="http://schemas.microsoft.com/office/drawing/2014/main" id="{62772210-C84F-FCB0-B265-D12893B7B0D3}"/>
+            </a:ext>
+          </a:extLst>
+        </p:cNvPr>
+        <p:cNvGrpSpPr/>
+        <p:nvPr/>
+      </p:nvGrpSpPr>
+      <p:grpSpPr>
+        <a:xfrm>
+          <a:off x="0" y="0"/>
+          <a:ext cx="0" cy="0"/>
+          <a:chOff x="0" y="0"/>
+          <a:chExt cx="0" cy="0"/>
+        </a:xfrm>
+      </p:grpSpPr>
+      <p:sp>
+        <p:nvSpPr>
+          <p:cNvPr id="2" name="Titolo 1">
+            <a:extLst>
+              <a:ext uri="{FF2B5EF4-FFF2-40B4-BE49-F238E27FC236}">
+                <a16:creationId xmlns:a16="http://schemas.microsoft.com/office/drawing/2014/main" id="{E3A8F0E9-385C-1C5E-B0DB-5C7F03FB1219}"/>
+              </a:ext>
+            </a:extLst>
+          </p:cNvPr>
+          <p:cNvSpPr>
+            <a:spLocks noGrp="1"/>
+          </p:cNvSpPr>
+          <p:nvPr>
+            <p:ph type="title"/>
+          </p:nvPr>
+        </p:nvSpPr>
+        <p:spPr/>
+        <p:txBody>
+          <a:bodyPr/>
+          <a:lstStyle/>
+          <a:p>
+            <a:pPr algn="ctr"/>
+            <a:r>
+              <a:rPr lang="it-IT" dirty="0"/>
+              <a:t>SEQUENCE DIAGRAM – GO TO VENDO</a:t>
+            </a:r>
+          </a:p>
+        </p:txBody>
+      </p:sp>
+      <p:pic>
+        <p:nvPicPr>
+          <p:cNvPr id="5" name="Segnaposto contenuto 4" descr="Immagine che contiene testo, ricevuta, schermata, numero&#10;&#10;Il contenuto generato dall'IA potrebbe non essere corretto.">
+            <a:extLst>
+              <a:ext uri="{FF2B5EF4-FFF2-40B4-BE49-F238E27FC236}">
+                <a16:creationId xmlns:a16="http://schemas.microsoft.com/office/drawing/2014/main" id="{915CC658-91A3-37D2-9296-AA23773D767E}"/>
+              </a:ext>
+            </a:extLst>
+          </p:cNvPr>
+          <p:cNvPicPr>
+            <a:picLocks noGrp="1" noChangeAspect="1"/>
+          </p:cNvPicPr>
+          <p:nvPr>
+            <p:ph idx="1"/>
+          </p:nvPr>
+        </p:nvPicPr>
+        <p:blipFill>
+          <a:blip r:embed="rId2"/>
+          <a:stretch>
+            <a:fillRect/>
+          </a:stretch>
+        </p:blipFill>
+        <p:spPr>
+          <a:xfrm>
+            <a:off x="2369126" y="1563690"/>
+            <a:ext cx="7533409" cy="5084614"/>
+          </a:xfrm>
+        </p:spPr>
+      </p:pic>
+    </p:spTree>
+    <p:extLst>
+      <p:ext uri="{BB962C8B-B14F-4D97-AF65-F5344CB8AC3E}">
+        <p14:creationId xmlns:p14="http://schemas.microsoft.com/office/powerpoint/2010/main" val="2796739571"/>
+      </p:ext>
+    </p:extLst>
+  </p:cSld>
+  <p:clrMapOvr>
+    <a:masterClrMapping/>
+  </p:clrMapOvr>
+</p:sld>
+</file>
+
+<file path=ppt/slides/slide28.xml><?xml version="1.0" encoding="utf-8"?>
+<p:sld xmlns:a="http://schemas.openxmlformats.org/drawingml/2006/main" xmlns:r="http://schemas.openxmlformats.org/officeDocument/2006/relationships" xmlns:p="http://schemas.openxmlformats.org/presentationml/2006/main">
+  <p:cSld>
+    <p:spTree>
+      <p:nvGrpSpPr>
+        <p:cNvPr id="1" name="">
+          <a:extLst>
+            <a:ext uri="{FF2B5EF4-FFF2-40B4-BE49-F238E27FC236}">
+              <a16:creationId xmlns:a16="http://schemas.microsoft.com/office/drawing/2014/main" id="{7D4AA0AA-E97E-39A8-8EC5-0BF71DC2DFC6}"/>
+            </a:ext>
+          </a:extLst>
+        </p:cNvPr>
+        <p:cNvGrpSpPr/>
+        <p:nvPr/>
+      </p:nvGrpSpPr>
+      <p:grpSpPr>
+        <a:xfrm>
+          <a:off x="0" y="0"/>
+          <a:ext cx="0" cy="0"/>
+          <a:chOff x="0" y="0"/>
+          <a:chExt cx="0" cy="0"/>
+        </a:xfrm>
+      </p:grpSpPr>
+      <p:sp>
+        <p:nvSpPr>
+          <p:cNvPr id="2" name="Titolo 1">
+            <a:extLst>
+              <a:ext uri="{FF2B5EF4-FFF2-40B4-BE49-F238E27FC236}">
+                <a16:creationId xmlns:a16="http://schemas.microsoft.com/office/drawing/2014/main" id="{26C2AFD9-F249-34EA-0DFD-B9149B1429FE}"/>
+              </a:ext>
+            </a:extLst>
+          </p:cNvPr>
+          <p:cNvSpPr>
+            <a:spLocks noGrp="1"/>
+          </p:cNvSpPr>
+          <p:nvPr>
+            <p:ph type="title"/>
+          </p:nvPr>
+        </p:nvSpPr>
+        <p:spPr/>
+        <p:txBody>
+          <a:bodyPr/>
+          <a:lstStyle/>
+          <a:p>
+            <a:pPr algn="ctr"/>
+            <a:r>
+              <a:rPr lang="it-IT" dirty="0"/>
+              <a:t>SEQUENCE DIAGRAM – GO TO ACQUISTO</a:t>
+            </a:r>
+          </a:p>
+        </p:txBody>
+      </p:sp>
+      <p:pic>
+        <p:nvPicPr>
+          <p:cNvPr id="5" name="Segnaposto contenuto 4" descr="Immagine che contiene testo, schermata, numero, Carattere&#10;&#10;Il contenuto generato dall'IA potrebbe non essere corretto.">
+            <a:extLst>
+              <a:ext uri="{FF2B5EF4-FFF2-40B4-BE49-F238E27FC236}">
+                <a16:creationId xmlns:a16="http://schemas.microsoft.com/office/drawing/2014/main" id="{1C3E70CE-AB16-84E7-3B89-C93CE931019E}"/>
+              </a:ext>
+            </a:extLst>
+          </p:cNvPr>
+          <p:cNvPicPr>
+            <a:picLocks noGrp="1" noChangeAspect="1"/>
+          </p:cNvPicPr>
+          <p:nvPr>
+            <p:ph idx="1"/>
+          </p:nvPr>
+        </p:nvPicPr>
+        <p:blipFill>
+          <a:blip r:embed="rId2"/>
+          <a:stretch>
+            <a:fillRect/>
+          </a:stretch>
+        </p:blipFill>
+        <p:spPr>
+          <a:xfrm>
+            <a:off x="1548246" y="1628957"/>
+            <a:ext cx="9310254" cy="4766103"/>
+          </a:xfrm>
+        </p:spPr>
+      </p:pic>
+    </p:spTree>
+    <p:extLst>
+      <p:ext uri="{BB962C8B-B14F-4D97-AF65-F5344CB8AC3E}">
+        <p14:creationId xmlns:p14="http://schemas.microsoft.com/office/powerpoint/2010/main" val="3112876415"/>
+      </p:ext>
+    </p:extLst>
+  </p:cSld>
+  <p:clrMapOvr>
+    <a:masterClrMapping/>
+  </p:clrMapOvr>
+</p:sld>
+</file>
+
+<file path=ppt/slides/slide29.xml><?xml version="1.0" encoding="utf-8"?>
+<p:sld xmlns:a="http://schemas.openxmlformats.org/drawingml/2006/main" xmlns:r="http://schemas.openxmlformats.org/officeDocument/2006/relationships" xmlns:p="http://schemas.openxmlformats.org/presentationml/2006/main">
+  <p:cSld>
+    <p:spTree>
+      <p:nvGrpSpPr>
+        <p:cNvPr id="1" name="">
+          <a:extLst>
+            <a:ext uri="{FF2B5EF4-FFF2-40B4-BE49-F238E27FC236}">
+              <a16:creationId xmlns:a16="http://schemas.microsoft.com/office/drawing/2014/main" id="{AA333138-BE70-8D72-7224-846E8B518A4B}"/>
+            </a:ext>
+          </a:extLst>
+        </p:cNvPr>
+        <p:cNvGrpSpPr/>
+        <p:nvPr/>
+      </p:nvGrpSpPr>
+      <p:grpSpPr>
+        <a:xfrm>
+          <a:off x="0" y="0"/>
+          <a:ext cx="0" cy="0"/>
+          <a:chOff x="0" y="0"/>
+          <a:chExt cx="0" cy="0"/>
+        </a:xfrm>
+      </p:grpSpPr>
+      <p:sp>
+        <p:nvSpPr>
+          <p:cNvPr id="2" name="Titolo 1">
+            <a:extLst>
+              <a:ext uri="{FF2B5EF4-FFF2-40B4-BE49-F238E27FC236}">
+                <a16:creationId xmlns:a16="http://schemas.microsoft.com/office/drawing/2014/main" id="{9833DF20-AA24-DDD3-3FFA-33C4AD79947D}"/>
+              </a:ext>
+            </a:extLst>
+          </p:cNvPr>
+          <p:cNvSpPr>
+            <a:spLocks noGrp="1"/>
+          </p:cNvSpPr>
+          <p:nvPr>
+            <p:ph type="title"/>
+          </p:nvPr>
+        </p:nvSpPr>
+        <p:spPr/>
+        <p:txBody>
+          <a:bodyPr/>
+          <a:lstStyle/>
+          <a:p>
+            <a:pPr algn="ctr"/>
+            <a:r>
+              <a:rPr lang="it-IT" dirty="0"/>
+              <a:t>SEQUENCE DIAGRAM – GO TO DETTAGLIO ASTA</a:t>
+            </a:r>
+          </a:p>
+        </p:txBody>
+      </p:sp>
+      <p:pic>
+        <p:nvPicPr>
+          <p:cNvPr id="5" name="Segnaposto contenuto 4" descr="Immagine che contiene testo, schermata, numero, Carattere&#10;&#10;Il contenuto generato dall'IA potrebbe non essere corretto.">
+            <a:extLst>
+              <a:ext uri="{FF2B5EF4-FFF2-40B4-BE49-F238E27FC236}">
+                <a16:creationId xmlns:a16="http://schemas.microsoft.com/office/drawing/2014/main" id="{EBCB93FA-E45A-C10C-DD16-554093D140FE}"/>
+              </a:ext>
+            </a:extLst>
+          </p:cNvPr>
+          <p:cNvPicPr>
+            <a:picLocks noGrp="1" noChangeAspect="1"/>
+          </p:cNvPicPr>
+          <p:nvPr>
+            <p:ph idx="1"/>
+          </p:nvPr>
+        </p:nvPicPr>
+        <p:blipFill>
+          <a:blip r:embed="rId2"/>
+          <a:stretch>
+            <a:fillRect/>
+          </a:stretch>
+        </p:blipFill>
+        <p:spPr>
+          <a:xfrm>
+            <a:off x="2722419" y="1641968"/>
+            <a:ext cx="6909954" cy="4721638"/>
+          </a:xfrm>
+        </p:spPr>
+      </p:pic>
+    </p:spTree>
+    <p:extLst>
+      <p:ext uri="{BB962C8B-B14F-4D97-AF65-F5344CB8AC3E}">
+        <p14:creationId xmlns:p14="http://schemas.microsoft.com/office/powerpoint/2010/main" val="2371181397"/>
+      </p:ext>
+    </p:extLst>
+  </p:cSld>
+  <p:clrMapOvr>
+    <a:masterClrMapping/>
+  </p:clrMapOvr>
+</p:sld>
+</file>
+
 <file path=ppt/slides/slide3.xml><?xml version="1.0" encoding="utf-8"?>
 <p:sld xmlns:a="http://schemas.openxmlformats.org/drawingml/2006/main" xmlns:r="http://schemas.openxmlformats.org/officeDocument/2006/relationships" xmlns:p="http://schemas.openxmlformats.org/presentationml/2006/main">
   <p:cSld>
@@ -9572,6 +12778,952 @@
     <p:extLst>
       <p:ext uri="{BB962C8B-B14F-4D97-AF65-F5344CB8AC3E}">
         <p14:creationId xmlns:p14="http://schemas.microsoft.com/office/powerpoint/2010/main" val="973804671"/>
+      </p:ext>
+    </p:extLst>
+  </p:cSld>
+  <p:clrMapOvr>
+    <a:masterClrMapping/>
+  </p:clrMapOvr>
+</p:sld>
+</file>
+
+<file path=ppt/slides/slide30.xml><?xml version="1.0" encoding="utf-8"?>
+<p:sld xmlns:a="http://schemas.openxmlformats.org/drawingml/2006/main" xmlns:r="http://schemas.openxmlformats.org/officeDocument/2006/relationships" xmlns:p="http://schemas.openxmlformats.org/presentationml/2006/main">
+  <p:cSld>
+    <p:spTree>
+      <p:nvGrpSpPr>
+        <p:cNvPr id="1" name="">
+          <a:extLst>
+            <a:ext uri="{FF2B5EF4-FFF2-40B4-BE49-F238E27FC236}">
+              <a16:creationId xmlns:a16="http://schemas.microsoft.com/office/drawing/2014/main" id="{73238343-DEA0-2086-1C54-63C48A8E27DE}"/>
+            </a:ext>
+          </a:extLst>
+        </p:cNvPr>
+        <p:cNvGrpSpPr/>
+        <p:nvPr/>
+      </p:nvGrpSpPr>
+      <p:grpSpPr>
+        <a:xfrm>
+          <a:off x="0" y="0"/>
+          <a:ext cx="0" cy="0"/>
+          <a:chOff x="0" y="0"/>
+          <a:chExt cx="0" cy="0"/>
+        </a:xfrm>
+      </p:grpSpPr>
+      <p:sp>
+        <p:nvSpPr>
+          <p:cNvPr id="2" name="Titolo 1">
+            <a:extLst>
+              <a:ext uri="{FF2B5EF4-FFF2-40B4-BE49-F238E27FC236}">
+                <a16:creationId xmlns:a16="http://schemas.microsoft.com/office/drawing/2014/main" id="{F08D50D1-BF1F-1913-29B2-9A7F9C8FD4FD}"/>
+              </a:ext>
+            </a:extLst>
+          </p:cNvPr>
+          <p:cNvSpPr>
+            <a:spLocks noGrp="1"/>
+          </p:cNvSpPr>
+          <p:nvPr>
+            <p:ph type="title"/>
+          </p:nvPr>
+        </p:nvSpPr>
+        <p:spPr/>
+        <p:txBody>
+          <a:bodyPr/>
+          <a:lstStyle/>
+          <a:p>
+            <a:pPr algn="ctr"/>
+            <a:r>
+              <a:rPr lang="it-IT" dirty="0"/>
+              <a:t>SEQUENCE DIAGRAM – SEARCH ASTE BY KEY </a:t>
+            </a:r>
+          </a:p>
+        </p:txBody>
+      </p:sp>
+      <p:pic>
+        <p:nvPicPr>
+          <p:cNvPr id="5" name="Segnaposto contenuto 4" descr="Immagine che contiene testo, schermata, Carattere, linea&#10;&#10;Il contenuto generato dall'IA potrebbe non essere corretto.">
+            <a:extLst>
+              <a:ext uri="{FF2B5EF4-FFF2-40B4-BE49-F238E27FC236}">
+                <a16:creationId xmlns:a16="http://schemas.microsoft.com/office/drawing/2014/main" id="{39BF1B3C-8B65-4BD8-1C2F-CDA1BC851D9A}"/>
+              </a:ext>
+            </a:extLst>
+          </p:cNvPr>
+          <p:cNvPicPr>
+            <a:picLocks noGrp="1" noChangeAspect="1"/>
+          </p:cNvPicPr>
+          <p:nvPr>
+            <p:ph idx="1"/>
+          </p:nvPr>
+        </p:nvPicPr>
+        <p:blipFill>
+          <a:blip r:embed="rId2"/>
+          <a:stretch>
+            <a:fillRect/>
+          </a:stretch>
+        </p:blipFill>
+        <p:spPr>
+          <a:xfrm>
+            <a:off x="2272636" y="1724891"/>
+            <a:ext cx="7924204" cy="4520045"/>
+          </a:xfrm>
+        </p:spPr>
+      </p:pic>
+    </p:spTree>
+    <p:extLst>
+      <p:ext uri="{BB962C8B-B14F-4D97-AF65-F5344CB8AC3E}">
+        <p14:creationId xmlns:p14="http://schemas.microsoft.com/office/powerpoint/2010/main" val="1866007806"/>
+      </p:ext>
+    </p:extLst>
+  </p:cSld>
+  <p:clrMapOvr>
+    <a:masterClrMapping/>
+  </p:clrMapOvr>
+</p:sld>
+</file>
+
+<file path=ppt/slides/slide31.xml><?xml version="1.0" encoding="utf-8"?>
+<p:sld xmlns:a="http://schemas.openxmlformats.org/drawingml/2006/main" xmlns:r="http://schemas.openxmlformats.org/officeDocument/2006/relationships" xmlns:p="http://schemas.openxmlformats.org/presentationml/2006/main">
+  <p:cSld>
+    <p:spTree>
+      <p:nvGrpSpPr>
+        <p:cNvPr id="1" name="">
+          <a:extLst>
+            <a:ext uri="{FF2B5EF4-FFF2-40B4-BE49-F238E27FC236}">
+              <a16:creationId xmlns:a16="http://schemas.microsoft.com/office/drawing/2014/main" id="{31FAC8C2-4EA9-B8C7-1A88-A526A93B9E77}"/>
+            </a:ext>
+          </a:extLst>
+        </p:cNvPr>
+        <p:cNvGrpSpPr/>
+        <p:nvPr/>
+      </p:nvGrpSpPr>
+      <p:grpSpPr>
+        <a:xfrm>
+          <a:off x="0" y="0"/>
+          <a:ext cx="0" cy="0"/>
+          <a:chOff x="0" y="0"/>
+          <a:chExt cx="0" cy="0"/>
+        </a:xfrm>
+      </p:grpSpPr>
+      <p:sp>
+        <p:nvSpPr>
+          <p:cNvPr id="2" name="Titolo 1">
+            <a:extLst>
+              <a:ext uri="{FF2B5EF4-FFF2-40B4-BE49-F238E27FC236}">
+                <a16:creationId xmlns:a16="http://schemas.microsoft.com/office/drawing/2014/main" id="{5D6AC322-0E0B-6A6E-04D0-8AEC47B203AB}"/>
+              </a:ext>
+            </a:extLst>
+          </p:cNvPr>
+          <p:cNvSpPr>
+            <a:spLocks noGrp="1"/>
+          </p:cNvSpPr>
+          <p:nvPr>
+            <p:ph type="title"/>
+          </p:nvPr>
+        </p:nvSpPr>
+        <p:spPr/>
+        <p:txBody>
+          <a:bodyPr/>
+          <a:lstStyle/>
+          <a:p>
+            <a:pPr algn="ctr"/>
+            <a:r>
+              <a:rPr lang="it-IT" dirty="0"/>
+              <a:t>SEQUENCE DIAGRAM – FAI OFFERTA</a:t>
+            </a:r>
+          </a:p>
+        </p:txBody>
+      </p:sp>
+      <p:pic>
+        <p:nvPicPr>
+          <p:cNvPr id="5" name="Segnaposto contenuto 4" descr="Immagine che contiene testo, schermata, linea, Carattere&#10;&#10;Il contenuto generato dall'IA potrebbe non essere corretto.">
+            <a:extLst>
+              <a:ext uri="{FF2B5EF4-FFF2-40B4-BE49-F238E27FC236}">
+                <a16:creationId xmlns:a16="http://schemas.microsoft.com/office/drawing/2014/main" id="{8F0A9A2C-7FDE-9C44-66DA-9924D0DC10D0}"/>
+              </a:ext>
+            </a:extLst>
+          </p:cNvPr>
+          <p:cNvPicPr>
+            <a:picLocks noGrp="1" noChangeAspect="1"/>
+          </p:cNvPicPr>
+          <p:nvPr>
+            <p:ph idx="1"/>
+          </p:nvPr>
+        </p:nvPicPr>
+        <p:blipFill>
+          <a:blip r:embed="rId2"/>
+          <a:stretch>
+            <a:fillRect/>
+          </a:stretch>
+        </p:blipFill>
+        <p:spPr>
+          <a:xfrm>
+            <a:off x="2493818" y="1577483"/>
+            <a:ext cx="7232073" cy="4942889"/>
+          </a:xfrm>
+        </p:spPr>
+      </p:pic>
+    </p:spTree>
+    <p:extLst>
+      <p:ext uri="{BB962C8B-B14F-4D97-AF65-F5344CB8AC3E}">
+        <p14:creationId xmlns:p14="http://schemas.microsoft.com/office/powerpoint/2010/main" val="83448595"/>
+      </p:ext>
+    </p:extLst>
+  </p:cSld>
+  <p:clrMapOvr>
+    <a:masterClrMapping/>
+  </p:clrMapOvr>
+</p:sld>
+</file>
+
+<file path=ppt/slides/slide32.xml><?xml version="1.0" encoding="utf-8"?>
+<p:sld xmlns:a="http://schemas.openxmlformats.org/drawingml/2006/main" xmlns:r="http://schemas.openxmlformats.org/officeDocument/2006/relationships" xmlns:p="http://schemas.openxmlformats.org/presentationml/2006/main">
+  <p:cSld>
+    <p:spTree>
+      <p:nvGrpSpPr>
+        <p:cNvPr id="1" name="">
+          <a:extLst>
+            <a:ext uri="{FF2B5EF4-FFF2-40B4-BE49-F238E27FC236}">
+              <a16:creationId xmlns:a16="http://schemas.microsoft.com/office/drawing/2014/main" id="{92B188A3-A14D-95AB-C2D1-2831127D18BE}"/>
+            </a:ext>
+          </a:extLst>
+        </p:cNvPr>
+        <p:cNvGrpSpPr/>
+        <p:nvPr/>
+      </p:nvGrpSpPr>
+      <p:grpSpPr>
+        <a:xfrm>
+          <a:off x="0" y="0"/>
+          <a:ext cx="0" cy="0"/>
+          <a:chOff x="0" y="0"/>
+          <a:chExt cx="0" cy="0"/>
+        </a:xfrm>
+      </p:grpSpPr>
+      <p:sp>
+        <p:nvSpPr>
+          <p:cNvPr id="2" name="Titolo 1">
+            <a:extLst>
+              <a:ext uri="{FF2B5EF4-FFF2-40B4-BE49-F238E27FC236}">
+                <a16:creationId xmlns:a16="http://schemas.microsoft.com/office/drawing/2014/main" id="{D9CA4EB5-8E57-4A25-867E-E9341ABFB2FA}"/>
+              </a:ext>
+            </a:extLst>
+          </p:cNvPr>
+          <p:cNvSpPr>
+            <a:spLocks noGrp="1"/>
+          </p:cNvSpPr>
+          <p:nvPr>
+            <p:ph type="title"/>
+          </p:nvPr>
+        </p:nvSpPr>
+        <p:spPr/>
+        <p:txBody>
+          <a:bodyPr/>
+          <a:lstStyle/>
+          <a:p>
+            <a:pPr algn="ctr"/>
+            <a:r>
+              <a:rPr lang="it-IT" dirty="0"/>
+              <a:t>SEQUENCE DIAGRAM – CREA ASTA</a:t>
+            </a:r>
+          </a:p>
+        </p:txBody>
+      </p:sp>
+      <p:pic>
+        <p:nvPicPr>
+          <p:cNvPr id="5" name="Segnaposto contenuto 4" descr="Immagine che contiene testo, ricevuta, numero, schermata&#10;&#10;Il contenuto generato dall'IA potrebbe non essere corretto.">
+            <a:extLst>
+              <a:ext uri="{FF2B5EF4-FFF2-40B4-BE49-F238E27FC236}">
+                <a16:creationId xmlns:a16="http://schemas.microsoft.com/office/drawing/2014/main" id="{870186E4-665D-942A-2A39-DA895250F04B}"/>
+              </a:ext>
+            </a:extLst>
+          </p:cNvPr>
+          <p:cNvPicPr>
+            <a:picLocks noGrp="1" noChangeAspect="1"/>
+          </p:cNvPicPr>
+          <p:nvPr>
+            <p:ph idx="1"/>
+          </p:nvPr>
+        </p:nvPicPr>
+        <p:blipFill>
+          <a:blip r:embed="rId2"/>
+          <a:stretch>
+            <a:fillRect/>
+          </a:stretch>
+        </p:blipFill>
+        <p:spPr>
+          <a:xfrm>
+            <a:off x="2660073" y="1565957"/>
+            <a:ext cx="7003471" cy="4891458"/>
+          </a:xfrm>
+        </p:spPr>
+      </p:pic>
+    </p:spTree>
+    <p:extLst>
+      <p:ext uri="{BB962C8B-B14F-4D97-AF65-F5344CB8AC3E}">
+        <p14:creationId xmlns:p14="http://schemas.microsoft.com/office/powerpoint/2010/main" val="378536628"/>
+      </p:ext>
+    </p:extLst>
+  </p:cSld>
+  <p:clrMapOvr>
+    <a:masterClrMapping/>
+  </p:clrMapOvr>
+</p:sld>
+</file>
+
+<file path=ppt/slides/slide33.xml><?xml version="1.0" encoding="utf-8"?>
+<p:sld xmlns:a="http://schemas.openxmlformats.org/drawingml/2006/main" xmlns:r="http://schemas.openxmlformats.org/officeDocument/2006/relationships" xmlns:p="http://schemas.openxmlformats.org/presentationml/2006/main">
+  <p:cSld>
+    <p:spTree>
+      <p:nvGrpSpPr>
+        <p:cNvPr id="1" name="">
+          <a:extLst>
+            <a:ext uri="{FF2B5EF4-FFF2-40B4-BE49-F238E27FC236}">
+              <a16:creationId xmlns:a16="http://schemas.microsoft.com/office/drawing/2014/main" id="{7B94707B-F5C1-1BBA-43DE-BC2D643DEF74}"/>
+            </a:ext>
+          </a:extLst>
+        </p:cNvPr>
+        <p:cNvGrpSpPr/>
+        <p:nvPr/>
+      </p:nvGrpSpPr>
+      <p:grpSpPr>
+        <a:xfrm>
+          <a:off x="0" y="0"/>
+          <a:ext cx="0" cy="0"/>
+          <a:chOff x="0" y="0"/>
+          <a:chExt cx="0" cy="0"/>
+        </a:xfrm>
+      </p:grpSpPr>
+      <p:sp>
+        <p:nvSpPr>
+          <p:cNvPr id="2" name="Titolo 1">
+            <a:extLst>
+              <a:ext uri="{FF2B5EF4-FFF2-40B4-BE49-F238E27FC236}">
+                <a16:creationId xmlns:a16="http://schemas.microsoft.com/office/drawing/2014/main" id="{45B0ED28-1D68-2A79-F499-E7FC63635630}"/>
+              </a:ext>
+            </a:extLst>
+          </p:cNvPr>
+          <p:cNvSpPr>
+            <a:spLocks noGrp="1"/>
+          </p:cNvSpPr>
+          <p:nvPr>
+            <p:ph type="title"/>
+          </p:nvPr>
+        </p:nvSpPr>
+        <p:spPr/>
+        <p:txBody>
+          <a:bodyPr/>
+          <a:lstStyle/>
+          <a:p>
+            <a:pPr algn="ctr"/>
+            <a:r>
+              <a:rPr lang="it-IT" dirty="0"/>
+              <a:t>SEQUENCE DIAGRAM – CHIUDI ASTA</a:t>
+            </a:r>
+          </a:p>
+        </p:txBody>
+      </p:sp>
+      <p:pic>
+        <p:nvPicPr>
+          <p:cNvPr id="5" name="Segnaposto contenuto 4" descr="Immagine che contiene testo, schermata, Carattere, numero&#10;&#10;Il contenuto generato dall'IA potrebbe non essere corretto.">
+            <a:extLst>
+              <a:ext uri="{FF2B5EF4-FFF2-40B4-BE49-F238E27FC236}">
+                <a16:creationId xmlns:a16="http://schemas.microsoft.com/office/drawing/2014/main" id="{C4D23C40-C00A-BCB2-36EC-CDD6988AE44F}"/>
+              </a:ext>
+            </a:extLst>
+          </p:cNvPr>
+          <p:cNvPicPr>
+            <a:picLocks noGrp="1" noChangeAspect="1"/>
+          </p:cNvPicPr>
+          <p:nvPr>
+            <p:ph idx="1"/>
+          </p:nvPr>
+        </p:nvPicPr>
+        <p:blipFill>
+          <a:blip r:embed="rId2"/>
+          <a:stretch>
+            <a:fillRect/>
+          </a:stretch>
+        </p:blipFill>
+        <p:spPr>
+          <a:xfrm>
+            <a:off x="2548344" y="1535101"/>
+            <a:ext cx="7271065" cy="4928044"/>
+          </a:xfrm>
+        </p:spPr>
+      </p:pic>
+    </p:spTree>
+    <p:extLst>
+      <p:ext uri="{BB962C8B-B14F-4D97-AF65-F5344CB8AC3E}">
+        <p14:creationId xmlns:p14="http://schemas.microsoft.com/office/powerpoint/2010/main" val="226067210"/>
+      </p:ext>
+    </p:extLst>
+  </p:cSld>
+  <p:clrMapOvr>
+    <a:masterClrMapping/>
+  </p:clrMapOvr>
+</p:sld>
+</file>
+
+<file path=ppt/slides/slide34.xml><?xml version="1.0" encoding="utf-8"?>
+<p:sld xmlns:a="http://schemas.openxmlformats.org/drawingml/2006/main" xmlns:r="http://schemas.openxmlformats.org/officeDocument/2006/relationships" xmlns:p="http://schemas.openxmlformats.org/presentationml/2006/main">
+  <p:cSld>
+    <p:spTree>
+      <p:nvGrpSpPr>
+        <p:cNvPr id="1" name="">
+          <a:extLst>
+            <a:ext uri="{FF2B5EF4-FFF2-40B4-BE49-F238E27FC236}">
+              <a16:creationId xmlns:a16="http://schemas.microsoft.com/office/drawing/2014/main" id="{19C3C918-7594-30C2-4CB0-5C4CE88A0E38}"/>
+            </a:ext>
+          </a:extLst>
+        </p:cNvPr>
+        <p:cNvGrpSpPr/>
+        <p:nvPr/>
+      </p:nvGrpSpPr>
+      <p:grpSpPr>
+        <a:xfrm>
+          <a:off x="0" y="0"/>
+          <a:ext cx="0" cy="0"/>
+          <a:chOff x="0" y="0"/>
+          <a:chExt cx="0" cy="0"/>
+        </a:xfrm>
+      </p:grpSpPr>
+      <p:sp>
+        <p:nvSpPr>
+          <p:cNvPr id="2" name="Titolo 1">
+            <a:extLst>
+              <a:ext uri="{FF2B5EF4-FFF2-40B4-BE49-F238E27FC236}">
+                <a16:creationId xmlns:a16="http://schemas.microsoft.com/office/drawing/2014/main" id="{FF874F21-99E4-2CD9-799E-C6509178008C}"/>
+              </a:ext>
+            </a:extLst>
+          </p:cNvPr>
+          <p:cNvSpPr>
+            <a:spLocks noGrp="1"/>
+          </p:cNvSpPr>
+          <p:nvPr>
+            <p:ph type="title"/>
+          </p:nvPr>
+        </p:nvSpPr>
+        <p:spPr/>
+        <p:txBody>
+          <a:bodyPr/>
+          <a:lstStyle/>
+          <a:p>
+            <a:pPr algn="ctr"/>
+            <a:r>
+              <a:rPr lang="it-IT" dirty="0"/>
+              <a:t>SEQUENCE DIAGRAM – AGGIUNGI ARTICOLO</a:t>
+            </a:r>
+          </a:p>
+        </p:txBody>
+      </p:sp>
+      <p:pic>
+        <p:nvPicPr>
+          <p:cNvPr id="5" name="Segnaposto contenuto 4" descr="Immagine che contiene testo, schermata, Carattere, linea&#10;&#10;Il contenuto generato dall'IA potrebbe non essere corretto.">
+            <a:extLst>
+              <a:ext uri="{FF2B5EF4-FFF2-40B4-BE49-F238E27FC236}">
+                <a16:creationId xmlns:a16="http://schemas.microsoft.com/office/drawing/2014/main" id="{B5862C63-546E-D1F9-48BF-262CDA953E85}"/>
+              </a:ext>
+            </a:extLst>
+          </p:cNvPr>
+          <p:cNvPicPr>
+            <a:picLocks noGrp="1" noChangeAspect="1"/>
+          </p:cNvPicPr>
+          <p:nvPr>
+            <p:ph idx="1"/>
+          </p:nvPr>
+        </p:nvPicPr>
+        <p:blipFill>
+          <a:blip r:embed="rId2"/>
+          <a:stretch>
+            <a:fillRect/>
+          </a:stretch>
+        </p:blipFill>
+        <p:spPr>
+          <a:xfrm>
+            <a:off x="800100" y="1776846"/>
+            <a:ext cx="10606379" cy="4581956"/>
+          </a:xfrm>
+        </p:spPr>
+      </p:pic>
+    </p:spTree>
+    <p:extLst>
+      <p:ext uri="{BB962C8B-B14F-4D97-AF65-F5344CB8AC3E}">
+        <p14:creationId xmlns:p14="http://schemas.microsoft.com/office/powerpoint/2010/main" val="2333171487"/>
+      </p:ext>
+    </p:extLst>
+  </p:cSld>
+  <p:clrMapOvr>
+    <a:masterClrMapping/>
+  </p:clrMapOvr>
+</p:sld>
+</file>
+
+<file path=ppt/slides/slide35.xml><?xml version="1.0" encoding="utf-8"?>
+<p:sld xmlns:a="http://schemas.openxmlformats.org/drawingml/2006/main" xmlns:r="http://schemas.openxmlformats.org/officeDocument/2006/relationships" xmlns:p="http://schemas.openxmlformats.org/presentationml/2006/main">
+  <p:cSld>
+    <p:spTree>
+      <p:nvGrpSpPr>
+        <p:cNvPr id="1" name="">
+          <a:extLst>
+            <a:ext uri="{FF2B5EF4-FFF2-40B4-BE49-F238E27FC236}">
+              <a16:creationId xmlns:a16="http://schemas.microsoft.com/office/drawing/2014/main" id="{A3AA708F-17E3-13BB-FFC7-4E98B1FD7675}"/>
+            </a:ext>
+          </a:extLst>
+        </p:cNvPr>
+        <p:cNvGrpSpPr/>
+        <p:nvPr/>
+      </p:nvGrpSpPr>
+      <p:grpSpPr>
+        <a:xfrm>
+          <a:off x="0" y="0"/>
+          <a:ext cx="0" cy="0"/>
+          <a:chOff x="0" y="0"/>
+          <a:chExt cx="0" cy="0"/>
+        </a:xfrm>
+      </p:grpSpPr>
+      <p:sp>
+        <p:nvSpPr>
+          <p:cNvPr id="2" name="Titolo 1">
+            <a:extLst>
+              <a:ext uri="{FF2B5EF4-FFF2-40B4-BE49-F238E27FC236}">
+                <a16:creationId xmlns:a16="http://schemas.microsoft.com/office/drawing/2014/main" id="{C42EB8AF-6D01-C19F-D1ED-19B5F2EB60DB}"/>
+              </a:ext>
+            </a:extLst>
+          </p:cNvPr>
+          <p:cNvSpPr>
+            <a:spLocks noGrp="1"/>
+          </p:cNvSpPr>
+          <p:nvPr>
+            <p:ph type="title"/>
+          </p:nvPr>
+        </p:nvSpPr>
+        <p:spPr/>
+        <p:txBody>
+          <a:bodyPr>
+            <a:normAutofit fontScale="90000"/>
+          </a:bodyPr>
+          <a:lstStyle/>
+          <a:p>
+            <a:pPr algn="ctr"/>
+            <a:r>
+              <a:rPr lang="it-IT" dirty="0"/>
+              <a:t>SEQUENCE DIAGRAM – RIA – CARICAMENTO HOME</a:t>
+            </a:r>
+          </a:p>
+        </p:txBody>
+      </p:sp>
+      <p:pic>
+        <p:nvPicPr>
+          <p:cNvPr id="5" name="Segnaposto contenuto 4" descr="Immagine che contiene testo, schermata, Carattere, linea&#10;&#10;Il contenuto generato dall'IA potrebbe non essere corretto.">
+            <a:extLst>
+              <a:ext uri="{FF2B5EF4-FFF2-40B4-BE49-F238E27FC236}">
+                <a16:creationId xmlns:a16="http://schemas.microsoft.com/office/drawing/2014/main" id="{923BC546-CE1A-804A-96D6-4A94D96F62C0}"/>
+              </a:ext>
+            </a:extLst>
+          </p:cNvPr>
+          <p:cNvPicPr>
+            <a:picLocks noGrp="1" noChangeAspect="1"/>
+          </p:cNvPicPr>
+          <p:nvPr>
+            <p:ph idx="1"/>
+          </p:nvPr>
+        </p:nvPicPr>
+        <p:blipFill>
+          <a:blip r:embed="rId2"/>
+          <a:stretch>
+            <a:fillRect/>
+          </a:stretch>
+        </p:blipFill>
+        <p:spPr>
+          <a:xfrm>
+            <a:off x="684644" y="2639291"/>
+            <a:ext cx="10712074" cy="2909453"/>
+          </a:xfrm>
+        </p:spPr>
+      </p:pic>
+    </p:spTree>
+    <p:extLst>
+      <p:ext uri="{BB962C8B-B14F-4D97-AF65-F5344CB8AC3E}">
+        <p14:creationId xmlns:p14="http://schemas.microsoft.com/office/powerpoint/2010/main" val="1872397111"/>
+      </p:ext>
+    </p:extLst>
+  </p:cSld>
+  <p:clrMapOvr>
+    <a:masterClrMapping/>
+  </p:clrMapOvr>
+</p:sld>
+</file>
+
+<file path=ppt/slides/slide36.xml><?xml version="1.0" encoding="utf-8"?>
+<p:sld xmlns:a="http://schemas.openxmlformats.org/drawingml/2006/main" xmlns:r="http://schemas.openxmlformats.org/officeDocument/2006/relationships" xmlns:p="http://schemas.openxmlformats.org/presentationml/2006/main">
+  <p:cSld>
+    <p:spTree>
+      <p:nvGrpSpPr>
+        <p:cNvPr id="1" name="">
+          <a:extLst>
+            <a:ext uri="{FF2B5EF4-FFF2-40B4-BE49-F238E27FC236}">
+              <a16:creationId xmlns:a16="http://schemas.microsoft.com/office/drawing/2014/main" id="{E6027CDA-71F6-7034-176F-3B934C3FF8EE}"/>
+            </a:ext>
+          </a:extLst>
+        </p:cNvPr>
+        <p:cNvGrpSpPr/>
+        <p:nvPr/>
+      </p:nvGrpSpPr>
+      <p:grpSpPr>
+        <a:xfrm>
+          <a:off x="0" y="0"/>
+          <a:ext cx="0" cy="0"/>
+          <a:chOff x="0" y="0"/>
+          <a:chExt cx="0" cy="0"/>
+        </a:xfrm>
+      </p:grpSpPr>
+      <p:sp>
+        <p:nvSpPr>
+          <p:cNvPr id="2" name="Titolo 1">
+            <a:extLst>
+              <a:ext uri="{FF2B5EF4-FFF2-40B4-BE49-F238E27FC236}">
+                <a16:creationId xmlns:a16="http://schemas.microsoft.com/office/drawing/2014/main" id="{A466FA82-DE60-7646-0359-E385CE60B4BE}"/>
+              </a:ext>
+            </a:extLst>
+          </p:cNvPr>
+          <p:cNvSpPr>
+            <a:spLocks noGrp="1"/>
+          </p:cNvSpPr>
+          <p:nvPr>
+            <p:ph type="title"/>
+          </p:nvPr>
+        </p:nvSpPr>
+        <p:spPr/>
+        <p:txBody>
+          <a:bodyPr>
+            <a:normAutofit fontScale="90000"/>
+          </a:bodyPr>
+          <a:lstStyle/>
+          <a:p>
+            <a:pPr algn="ctr"/>
+            <a:r>
+              <a:rPr lang="it-IT" dirty="0"/>
+              <a:t>SEQUENCE DIAGRAM – CARICAMENTO ACQUISTO</a:t>
+            </a:r>
+          </a:p>
+        </p:txBody>
+      </p:sp>
+      <p:pic>
+        <p:nvPicPr>
+          <p:cNvPr id="5" name="Segnaposto contenuto 4" descr="Immagine che contiene testo, diagramma, Parallelo, linea&#10;&#10;Il contenuto generato dall'IA potrebbe non essere corretto.">
+            <a:extLst>
+              <a:ext uri="{FF2B5EF4-FFF2-40B4-BE49-F238E27FC236}">
+                <a16:creationId xmlns:a16="http://schemas.microsoft.com/office/drawing/2014/main" id="{EC996D10-F426-5334-EEEE-6B381700E448}"/>
+              </a:ext>
+            </a:extLst>
+          </p:cNvPr>
+          <p:cNvPicPr>
+            <a:picLocks noGrp="1" noChangeAspect="1"/>
+          </p:cNvPicPr>
+          <p:nvPr>
+            <p:ph idx="1"/>
+          </p:nvPr>
+        </p:nvPicPr>
+        <p:blipFill>
+          <a:blip r:embed="rId2"/>
+          <a:stretch>
+            <a:fillRect/>
+          </a:stretch>
+        </p:blipFill>
+        <p:spPr>
+          <a:xfrm>
+            <a:off x="2815936" y="1553015"/>
+            <a:ext cx="6858000" cy="4800600"/>
+          </a:xfrm>
+        </p:spPr>
+      </p:pic>
+    </p:spTree>
+    <p:extLst>
+      <p:ext uri="{BB962C8B-B14F-4D97-AF65-F5344CB8AC3E}">
+        <p14:creationId xmlns:p14="http://schemas.microsoft.com/office/powerpoint/2010/main" val="4164563900"/>
+      </p:ext>
+    </p:extLst>
+  </p:cSld>
+  <p:clrMapOvr>
+    <a:masterClrMapping/>
+  </p:clrMapOvr>
+</p:sld>
+</file>
+
+<file path=ppt/slides/slide37.xml><?xml version="1.0" encoding="utf-8"?>
+<p:sld xmlns:a="http://schemas.openxmlformats.org/drawingml/2006/main" xmlns:r="http://schemas.openxmlformats.org/officeDocument/2006/relationships" xmlns:p="http://schemas.openxmlformats.org/presentationml/2006/main">
+  <p:cSld>
+    <p:spTree>
+      <p:nvGrpSpPr>
+        <p:cNvPr id="1" name="">
+          <a:extLst>
+            <a:ext uri="{FF2B5EF4-FFF2-40B4-BE49-F238E27FC236}">
+              <a16:creationId xmlns:a16="http://schemas.microsoft.com/office/drawing/2014/main" id="{6DCA445D-A68C-E6A4-C755-2DA511001669}"/>
+            </a:ext>
+          </a:extLst>
+        </p:cNvPr>
+        <p:cNvGrpSpPr/>
+        <p:nvPr/>
+      </p:nvGrpSpPr>
+      <p:grpSpPr>
+        <a:xfrm>
+          <a:off x="0" y="0"/>
+          <a:ext cx="0" cy="0"/>
+          <a:chOff x="0" y="0"/>
+          <a:chExt cx="0" cy="0"/>
+        </a:xfrm>
+      </p:grpSpPr>
+      <p:sp>
+        <p:nvSpPr>
+          <p:cNvPr id="2" name="Titolo 1">
+            <a:extLst>
+              <a:ext uri="{FF2B5EF4-FFF2-40B4-BE49-F238E27FC236}">
+                <a16:creationId xmlns:a16="http://schemas.microsoft.com/office/drawing/2014/main" id="{BA22202D-1A9C-A99F-2844-7251BC30ABA2}"/>
+              </a:ext>
+            </a:extLst>
+          </p:cNvPr>
+          <p:cNvSpPr>
+            <a:spLocks noGrp="1"/>
+          </p:cNvSpPr>
+          <p:nvPr>
+            <p:ph type="title"/>
+          </p:nvPr>
+        </p:nvSpPr>
+        <p:spPr/>
+        <p:txBody>
+          <a:bodyPr/>
+          <a:lstStyle/>
+          <a:p>
+            <a:pPr algn="ctr"/>
+            <a:r>
+              <a:rPr lang="it-IT" dirty="0"/>
+              <a:t>SEQUENCE DIAGRAM – CARICAMENTO VENDO</a:t>
+            </a:r>
+          </a:p>
+        </p:txBody>
+      </p:sp>
+      <p:pic>
+        <p:nvPicPr>
+          <p:cNvPr id="5" name="Segnaposto contenuto 4" descr="Immagine che contiene testo, schermata, numero, Carattere&#10;&#10;Il contenuto generato dall'IA potrebbe non essere corretto.">
+            <a:extLst>
+              <a:ext uri="{FF2B5EF4-FFF2-40B4-BE49-F238E27FC236}">
+                <a16:creationId xmlns:a16="http://schemas.microsoft.com/office/drawing/2014/main" id="{6E72BBF1-1153-67E7-222E-A40E50E10079}"/>
+              </a:ext>
+            </a:extLst>
+          </p:cNvPr>
+          <p:cNvPicPr>
+            <a:picLocks noGrp="1" noChangeAspect="1"/>
+          </p:cNvPicPr>
+          <p:nvPr>
+            <p:ph idx="1"/>
+          </p:nvPr>
+        </p:nvPicPr>
+        <p:blipFill>
+          <a:blip r:embed="rId2"/>
+          <a:stretch>
+            <a:fillRect/>
+          </a:stretch>
+        </p:blipFill>
+        <p:spPr>
+          <a:xfrm>
+            <a:off x="2336312" y="1596375"/>
+            <a:ext cx="7451924" cy="4970679"/>
+          </a:xfrm>
+        </p:spPr>
+      </p:pic>
+    </p:spTree>
+    <p:extLst>
+      <p:ext uri="{BB962C8B-B14F-4D97-AF65-F5344CB8AC3E}">
+        <p14:creationId xmlns:p14="http://schemas.microsoft.com/office/powerpoint/2010/main" val="2424893026"/>
+      </p:ext>
+    </p:extLst>
+  </p:cSld>
+  <p:clrMapOvr>
+    <a:masterClrMapping/>
+  </p:clrMapOvr>
+</p:sld>
+</file>
+
+<file path=ppt/slides/slide38.xml><?xml version="1.0" encoding="utf-8"?>
+<p:sld xmlns:a="http://schemas.openxmlformats.org/drawingml/2006/main" xmlns:r="http://schemas.openxmlformats.org/officeDocument/2006/relationships" xmlns:p="http://schemas.openxmlformats.org/presentationml/2006/main">
+  <p:cSld>
+    <p:spTree>
+      <p:nvGrpSpPr>
+        <p:cNvPr id="1" name="">
+          <a:extLst>
+            <a:ext uri="{FF2B5EF4-FFF2-40B4-BE49-F238E27FC236}">
+              <a16:creationId xmlns:a16="http://schemas.microsoft.com/office/drawing/2014/main" id="{E719DE2E-321B-F75B-09CA-B5FDEBADC03C}"/>
+            </a:ext>
+          </a:extLst>
+        </p:cNvPr>
+        <p:cNvGrpSpPr/>
+        <p:nvPr/>
+      </p:nvGrpSpPr>
+      <p:grpSpPr>
+        <a:xfrm>
+          <a:off x="0" y="0"/>
+          <a:ext cx="0" cy="0"/>
+          <a:chOff x="0" y="0"/>
+          <a:chExt cx="0" cy="0"/>
+        </a:xfrm>
+      </p:grpSpPr>
+      <p:sp>
+        <p:nvSpPr>
+          <p:cNvPr id="2" name="Titolo 1">
+            <a:extLst>
+              <a:ext uri="{FF2B5EF4-FFF2-40B4-BE49-F238E27FC236}">
+                <a16:creationId xmlns:a16="http://schemas.microsoft.com/office/drawing/2014/main" id="{250A6346-DD04-F6D5-68B8-8580EF73BE89}"/>
+              </a:ext>
+            </a:extLst>
+          </p:cNvPr>
+          <p:cNvSpPr>
+            <a:spLocks noGrp="1"/>
+          </p:cNvSpPr>
+          <p:nvPr>
+            <p:ph type="title"/>
+          </p:nvPr>
+        </p:nvSpPr>
+        <p:spPr/>
+        <p:txBody>
+          <a:bodyPr/>
+          <a:lstStyle/>
+          <a:p>
+            <a:pPr algn="ctr"/>
+            <a:r>
+              <a:rPr lang="it-IT" dirty="0"/>
+              <a:t>SEQUENCE DIAGRAM – CARICAMENTO OFFERTA</a:t>
+            </a:r>
+          </a:p>
+        </p:txBody>
+      </p:sp>
+      <p:pic>
+        <p:nvPicPr>
+          <p:cNvPr id="5" name="Segnaposto contenuto 4" descr="Immagine che contiene testo, diagramma, numero, Parallelo&#10;&#10;Il contenuto generato dall'IA potrebbe non essere corretto.">
+            <a:extLst>
+              <a:ext uri="{FF2B5EF4-FFF2-40B4-BE49-F238E27FC236}">
+                <a16:creationId xmlns:a16="http://schemas.microsoft.com/office/drawing/2014/main" id="{57B2568F-9C84-9892-A123-C397BB683759}"/>
+              </a:ext>
+            </a:extLst>
+          </p:cNvPr>
+          <p:cNvPicPr>
+            <a:picLocks noGrp="1" noChangeAspect="1"/>
+          </p:cNvPicPr>
+          <p:nvPr>
+            <p:ph idx="1"/>
+          </p:nvPr>
+        </p:nvPicPr>
+        <p:blipFill>
+          <a:blip r:embed="rId2"/>
+          <a:stretch>
+            <a:fillRect/>
+          </a:stretch>
+        </p:blipFill>
+        <p:spPr>
+          <a:xfrm>
+            <a:off x="1908150" y="1636996"/>
+            <a:ext cx="8461977" cy="4805368"/>
+          </a:xfrm>
+        </p:spPr>
+      </p:pic>
+    </p:spTree>
+    <p:extLst>
+      <p:ext uri="{BB962C8B-B14F-4D97-AF65-F5344CB8AC3E}">
+        <p14:creationId xmlns:p14="http://schemas.microsoft.com/office/powerpoint/2010/main" val="1203242601"/>
+      </p:ext>
+    </p:extLst>
+  </p:cSld>
+  <p:clrMapOvr>
+    <a:masterClrMapping/>
+  </p:clrMapOvr>
+</p:sld>
+</file>
+
+<file path=ppt/slides/slide39.xml><?xml version="1.0" encoding="utf-8"?>
+<p:sld xmlns:a="http://schemas.openxmlformats.org/drawingml/2006/main" xmlns:r="http://schemas.openxmlformats.org/officeDocument/2006/relationships" xmlns:p="http://schemas.openxmlformats.org/presentationml/2006/main">
+  <p:cSld>
+    <p:spTree>
+      <p:nvGrpSpPr>
+        <p:cNvPr id="1" name="">
+          <a:extLst>
+            <a:ext uri="{FF2B5EF4-FFF2-40B4-BE49-F238E27FC236}">
+              <a16:creationId xmlns:a16="http://schemas.microsoft.com/office/drawing/2014/main" id="{0C5B6EF7-E90F-C03E-0639-33F75ACF4D5B}"/>
+            </a:ext>
+          </a:extLst>
+        </p:cNvPr>
+        <p:cNvGrpSpPr/>
+        <p:nvPr/>
+      </p:nvGrpSpPr>
+      <p:grpSpPr>
+        <a:xfrm>
+          <a:off x="0" y="0"/>
+          <a:ext cx="0" cy="0"/>
+          <a:chOff x="0" y="0"/>
+          <a:chExt cx="0" cy="0"/>
+        </a:xfrm>
+      </p:grpSpPr>
+      <p:sp>
+        <p:nvSpPr>
+          <p:cNvPr id="2" name="Titolo 1">
+            <a:extLst>
+              <a:ext uri="{FF2B5EF4-FFF2-40B4-BE49-F238E27FC236}">
+                <a16:creationId xmlns:a16="http://schemas.microsoft.com/office/drawing/2014/main" id="{856268D3-40B1-CE8D-68F0-3A4A1D0BC9A6}"/>
+              </a:ext>
+            </a:extLst>
+          </p:cNvPr>
+          <p:cNvSpPr>
+            <a:spLocks noGrp="1"/>
+          </p:cNvSpPr>
+          <p:nvPr>
+            <p:ph type="title"/>
+          </p:nvPr>
+        </p:nvSpPr>
+        <p:spPr/>
+        <p:txBody>
+          <a:bodyPr>
+            <a:normAutofit fontScale="90000"/>
+          </a:bodyPr>
+          <a:lstStyle/>
+          <a:p>
+            <a:pPr algn="ctr"/>
+            <a:r>
+              <a:rPr lang="it-IT" dirty="0"/>
+              <a:t>SEQUENCE DIAGRAM – CARICAMENTO DETTAGLIO ASTA</a:t>
+            </a:r>
+          </a:p>
+        </p:txBody>
+      </p:sp>
+      <p:pic>
+        <p:nvPicPr>
+          <p:cNvPr id="5" name="Segnaposto contenuto 4" descr="Immagine che contiene testo, schermata, numero, Carattere&#10;&#10;Il contenuto generato dall'IA potrebbe non essere corretto.">
+            <a:extLst>
+              <a:ext uri="{FF2B5EF4-FFF2-40B4-BE49-F238E27FC236}">
+                <a16:creationId xmlns:a16="http://schemas.microsoft.com/office/drawing/2014/main" id="{9516FA46-E1A4-0709-501F-8E0CFFC7BC29}"/>
+              </a:ext>
+            </a:extLst>
+          </p:cNvPr>
+          <p:cNvPicPr>
+            <a:picLocks noGrp="1" noChangeAspect="1"/>
+          </p:cNvPicPr>
+          <p:nvPr>
+            <p:ph idx="1"/>
+          </p:nvPr>
+        </p:nvPicPr>
+        <p:blipFill>
+          <a:blip r:embed="rId2"/>
+          <a:stretch>
+            <a:fillRect/>
+          </a:stretch>
+        </p:blipFill>
+        <p:spPr>
+          <a:xfrm>
+            <a:off x="1860238" y="2043659"/>
+            <a:ext cx="8437153" cy="4066195"/>
+          </a:xfrm>
+        </p:spPr>
+      </p:pic>
+    </p:spTree>
+    <p:extLst>
+      <p:ext uri="{BB962C8B-B14F-4D97-AF65-F5344CB8AC3E}">
+        <p14:creationId xmlns:p14="http://schemas.microsoft.com/office/powerpoint/2010/main" val="2457930748"/>
       </p:ext>
     </p:extLst>
   </p:cSld>
@@ -9819,6 +13971,476 @@
     <p:extLst>
       <p:ext uri="{BB962C8B-B14F-4D97-AF65-F5344CB8AC3E}">
         <p14:creationId xmlns:p14="http://schemas.microsoft.com/office/powerpoint/2010/main" val="1561828668"/>
+      </p:ext>
+    </p:extLst>
+  </p:cSld>
+  <p:clrMapOvr>
+    <a:masterClrMapping/>
+  </p:clrMapOvr>
+</p:sld>
+</file>
+
+<file path=ppt/slides/slide40.xml><?xml version="1.0" encoding="utf-8"?>
+<p:sld xmlns:a="http://schemas.openxmlformats.org/drawingml/2006/main" xmlns:r="http://schemas.openxmlformats.org/officeDocument/2006/relationships" xmlns:p="http://schemas.openxmlformats.org/presentationml/2006/main">
+  <p:cSld>
+    <p:spTree>
+      <p:nvGrpSpPr>
+        <p:cNvPr id="1" name="">
+          <a:extLst>
+            <a:ext uri="{FF2B5EF4-FFF2-40B4-BE49-F238E27FC236}">
+              <a16:creationId xmlns:a16="http://schemas.microsoft.com/office/drawing/2014/main" id="{84D3DD91-D270-A745-4170-FEF9B69E0C00}"/>
+            </a:ext>
+          </a:extLst>
+        </p:cNvPr>
+        <p:cNvGrpSpPr/>
+        <p:nvPr/>
+      </p:nvGrpSpPr>
+      <p:grpSpPr>
+        <a:xfrm>
+          <a:off x="0" y="0"/>
+          <a:ext cx="0" cy="0"/>
+          <a:chOff x="0" y="0"/>
+          <a:chExt cx="0" cy="0"/>
+        </a:xfrm>
+      </p:grpSpPr>
+      <p:sp>
+        <p:nvSpPr>
+          <p:cNvPr id="2" name="Titolo 1">
+            <a:extLst>
+              <a:ext uri="{FF2B5EF4-FFF2-40B4-BE49-F238E27FC236}">
+                <a16:creationId xmlns:a16="http://schemas.microsoft.com/office/drawing/2014/main" id="{0122CB3C-0A15-7C60-8443-F44CC5ED59A6}"/>
+              </a:ext>
+            </a:extLst>
+          </p:cNvPr>
+          <p:cNvSpPr>
+            <a:spLocks noGrp="1"/>
+          </p:cNvSpPr>
+          <p:nvPr>
+            <p:ph type="title"/>
+          </p:nvPr>
+        </p:nvSpPr>
+        <p:spPr/>
+        <p:txBody>
+          <a:bodyPr/>
+          <a:lstStyle/>
+          <a:p>
+            <a:pPr algn="ctr"/>
+            <a:r>
+              <a:rPr lang="it-IT" dirty="0"/>
+              <a:t>SEQUENCE DIAGRAM – AGGIUNGI ARTICOLO</a:t>
+            </a:r>
+          </a:p>
+        </p:txBody>
+      </p:sp>
+      <p:pic>
+        <p:nvPicPr>
+          <p:cNvPr id="5" name="Segnaposto contenuto 4" descr="Immagine che contiene testo, schermata, diagramma, linea&#10;&#10;Il contenuto generato dall'IA potrebbe non essere corretto.">
+            <a:extLst>
+              <a:ext uri="{FF2B5EF4-FFF2-40B4-BE49-F238E27FC236}">
+                <a16:creationId xmlns:a16="http://schemas.microsoft.com/office/drawing/2014/main" id="{123E8D6E-713A-5AC7-9BAD-41AB27C67420}"/>
+              </a:ext>
+            </a:extLst>
+          </p:cNvPr>
+          <p:cNvPicPr>
+            <a:picLocks noGrp="1" noChangeAspect="1"/>
+          </p:cNvPicPr>
+          <p:nvPr>
+            <p:ph idx="1"/>
+          </p:nvPr>
+        </p:nvPicPr>
+        <p:blipFill>
+          <a:blip r:embed="rId2"/>
+          <a:stretch>
+            <a:fillRect/>
+          </a:stretch>
+        </p:blipFill>
+        <p:spPr>
+          <a:xfrm>
+            <a:off x="700634" y="1614698"/>
+            <a:ext cx="10691265" cy="4955500"/>
+          </a:xfrm>
+        </p:spPr>
+      </p:pic>
+    </p:spTree>
+    <p:extLst>
+      <p:ext uri="{BB962C8B-B14F-4D97-AF65-F5344CB8AC3E}">
+        <p14:creationId xmlns:p14="http://schemas.microsoft.com/office/powerpoint/2010/main" val="1349043980"/>
+      </p:ext>
+    </p:extLst>
+  </p:cSld>
+  <p:clrMapOvr>
+    <a:masterClrMapping/>
+  </p:clrMapOvr>
+</p:sld>
+</file>
+
+<file path=ppt/slides/slide41.xml><?xml version="1.0" encoding="utf-8"?>
+<p:sld xmlns:a="http://schemas.openxmlformats.org/drawingml/2006/main" xmlns:r="http://schemas.openxmlformats.org/officeDocument/2006/relationships" xmlns:p="http://schemas.openxmlformats.org/presentationml/2006/main">
+  <p:cSld>
+    <p:spTree>
+      <p:nvGrpSpPr>
+        <p:cNvPr id="1" name="">
+          <a:extLst>
+            <a:ext uri="{FF2B5EF4-FFF2-40B4-BE49-F238E27FC236}">
+              <a16:creationId xmlns:a16="http://schemas.microsoft.com/office/drawing/2014/main" id="{37BDB7F8-8811-C36F-605B-80E6B61B4D55}"/>
+            </a:ext>
+          </a:extLst>
+        </p:cNvPr>
+        <p:cNvGrpSpPr/>
+        <p:nvPr/>
+      </p:nvGrpSpPr>
+      <p:grpSpPr>
+        <a:xfrm>
+          <a:off x="0" y="0"/>
+          <a:ext cx="0" cy="0"/>
+          <a:chOff x="0" y="0"/>
+          <a:chExt cx="0" cy="0"/>
+        </a:xfrm>
+      </p:grpSpPr>
+      <p:sp>
+        <p:nvSpPr>
+          <p:cNvPr id="2" name="Titolo 1">
+            <a:extLst>
+              <a:ext uri="{FF2B5EF4-FFF2-40B4-BE49-F238E27FC236}">
+                <a16:creationId xmlns:a16="http://schemas.microsoft.com/office/drawing/2014/main" id="{68BB636B-D419-C643-EF2D-5AB5C71A0693}"/>
+              </a:ext>
+            </a:extLst>
+          </p:cNvPr>
+          <p:cNvSpPr>
+            <a:spLocks noGrp="1"/>
+          </p:cNvSpPr>
+          <p:nvPr>
+            <p:ph type="title"/>
+          </p:nvPr>
+        </p:nvSpPr>
+        <p:spPr/>
+        <p:txBody>
+          <a:bodyPr/>
+          <a:lstStyle/>
+          <a:p>
+            <a:pPr algn="ctr"/>
+            <a:r>
+              <a:rPr lang="it-IT" dirty="0"/>
+              <a:t>SEQUENCE DIAGRAM – CREA ASTA</a:t>
+            </a:r>
+          </a:p>
+        </p:txBody>
+      </p:sp>
+      <p:pic>
+        <p:nvPicPr>
+          <p:cNvPr id="5" name="Segnaposto contenuto 4" descr="Immagine che contiene testo, schermata, Carattere, diagramma&#10;&#10;Il contenuto generato dall'IA potrebbe non essere corretto.">
+            <a:extLst>
+              <a:ext uri="{FF2B5EF4-FFF2-40B4-BE49-F238E27FC236}">
+                <a16:creationId xmlns:a16="http://schemas.microsoft.com/office/drawing/2014/main" id="{1E30C2F4-DFD6-FEB6-24CF-068C7DF15E8E}"/>
+              </a:ext>
+            </a:extLst>
+          </p:cNvPr>
+          <p:cNvPicPr>
+            <a:picLocks noGrp="1" noChangeAspect="1"/>
+          </p:cNvPicPr>
+          <p:nvPr>
+            <p:ph idx="1"/>
+          </p:nvPr>
+        </p:nvPicPr>
+        <p:blipFill>
+          <a:blip r:embed="rId2"/>
+          <a:stretch>
+            <a:fillRect/>
+          </a:stretch>
+        </p:blipFill>
+        <p:spPr>
+          <a:xfrm>
+            <a:off x="2400300" y="1509102"/>
+            <a:ext cx="7471063" cy="4964434"/>
+          </a:xfrm>
+        </p:spPr>
+      </p:pic>
+    </p:spTree>
+    <p:extLst>
+      <p:ext uri="{BB962C8B-B14F-4D97-AF65-F5344CB8AC3E}">
+        <p14:creationId xmlns:p14="http://schemas.microsoft.com/office/powerpoint/2010/main" val="3736278895"/>
+      </p:ext>
+    </p:extLst>
+  </p:cSld>
+  <p:clrMapOvr>
+    <a:masterClrMapping/>
+  </p:clrMapOvr>
+</p:sld>
+</file>
+
+<file path=ppt/slides/slide42.xml><?xml version="1.0" encoding="utf-8"?>
+<p:sld xmlns:a="http://schemas.openxmlformats.org/drawingml/2006/main" xmlns:r="http://schemas.openxmlformats.org/officeDocument/2006/relationships" xmlns:p="http://schemas.openxmlformats.org/presentationml/2006/main">
+  <p:cSld>
+    <p:spTree>
+      <p:nvGrpSpPr>
+        <p:cNvPr id="1" name="">
+          <a:extLst>
+            <a:ext uri="{FF2B5EF4-FFF2-40B4-BE49-F238E27FC236}">
+              <a16:creationId xmlns:a16="http://schemas.microsoft.com/office/drawing/2014/main" id="{9090ADEB-B033-7355-F48D-DA83D509F2D9}"/>
+            </a:ext>
+          </a:extLst>
+        </p:cNvPr>
+        <p:cNvGrpSpPr/>
+        <p:nvPr/>
+      </p:nvGrpSpPr>
+      <p:grpSpPr>
+        <a:xfrm>
+          <a:off x="0" y="0"/>
+          <a:ext cx="0" cy="0"/>
+          <a:chOff x="0" y="0"/>
+          <a:chExt cx="0" cy="0"/>
+        </a:xfrm>
+      </p:grpSpPr>
+      <p:sp>
+        <p:nvSpPr>
+          <p:cNvPr id="2" name="Titolo 1">
+            <a:extLst>
+              <a:ext uri="{FF2B5EF4-FFF2-40B4-BE49-F238E27FC236}">
+                <a16:creationId xmlns:a16="http://schemas.microsoft.com/office/drawing/2014/main" id="{EE1B7A22-6764-7F1D-7CEE-C0FBB6B50C5D}"/>
+              </a:ext>
+            </a:extLst>
+          </p:cNvPr>
+          <p:cNvSpPr>
+            <a:spLocks noGrp="1"/>
+          </p:cNvSpPr>
+          <p:nvPr>
+            <p:ph type="title"/>
+          </p:nvPr>
+        </p:nvSpPr>
+        <p:spPr/>
+        <p:txBody>
+          <a:bodyPr/>
+          <a:lstStyle/>
+          <a:p>
+            <a:pPr algn="ctr"/>
+            <a:r>
+              <a:rPr lang="it-IT" dirty="0"/>
+              <a:t>SEQUENCE DIAGRAM – CHIUDI ASTA</a:t>
+            </a:r>
+          </a:p>
+        </p:txBody>
+      </p:sp>
+      <p:pic>
+        <p:nvPicPr>
+          <p:cNvPr id="5" name="Segnaposto contenuto 4" descr="Immagine che contiene testo, schermata, numero, Carattere&#10;&#10;Il contenuto generato dall'IA potrebbe non essere corretto.">
+            <a:extLst>
+              <a:ext uri="{FF2B5EF4-FFF2-40B4-BE49-F238E27FC236}">
+                <a16:creationId xmlns:a16="http://schemas.microsoft.com/office/drawing/2014/main" id="{54FDBB04-B578-B662-FEB7-9BAEC73A5867}"/>
+              </a:ext>
+            </a:extLst>
+          </p:cNvPr>
+          <p:cNvPicPr>
+            <a:picLocks noGrp="1" noChangeAspect="1"/>
+          </p:cNvPicPr>
+          <p:nvPr>
+            <p:ph idx="1"/>
+          </p:nvPr>
+        </p:nvPicPr>
+        <p:blipFill>
+          <a:blip r:embed="rId2"/>
+          <a:stretch>
+            <a:fillRect/>
+          </a:stretch>
+        </p:blipFill>
+        <p:spPr>
+          <a:xfrm>
+            <a:off x="2327565" y="1567729"/>
+            <a:ext cx="7658100" cy="4825867"/>
+          </a:xfrm>
+        </p:spPr>
+      </p:pic>
+    </p:spTree>
+    <p:extLst>
+      <p:ext uri="{BB962C8B-B14F-4D97-AF65-F5344CB8AC3E}">
+        <p14:creationId xmlns:p14="http://schemas.microsoft.com/office/powerpoint/2010/main" val="900218779"/>
+      </p:ext>
+    </p:extLst>
+  </p:cSld>
+  <p:clrMapOvr>
+    <a:masterClrMapping/>
+  </p:clrMapOvr>
+</p:sld>
+</file>
+
+<file path=ppt/slides/slide43.xml><?xml version="1.0" encoding="utf-8"?>
+<p:sld xmlns:a="http://schemas.openxmlformats.org/drawingml/2006/main" xmlns:r="http://schemas.openxmlformats.org/officeDocument/2006/relationships" xmlns:p="http://schemas.openxmlformats.org/presentationml/2006/main">
+  <p:cSld>
+    <p:spTree>
+      <p:nvGrpSpPr>
+        <p:cNvPr id="1" name="">
+          <a:extLst>
+            <a:ext uri="{FF2B5EF4-FFF2-40B4-BE49-F238E27FC236}">
+              <a16:creationId xmlns:a16="http://schemas.microsoft.com/office/drawing/2014/main" id="{82E3FE80-BE74-AA18-DD56-A6E3F4C2BC6F}"/>
+            </a:ext>
+          </a:extLst>
+        </p:cNvPr>
+        <p:cNvGrpSpPr/>
+        <p:nvPr/>
+      </p:nvGrpSpPr>
+      <p:grpSpPr>
+        <a:xfrm>
+          <a:off x="0" y="0"/>
+          <a:ext cx="0" cy="0"/>
+          <a:chOff x="0" y="0"/>
+          <a:chExt cx="0" cy="0"/>
+        </a:xfrm>
+      </p:grpSpPr>
+      <p:sp>
+        <p:nvSpPr>
+          <p:cNvPr id="2" name="Titolo 1">
+            <a:extLst>
+              <a:ext uri="{FF2B5EF4-FFF2-40B4-BE49-F238E27FC236}">
+                <a16:creationId xmlns:a16="http://schemas.microsoft.com/office/drawing/2014/main" id="{2C030651-BCA1-A728-15E0-106761D029EC}"/>
+              </a:ext>
+            </a:extLst>
+          </p:cNvPr>
+          <p:cNvSpPr>
+            <a:spLocks noGrp="1"/>
+          </p:cNvSpPr>
+          <p:nvPr>
+            <p:ph type="title"/>
+          </p:nvPr>
+        </p:nvSpPr>
+        <p:spPr/>
+        <p:txBody>
+          <a:bodyPr/>
+          <a:lstStyle/>
+          <a:p>
+            <a:pPr algn="ctr"/>
+            <a:r>
+              <a:rPr lang="it-IT" dirty="0"/>
+              <a:t>SEQUENCE DIAGRAM – FAI OFFERTA</a:t>
+            </a:r>
+          </a:p>
+        </p:txBody>
+      </p:sp>
+      <p:pic>
+        <p:nvPicPr>
+          <p:cNvPr id="5" name="Segnaposto contenuto 4" descr="Immagine che contiene testo, schermata, numero, Carattere&#10;&#10;Il contenuto generato dall'IA potrebbe non essere corretto.">
+            <a:extLst>
+              <a:ext uri="{FF2B5EF4-FFF2-40B4-BE49-F238E27FC236}">
+                <a16:creationId xmlns:a16="http://schemas.microsoft.com/office/drawing/2014/main" id="{C1C89FC0-7B07-A877-D1F8-AB86DFFDE56F}"/>
+              </a:ext>
+            </a:extLst>
+          </p:cNvPr>
+          <p:cNvPicPr>
+            <a:picLocks noGrp="1" noChangeAspect="1"/>
+          </p:cNvPicPr>
+          <p:nvPr>
+            <p:ph idx="1"/>
+          </p:nvPr>
+        </p:nvPicPr>
+        <p:blipFill>
+          <a:blip r:embed="rId2"/>
+          <a:stretch>
+            <a:fillRect/>
+          </a:stretch>
+        </p:blipFill>
+        <p:spPr>
+          <a:xfrm>
+            <a:off x="1569027" y="1696697"/>
+            <a:ext cx="9227128" cy="4653963"/>
+          </a:xfrm>
+        </p:spPr>
+      </p:pic>
+    </p:spTree>
+    <p:extLst>
+      <p:ext uri="{BB962C8B-B14F-4D97-AF65-F5344CB8AC3E}">
+        <p14:creationId xmlns:p14="http://schemas.microsoft.com/office/powerpoint/2010/main" val="2474054820"/>
+      </p:ext>
+    </p:extLst>
+  </p:cSld>
+  <p:clrMapOvr>
+    <a:masterClrMapping/>
+  </p:clrMapOvr>
+</p:sld>
+</file>
+
+<file path=ppt/slides/slide44.xml><?xml version="1.0" encoding="utf-8"?>
+<p:sld xmlns:a="http://schemas.openxmlformats.org/drawingml/2006/main" xmlns:r="http://schemas.openxmlformats.org/officeDocument/2006/relationships" xmlns:p="http://schemas.openxmlformats.org/presentationml/2006/main">
+  <p:cSld>
+    <p:spTree>
+      <p:nvGrpSpPr>
+        <p:cNvPr id="1" name="">
+          <a:extLst>
+            <a:ext uri="{FF2B5EF4-FFF2-40B4-BE49-F238E27FC236}">
+              <a16:creationId xmlns:a16="http://schemas.microsoft.com/office/drawing/2014/main" id="{1B0556A0-31C6-C039-DDC3-F94A93D764AC}"/>
+            </a:ext>
+          </a:extLst>
+        </p:cNvPr>
+        <p:cNvGrpSpPr/>
+        <p:nvPr/>
+      </p:nvGrpSpPr>
+      <p:grpSpPr>
+        <a:xfrm>
+          <a:off x="0" y="0"/>
+          <a:ext cx="0" cy="0"/>
+          <a:chOff x="0" y="0"/>
+          <a:chExt cx="0" cy="0"/>
+        </a:xfrm>
+      </p:grpSpPr>
+      <p:sp>
+        <p:nvSpPr>
+          <p:cNvPr id="2" name="Titolo 1">
+            <a:extLst>
+              <a:ext uri="{FF2B5EF4-FFF2-40B4-BE49-F238E27FC236}">
+                <a16:creationId xmlns:a16="http://schemas.microsoft.com/office/drawing/2014/main" id="{21454DE5-8B62-B30F-4486-2DE1F78257E5}"/>
+              </a:ext>
+            </a:extLst>
+          </p:cNvPr>
+          <p:cNvSpPr>
+            <a:spLocks noGrp="1"/>
+          </p:cNvSpPr>
+          <p:nvPr>
+            <p:ph type="title"/>
+          </p:nvPr>
+        </p:nvSpPr>
+        <p:spPr/>
+        <p:txBody>
+          <a:bodyPr/>
+          <a:lstStyle/>
+          <a:p>
+            <a:pPr algn="ctr"/>
+            <a:r>
+              <a:rPr lang="it-IT" dirty="0"/>
+              <a:t>SEQUENCE DIAGRAM – SEARCH ASTE BY KEY</a:t>
+            </a:r>
+          </a:p>
+        </p:txBody>
+      </p:sp>
+      <p:pic>
+        <p:nvPicPr>
+          <p:cNvPr id="5" name="Segnaposto contenuto 4" descr="Immagine che contiene testo, schermata, diagramma, linea&#10;&#10;Il contenuto generato dall'IA potrebbe non essere corretto.">
+            <a:extLst>
+              <a:ext uri="{FF2B5EF4-FFF2-40B4-BE49-F238E27FC236}">
+                <a16:creationId xmlns:a16="http://schemas.microsoft.com/office/drawing/2014/main" id="{42BE1DA9-60DB-C1D6-0009-B605B5717F60}"/>
+              </a:ext>
+            </a:extLst>
+          </p:cNvPr>
+          <p:cNvPicPr>
+            <a:picLocks noGrp="1" noChangeAspect="1"/>
+          </p:cNvPicPr>
+          <p:nvPr>
+            <p:ph idx="1"/>
+          </p:nvPr>
+        </p:nvPicPr>
+        <p:blipFill>
+          <a:blip r:embed="rId2"/>
+          <a:stretch>
+            <a:fillRect/>
+          </a:stretch>
+        </p:blipFill>
+        <p:spPr>
+          <a:xfrm>
+            <a:off x="1350464" y="1808017"/>
+            <a:ext cx="9728041" cy="4416137"/>
+          </a:xfrm>
+        </p:spPr>
+      </p:pic>
+    </p:spTree>
+    <p:extLst>
+      <p:ext uri="{BB962C8B-B14F-4D97-AF65-F5344CB8AC3E}">
+        <p14:creationId xmlns:p14="http://schemas.microsoft.com/office/powerpoint/2010/main" val="1297480831"/>
       </p:ext>
     </p:extLst>
   </p:cSld>

</xml_diff>